<commit_message>
Add executive leadership team slide with six profiles
Replace the single-founder leadership slide with a condensed investor
overview of Rocky Chen, Stephanie Li, Gavin Ding, Robin Zhu, Chris Lin,
and Jon Serbin, with full bios noted as available in the data room.

Co-authored-by: anthonyleedu <anthonyleedu@users.noreply.github.com>
</commit_message>
<xml_diff>
--- a/51Careers_AI_Investor_Presentation.pptx
+++ b/51Careers_AI_Investor_Presentation.pptx
@@ -1583,200 +1583,6 @@
         <a:defRPr sz="1800"/>
       </a:pPr>
       <a:endParaRPr/>
-    </a:p>
-  </c:txPr>
-  <c:externalData r:id="rId1">
-    <c:autoUpdate val="0"/>
-  </c:externalData>
-</c:chartSpace>
-</file>
-
-<file path=ppt/charts/chart8.xml><?xml version="1.0" encoding="utf-8"?>
-<c:chartSpace xmlns:c="http://schemas.openxmlformats.org/drawingml/2006/chart" xmlns:a="http://schemas.openxmlformats.org/drawingml/2006/main" xmlns:r="http://schemas.openxmlformats.org/officeDocument/2006/relationships">
-  <c:date1904 val="0"/>
-  <c:chart>
-    <c:autoTitleDeleted val="0"/>
-    <c:plotArea>
-      <c:barChart>
-        <c:barDir val="bar"/>
-        <c:grouping val="clustered"/>
-        <c:ser>
-          <c:idx val="0"/>
-          <c:order val="0"/>
-          <c:tx>
-            <c:strRef>
-              <c:f>Sheet1!$B$1</c:f>
-              <c:strCache>
-                <c:ptCount val="1"/>
-                <c:pt idx="0">
-                  <c:v>Relative presence</c:v>
-                </c:pt>
-              </c:strCache>
-            </c:strRef>
-          </c:tx>
-          <c:spPr>
-            <a:solidFill>
-              <a:srgbClr val="0A6B63"/>
-            </a:solidFill>
-            <a:ln>
-              <a:solidFill>
-                <a:srgbClr val="0A6B63"/>
-              </a:solidFill>
-            </a:ln>
-          </c:spPr>
-          <c:cat>
-            <c:strRef>
-              <c:f>Sheet1!$A$2:$A$8</c:f>
-              <c:strCache>
-                <c:ptCount val="7"/>
-                <c:pt idx="0">
-                  <c:v>New York</c:v>
-                </c:pt>
-                <c:pt idx="1">
-                  <c:v>Shanghai</c:v>
-                </c:pt>
-                <c:pt idx="2">
-                  <c:v>London</c:v>
-                </c:pt>
-                <c:pt idx="3">
-                  <c:v>Singapore</c:v>
-                </c:pt>
-                <c:pt idx="4">
-                  <c:v>Seoul</c:v>
-                </c:pt>
-                <c:pt idx="5">
-                  <c:v>Toronto</c:v>
-                </c:pt>
-                <c:pt idx="6">
-                  <c:v>Delhi</c:v>
-                </c:pt>
-              </c:strCache>
-            </c:strRef>
-          </c:cat>
-          <c:val>
-            <c:numRef>
-              <c:f>Sheet1!$B$2:$B$8</c:f>
-              <c:numCache>
-                <c:formatCode>General</c:formatCode>
-                <c:ptCount val="7"/>
-                <c:pt idx="0">
-                  <c:v>100</c:v>
-                </c:pt>
-                <c:pt idx="1">
-                  <c:v>95</c:v>
-                </c:pt>
-                <c:pt idx="2">
-                  <c:v>55</c:v>
-                </c:pt>
-                <c:pt idx="3">
-                  <c:v>50</c:v>
-                </c:pt>
-                <c:pt idx="4">
-                  <c:v>45</c:v>
-                </c:pt>
-                <c:pt idx="5">
-                  <c:v>40</c:v>
-                </c:pt>
-                <c:pt idx="6">
-                  <c:v>40</c:v>
-                </c:pt>
-              </c:numCache>
-            </c:numRef>
-          </c:val>
-        </c:ser>
-        <c:axId val="-2068027336"/>
-        <c:axId val="-2113994440"/>
-      </c:barChart>
-      <c:catAx>
-        <c:axId val="-2068027336"/>
-        <c:scaling>
-          <c:orientation val="minMax"/>
-        </c:scaling>
-        <c:delete val="0"/>
-        <c:axPos val="l"/>
-        <c:majorTickMark val="out"/>
-        <c:minorTickMark val="none"/>
-        <c:tickLblPos val="nextTo"/>
-        <c:spPr>
-          <a:ln>
-            <a:solidFill>
-              <a:srgbClr val="D4DEE8"/>
-            </a:solidFill>
-          </a:ln>
-        </c:spPr>
-        <c:txPr>
-          <a:bodyPr/>
-          <a:lstStyle/>
-          <a:p>
-            <a:pPr>
-              <a:defRPr sz="900">
-                <a:solidFill>
-                  <a:srgbClr val="5E6E80"/>
-                </a:solidFill>
-                <a:latin typeface="Segoe UI"/>
-              </a:defRPr>
-            </a:pPr>
-          </a:p>
-        </c:txPr>
-        <c:crossAx val="-2113994440"/>
-        <c:crosses val="autoZero"/>
-        <c:auto val="1"/>
-        <c:lblAlgn val="ctr"/>
-        <c:lblOffset val="100"/>
-        <c:noMultiLvlLbl val="0"/>
-      </c:catAx>
-      <c:valAx>
-        <c:axId val="-2113994440"/>
-        <c:scaling/>
-        <c:delete val="0"/>
-        <c:axPos val="b"/>
-        <c:majorGridlines>
-          <c:spPr>
-            <a:ln>
-              <a:solidFill>
-                <a:srgbClr val="D4DEE8"/>
-              </a:solidFill>
-            </a:ln>
-          </c:spPr>
-        </c:majorGridlines>
-        <c:majorTickMark val="out"/>
-        <c:minorTickMark val="none"/>
-        <c:tickLblPos val="nextTo"/>
-        <c:spPr>
-          <a:ln>
-            <a:solidFill>
-              <a:srgbClr val="D4DEE8"/>
-            </a:solidFill>
-          </a:ln>
-        </c:spPr>
-        <c:txPr>
-          <a:bodyPr/>
-          <a:lstStyle/>
-          <a:p>
-            <a:pPr>
-              <a:defRPr sz="900">
-                <a:solidFill>
-                  <a:srgbClr val="5E6E80"/>
-                </a:solidFill>
-                <a:latin typeface="Segoe UI"/>
-              </a:defRPr>
-            </a:pPr>
-          </a:p>
-        </c:txPr>
-        <c:crossAx val="-2068027336"/>
-        <c:crosses val="autoZero"/>
-      </c:valAx>
-    </c:plotArea>
-    <c:dispBlanksAs val="gap"/>
-  </c:chart>
-  <c:txPr>
-    <a:bodyPr/>
-    <a:lstStyle/>
-    <a:p>
-      <a:pPr>
-        <a:defRPr sz="1800"/>
-      </a:pPr>
-      <a:endParaRPr lang="en-US"/>
     </a:p>
   </c:txPr>
   <c:externalData r:id="rId1">
@@ -10279,7 +10085,7 @@
                 </a:solidFill>
                 <a:latin typeface="Georgia"/>
               </a:rPr>
-              <a:t>Founder-Led, Globally Distributed</a:t>
+              <a:t>Executive Leadership Team</a:t>
             </a:r>
           </a:p>
         </p:txBody>
@@ -10292,8 +10098,8 @@
         </p:nvSpPr>
         <p:spPr>
           <a:xfrm>
-            <a:off x="502920" y="1188720"/>
-            <a:ext cx="6858000" cy="3200400"/>
+            <a:off x="502920" y="1170432"/>
+            <a:ext cx="3657600" cy="2148840"/>
           </a:xfrm>
           <a:prstGeom prst="roundRect">
             <a:avLst>
@@ -10339,8 +10145,8 @@
         </p:nvSpPr>
         <p:spPr>
           <a:xfrm>
-            <a:off x="502920" y="1188720"/>
-            <a:ext cx="91440" cy="3200400"/>
+            <a:off x="502920" y="1170432"/>
+            <a:ext cx="73152" cy="2148840"/>
           </a:xfrm>
           <a:prstGeom prst="rect">
             <a:avLst/>
@@ -10382,21 +10188,21 @@
         </p:nvSpPr>
         <p:spPr>
           <a:xfrm>
-            <a:off x="822960" y="1371600"/>
-            <a:ext cx="6309360" cy="411480"/>
-          </a:xfrm>
-          <a:prstGeom prst="rect">
-            <a:avLst/>
-          </a:prstGeom>
-          <a:noFill/>
-        </p:spPr>
-        <p:txBody>
-          <a:bodyPr wrap="square" anchor="t"/>
-          <a:lstStyle/>
-          <a:p>
-            <a:pPr algn="l"/>
-            <a:r>
-              <a:rPr sz="2600" b="1" i="0">
+            <a:off x="704088" y="1298448"/>
+            <a:ext cx="3337560" cy="320040"/>
+          </a:xfrm>
+          <a:prstGeom prst="rect">
+            <a:avLst/>
+          </a:prstGeom>
+          <a:noFill/>
+        </p:spPr>
+        <p:txBody>
+          <a:bodyPr wrap="square" anchor="t"/>
+          <a:lstStyle/>
+          <a:p>
+            <a:pPr algn="l"/>
+            <a:r>
+              <a:rPr sz="1500" b="1" i="0">
                 <a:solidFill>
                   <a:srgbClr val="0B1F33"/>
                 </a:solidFill>
@@ -10415,27 +10221,27 @@
         </p:nvSpPr>
         <p:spPr>
           <a:xfrm>
-            <a:off x="822960" y="1874519"/>
-            <a:ext cx="6309360" cy="274320"/>
-          </a:xfrm>
-          <a:prstGeom prst="rect">
-            <a:avLst/>
-          </a:prstGeom>
-          <a:noFill/>
-        </p:spPr>
-        <p:txBody>
-          <a:bodyPr wrap="square" anchor="t"/>
-          <a:lstStyle/>
-          <a:p>
-            <a:pPr algn="l"/>
-            <a:r>
-              <a:rPr sz="1100" b="1" i="0">
+            <a:off x="704088" y="1609344"/>
+            <a:ext cx="3337560" cy="256032"/>
+          </a:xfrm>
+          <a:prstGeom prst="rect">
+            <a:avLst/>
+          </a:prstGeom>
+          <a:noFill/>
+        </p:spPr>
+        <p:txBody>
+          <a:bodyPr wrap="square" anchor="t"/>
+          <a:lstStyle/>
+          <a:p>
+            <a:pPr algn="l"/>
+            <a:r>
+              <a:rPr sz="1000" b="1" i="0">
                 <a:solidFill>
                   <a:srgbClr val="0A6B63"/>
                 </a:solidFill>
                 <a:latin typeface="Segoe UI"/>
               </a:rPr>
-              <a:t>FOUNDER &amp; CHIEF EXECUTIVE OFFICER</a:t>
+              <a:t>FOUNDER</a:t>
             </a:r>
           </a:p>
         </p:txBody>
@@ -10448,27 +10254,27 @@
         </p:nvSpPr>
         <p:spPr>
           <a:xfrm>
-            <a:off x="822960" y="2286000"/>
-            <a:ext cx="6309360" cy="1371600"/>
-          </a:xfrm>
-          <a:prstGeom prst="rect">
-            <a:avLst/>
-          </a:prstGeom>
-          <a:noFill/>
-        </p:spPr>
-        <p:txBody>
-          <a:bodyPr wrap="square" anchor="t"/>
-          <a:lstStyle/>
-          <a:p>
-            <a:pPr algn="l"/>
-            <a:r>
-              <a:rPr sz="1200" b="0" i="0">
+            <a:off x="704088" y="1947672"/>
+            <a:ext cx="3310128" cy="594360"/>
+          </a:xfrm>
+          <a:prstGeom prst="rect">
+            <a:avLst/>
+          </a:prstGeom>
+          <a:noFill/>
+        </p:spPr>
+        <p:txBody>
+          <a:bodyPr wrap="square" anchor="t"/>
+          <a:lstStyle/>
+          <a:p>
+            <a:pPr algn="l"/>
+            <a:r>
+              <a:rPr sz="1000" b="0" i="0">
                 <a:solidFill>
                   <a:srgbClr val="2C3A4B"/>
                 </a:solidFill>
                 <a:latin typeface="Segoe UI"/>
               </a:rPr>
-              <a:t>Founded 51 Careers in New York in 2016 and built it from a boutique consultancy into a multi-market career-services and technology business. Architect of the Company’s AI-first strategy, including the 2025 strategic partnership with Alibaba Cloud AI, and of its expansion across North America, Europe, and Asia.</a:t>
+              <a:t>▸  Founder of 51 Careers and 51Careers.AI; investor &amp; Managing Director at publicly listed Helio</a:t>
             </a:r>
           </a:p>
         </p:txBody>
@@ -10481,27 +10287,27 @@
         </p:nvSpPr>
         <p:spPr>
           <a:xfrm>
-            <a:off x="822960" y="3749039"/>
-            <a:ext cx="6309360" cy="457200"/>
-          </a:xfrm>
-          <a:prstGeom prst="rect">
-            <a:avLst/>
-          </a:prstGeom>
-          <a:noFill/>
-        </p:spPr>
-        <p:txBody>
-          <a:bodyPr wrap="square" anchor="t"/>
-          <a:lstStyle/>
-          <a:p>
-            <a:pPr algn="l"/>
-            <a:r>
-              <a:rPr sz="1100" b="0" i="0">
-                <a:solidFill>
-                  <a:srgbClr val="5E6E80"/>
-                </a:solidFill>
-                <a:latin typeface="Segoe UI"/>
-              </a:rPr>
-              <a:t>Supporting bench — Senior partners across business development, coaching operations, and engineering, supported by a mentor network of practitioners at leading global employers.</a:t>
+            <a:off x="704088" y="2569464"/>
+            <a:ext cx="3310128" cy="594360"/>
+          </a:xfrm>
+          <a:prstGeom prst="rect">
+            <a:avLst/>
+          </a:prstGeom>
+          <a:noFill/>
+        </p:spPr>
+        <p:txBody>
+          <a:bodyPr wrap="square" anchor="t"/>
+          <a:lstStyle/>
+          <a:p>
+            <a:pPr algn="l"/>
+            <a:r>
+              <a:rPr sz="1000" b="0" i="0">
+                <a:solidFill>
+                  <a:srgbClr val="2C3A4B"/>
+                </a:solidFill>
+                <a:latin typeface="Segoe UI"/>
+              </a:rPr>
+              <a:t>▸  Decade of international business, capital markets, and global resource integration across AI, education, and related industries</a:t>
             </a:r>
           </a:p>
         </p:txBody>
@@ -10514,284 +10320,8 @@
         </p:nvSpPr>
         <p:spPr>
           <a:xfrm>
-            <a:off x="7589520" y="1188720"/>
-            <a:ext cx="4114800" cy="3200400"/>
-          </a:xfrm>
-          <a:prstGeom prst="roundRect">
-            <a:avLst>
-              <a:gd name="adj" fmla="val 8000"/>
-            </a:avLst>
-          </a:prstGeom>
-          <a:solidFill>
-            <a:srgbClr val="0B1F33"/>
-          </a:solidFill>
-          <a:ln>
-            <a:noFill/>
-          </a:ln>
-        </p:spPr>
-        <p:style>
-          <a:lnRef idx="1">
-            <a:schemeClr val="accent1"/>
-          </a:lnRef>
-          <a:fillRef idx="3">
-            <a:schemeClr val="accent1"/>
-          </a:fillRef>
-          <a:effectRef idx="2">
-            <a:schemeClr val="accent1"/>
-          </a:effectRef>
-          <a:fontRef idx="minor">
-            <a:schemeClr val="lt1"/>
-          </a:fontRef>
-        </p:style>
-        <p:txBody>
-          <a:bodyPr rtlCol="0" anchor="ctr"/>
-          <a:lstStyle/>
-          <a:p>
-            <a:pPr algn="ctr"/>
-          </a:p>
-        </p:txBody>
-      </p:sp>
-      <p:sp>
-        <p:nvSpPr>
-          <p:cNvPr id="12" name="TextBox 11"/>
-          <p:cNvSpPr txBox="1"/>
-          <p:nvPr/>
-        </p:nvSpPr>
-        <p:spPr>
-          <a:xfrm>
-            <a:off x="7818120" y="1371600"/>
-            <a:ext cx="3657600" cy="274320"/>
-          </a:xfrm>
-          <a:prstGeom prst="rect">
-            <a:avLst/>
-          </a:prstGeom>
-          <a:noFill/>
-        </p:spPr>
-        <p:txBody>
-          <a:bodyPr wrap="square" anchor="t"/>
-          <a:lstStyle/>
-          <a:p>
-            <a:pPr algn="l"/>
-            <a:r>
-              <a:rPr sz="1100" b="1" i="0">
-                <a:solidFill>
-                  <a:srgbClr val="0A6B63"/>
-                </a:solidFill>
-                <a:latin typeface="Segoe UI"/>
-              </a:rPr>
-              <a:t>GLOBAL ORGANIZATION</a:t>
-            </a:r>
-          </a:p>
-        </p:txBody>
-      </p:sp>
-      <p:sp>
-        <p:nvSpPr>
-          <p:cNvPr id="13" name="TextBox 12"/>
-          <p:cNvSpPr txBox="1"/>
-          <p:nvPr/>
-        </p:nvSpPr>
-        <p:spPr>
-          <a:xfrm>
-            <a:off x="7818120" y="1783080"/>
-            <a:ext cx="3657600" cy="411480"/>
-          </a:xfrm>
-          <a:prstGeom prst="rect">
-            <a:avLst/>
-          </a:prstGeom>
-          <a:noFill/>
-        </p:spPr>
-        <p:txBody>
-          <a:bodyPr wrap="square" anchor="t"/>
-          <a:lstStyle/>
-          <a:p>
-            <a:pPr algn="l"/>
-            <a:r>
-              <a:rPr sz="2000" b="1" i="0">
-                <a:solidFill>
-                  <a:srgbClr val="FFFFFF"/>
-                </a:solidFill>
-                <a:latin typeface="Georgia"/>
-              </a:rPr>
-              <a:t>≈50 professionals</a:t>
-            </a:r>
-          </a:p>
-        </p:txBody>
-      </p:sp>
-      <p:sp>
-        <p:nvSpPr>
-          <p:cNvPr id="14" name="TextBox 13"/>
-          <p:cNvSpPr txBox="1"/>
-          <p:nvPr/>
-        </p:nvSpPr>
-        <p:spPr>
-          <a:xfrm>
-            <a:off x="7818120" y="2240280"/>
-            <a:ext cx="3657600" cy="274320"/>
-          </a:xfrm>
-          <a:prstGeom prst="rect">
-            <a:avLst/>
-          </a:prstGeom>
-          <a:noFill/>
-        </p:spPr>
-        <p:txBody>
-          <a:bodyPr wrap="square" anchor="t"/>
-          <a:lstStyle/>
-          <a:p>
-            <a:pPr algn="l"/>
-            <a:r>
-              <a:rPr sz="1100" b="0" i="0">
-                <a:solidFill>
-                  <a:srgbClr val="C5D5E0"/>
-                </a:solidFill>
-                <a:latin typeface="Segoe UI"/>
-              </a:rPr>
-              <a:t>Distributed across four continents†</a:t>
-            </a:r>
-          </a:p>
-        </p:txBody>
-      </p:sp>
-      <p:sp>
-        <p:nvSpPr>
-          <p:cNvPr id="15" name="TextBox 14"/>
-          <p:cNvSpPr txBox="1"/>
-          <p:nvPr/>
-        </p:nvSpPr>
-        <p:spPr>
-          <a:xfrm>
-            <a:off x="7818120" y="2743200"/>
-            <a:ext cx="3657600" cy="274320"/>
-          </a:xfrm>
-          <a:prstGeom prst="rect">
-            <a:avLst/>
-          </a:prstGeom>
-          <a:noFill/>
-        </p:spPr>
-        <p:txBody>
-          <a:bodyPr wrap="square" anchor="t"/>
-          <a:lstStyle/>
-          <a:p>
-            <a:pPr algn="l"/>
-            <a:r>
-              <a:rPr sz="1200" b="1" i="0">
-                <a:solidFill>
-                  <a:srgbClr val="0A6B63"/>
-                </a:solidFill>
-                <a:latin typeface="Segoe UI"/>
-              </a:rPr>
-              <a:t>Hubs</a:t>
-            </a:r>
-          </a:p>
-        </p:txBody>
-      </p:sp>
-      <p:sp>
-        <p:nvSpPr>
-          <p:cNvPr id="16" name="TextBox 15"/>
-          <p:cNvSpPr txBox="1"/>
-          <p:nvPr/>
-        </p:nvSpPr>
-        <p:spPr>
-          <a:xfrm>
-            <a:off x="7818120" y="3017520"/>
-            <a:ext cx="3657600" cy="502920"/>
-          </a:xfrm>
-          <a:prstGeom prst="rect">
-            <a:avLst/>
-          </a:prstGeom>
-          <a:noFill/>
-        </p:spPr>
-        <p:txBody>
-          <a:bodyPr wrap="square" anchor="t"/>
-          <a:lstStyle/>
-          <a:p>
-            <a:pPr algn="l"/>
-            <a:r>
-              <a:rPr sz="1100" b="0" i="0">
-                <a:solidFill>
-                  <a:srgbClr val="FFFFFF"/>
-                </a:solidFill>
-                <a:latin typeface="Segoe UI"/>
-              </a:rPr>
-              <a:t>New York &amp; Shanghai; presence in London, Singapore, Seoul, Toronto, and Delhi</a:t>
-            </a:r>
-          </a:p>
-        </p:txBody>
-      </p:sp>
-      <p:sp>
-        <p:nvSpPr>
-          <p:cNvPr id="17" name="TextBox 16"/>
-          <p:cNvSpPr txBox="1"/>
-          <p:nvPr/>
-        </p:nvSpPr>
-        <p:spPr>
-          <a:xfrm>
-            <a:off x="7818120" y="3657600"/>
-            <a:ext cx="3657600" cy="274320"/>
-          </a:xfrm>
-          <a:prstGeom prst="rect">
-            <a:avLst/>
-          </a:prstGeom>
-          <a:noFill/>
-        </p:spPr>
-        <p:txBody>
-          <a:bodyPr wrap="square" anchor="t"/>
-          <a:lstStyle/>
-          <a:p>
-            <a:pPr algn="l"/>
-            <a:r>
-              <a:rPr sz="1200" b="1" i="0">
-                <a:solidFill>
-                  <a:srgbClr val="0A6B63"/>
-                </a:solidFill>
-                <a:latin typeface="Segoe UI"/>
-              </a:rPr>
-              <a:t>Functions</a:t>
-            </a:r>
-          </a:p>
-        </p:txBody>
-      </p:sp>
-      <p:sp>
-        <p:nvSpPr>
-          <p:cNvPr id="18" name="TextBox 17"/>
-          <p:cNvSpPr txBox="1"/>
-          <p:nvPr/>
-        </p:nvSpPr>
-        <p:spPr>
-          <a:xfrm>
-            <a:off x="7818120" y="3931920"/>
-            <a:ext cx="3657600" cy="365760"/>
-          </a:xfrm>
-          <a:prstGeom prst="rect">
-            <a:avLst/>
-          </a:prstGeom>
-          <a:noFill/>
-        </p:spPr>
-        <p:txBody>
-          <a:bodyPr wrap="square" anchor="t"/>
-          <a:lstStyle/>
-          <a:p>
-            <a:pPr algn="l"/>
-            <a:r>
-              <a:rPr sz="1100" b="0" i="0">
-                <a:solidFill>
-                  <a:srgbClr val="FFFFFF"/>
-                </a:solidFill>
-                <a:latin typeface="Segoe UI"/>
-              </a:rPr>
-              <a:t>AI &amp; engineering · coaching &amp; mentor network · placement · employer partnerships</a:t>
-            </a:r>
-          </a:p>
-        </p:txBody>
-      </p:sp>
-      <p:sp>
-        <p:nvSpPr>
-          <p:cNvPr id="19" name="Rounded Rectangle 18"/>
-          <p:cNvSpPr/>
-          <p:nvPr/>
-        </p:nvSpPr>
-        <p:spPr>
-          <a:xfrm>
-            <a:off x="502920" y="4572000"/>
-            <a:ext cx="11201400" cy="1234440"/>
+            <a:off x="4343400" y="1170432"/>
+            <a:ext cx="3657600" cy="2148840"/>
           </a:xfrm>
           <a:prstGeom prst="roundRect">
             <a:avLst>
@@ -10831,91 +10361,1103 @@
       </p:sp>
       <p:sp>
         <p:nvSpPr>
+          <p:cNvPr id="12" name="Rectangle 11"/>
+          <p:cNvSpPr/>
+          <p:nvPr/>
+        </p:nvSpPr>
+        <p:spPr>
+          <a:xfrm>
+            <a:off x="4343400" y="1170432"/>
+            <a:ext cx="73152" cy="2148840"/>
+          </a:xfrm>
+          <a:prstGeom prst="rect">
+            <a:avLst/>
+          </a:prstGeom>
+          <a:solidFill>
+            <a:srgbClr val="2F5D8A"/>
+          </a:solidFill>
+          <a:ln>
+            <a:noFill/>
+          </a:ln>
+        </p:spPr>
+        <p:style>
+          <a:lnRef idx="1">
+            <a:schemeClr val="accent1"/>
+          </a:lnRef>
+          <a:fillRef idx="3">
+            <a:schemeClr val="accent1"/>
+          </a:fillRef>
+          <a:effectRef idx="2">
+            <a:schemeClr val="accent1"/>
+          </a:effectRef>
+          <a:fontRef idx="minor">
+            <a:schemeClr val="lt1"/>
+          </a:fontRef>
+        </p:style>
+        <p:txBody>
+          <a:bodyPr rtlCol="0" anchor="ctr"/>
+          <a:lstStyle/>
+          <a:p>
+            <a:pPr algn="ctr"/>
+          </a:p>
+        </p:txBody>
+      </p:sp>
+      <p:sp>
+        <p:nvSpPr>
+          <p:cNvPr id="13" name="TextBox 12"/>
+          <p:cNvSpPr txBox="1"/>
+          <p:nvPr/>
+        </p:nvSpPr>
+        <p:spPr>
+          <a:xfrm>
+            <a:off x="4544568" y="1298448"/>
+            <a:ext cx="3337560" cy="320040"/>
+          </a:xfrm>
+          <a:prstGeom prst="rect">
+            <a:avLst/>
+          </a:prstGeom>
+          <a:noFill/>
+        </p:spPr>
+        <p:txBody>
+          <a:bodyPr wrap="square" anchor="t"/>
+          <a:lstStyle/>
+          <a:p>
+            <a:pPr algn="l"/>
+            <a:r>
+              <a:rPr sz="1500" b="1" i="0">
+                <a:solidFill>
+                  <a:srgbClr val="0B1F33"/>
+                </a:solidFill>
+                <a:latin typeface="Georgia"/>
+              </a:rPr>
+              <a:t>Stephanie Li</a:t>
+            </a:r>
+          </a:p>
+        </p:txBody>
+      </p:sp>
+      <p:sp>
+        <p:nvSpPr>
+          <p:cNvPr id="14" name="TextBox 13"/>
+          <p:cNvSpPr txBox="1"/>
+          <p:nvPr/>
+        </p:nvSpPr>
+        <p:spPr>
+          <a:xfrm>
+            <a:off x="4544568" y="1609344"/>
+            <a:ext cx="3337560" cy="256032"/>
+          </a:xfrm>
+          <a:prstGeom prst="rect">
+            <a:avLst/>
+          </a:prstGeom>
+          <a:noFill/>
+        </p:spPr>
+        <p:txBody>
+          <a:bodyPr wrap="square" anchor="t"/>
+          <a:lstStyle/>
+          <a:p>
+            <a:pPr algn="l"/>
+            <a:r>
+              <a:rPr sz="1000" b="1" i="0">
+                <a:solidFill>
+                  <a:srgbClr val="0A6B63"/>
+                </a:solidFill>
+                <a:latin typeface="Segoe UI"/>
+              </a:rPr>
+              <a:t>CO-FOUNDER &amp; CFO</a:t>
+            </a:r>
+          </a:p>
+        </p:txBody>
+      </p:sp>
+      <p:sp>
+        <p:nvSpPr>
+          <p:cNvPr id="15" name="TextBox 14"/>
+          <p:cNvSpPr txBox="1"/>
+          <p:nvPr/>
+        </p:nvSpPr>
+        <p:spPr>
+          <a:xfrm>
+            <a:off x="4544568" y="1947672"/>
+            <a:ext cx="3310128" cy="594360"/>
+          </a:xfrm>
+          <a:prstGeom prst="rect">
+            <a:avLst/>
+          </a:prstGeom>
+          <a:noFill/>
+        </p:spPr>
+        <p:txBody>
+          <a:bodyPr wrap="square" anchor="t"/>
+          <a:lstStyle/>
+          <a:p>
+            <a:pPr algn="l"/>
+            <a:r>
+              <a:rPr sz="1000" b="0" i="0">
+                <a:solidFill>
+                  <a:srgbClr val="2C3A4B"/>
+                </a:solidFill>
+                <a:latin typeface="Segoe UI"/>
+              </a:rPr>
+              <a:t>▸  Co-Founder since 2016; U.S. CPA — M.S. Accounting (Pace); B.A. Accounting (Dongbei University of Finance and Economics)</a:t>
+            </a:r>
+          </a:p>
+        </p:txBody>
+      </p:sp>
+      <p:sp>
+        <p:nvSpPr>
+          <p:cNvPr id="16" name="TextBox 15"/>
+          <p:cNvSpPr txBox="1"/>
+          <p:nvPr/>
+        </p:nvSpPr>
+        <p:spPr>
+          <a:xfrm>
+            <a:off x="4544568" y="2569464"/>
+            <a:ext cx="3310128" cy="594360"/>
+          </a:xfrm>
+          <a:prstGeom prst="rect">
+            <a:avLst/>
+          </a:prstGeom>
+          <a:noFill/>
+        </p:spPr>
+        <p:txBody>
+          <a:bodyPr wrap="square" anchor="t"/>
+          <a:lstStyle/>
+          <a:p>
+            <a:pPr algn="l"/>
+            <a:r>
+              <a:rPr sz="1000" b="0" i="0">
+                <a:solidFill>
+                  <a:srgbClr val="2C3A4B"/>
+                </a:solidFill>
+                <a:latin typeface="Segoe UI"/>
+              </a:rPr>
+              <a:t>▸  Oversees financial strategy, corporate governance, and sustainable growth; prior senior finance leadership in U.S. industry</a:t>
+            </a:r>
+          </a:p>
+        </p:txBody>
+      </p:sp>
+      <p:sp>
+        <p:nvSpPr>
+          <p:cNvPr id="17" name="Rounded Rectangle 16"/>
+          <p:cNvSpPr/>
+          <p:nvPr/>
+        </p:nvSpPr>
+        <p:spPr>
+          <a:xfrm>
+            <a:off x="8183880" y="1170432"/>
+            <a:ext cx="3657600" cy="2148840"/>
+          </a:xfrm>
+          <a:prstGeom prst="roundRect">
+            <a:avLst>
+              <a:gd name="adj" fmla="val 8000"/>
+            </a:avLst>
+          </a:prstGeom>
+          <a:solidFill>
+            <a:srgbClr val="FFFFFF"/>
+          </a:solidFill>
+          <a:ln w="12700">
+            <a:solidFill>
+              <a:srgbClr val="D4DEE8"/>
+            </a:solidFill>
+          </a:ln>
+        </p:spPr>
+        <p:style>
+          <a:lnRef idx="1">
+            <a:schemeClr val="accent1"/>
+          </a:lnRef>
+          <a:fillRef idx="3">
+            <a:schemeClr val="accent1"/>
+          </a:fillRef>
+          <a:effectRef idx="2">
+            <a:schemeClr val="accent1"/>
+          </a:effectRef>
+          <a:fontRef idx="minor">
+            <a:schemeClr val="lt1"/>
+          </a:fontRef>
+        </p:style>
+        <p:txBody>
+          <a:bodyPr rtlCol="0" anchor="ctr"/>
+          <a:lstStyle/>
+          <a:p>
+            <a:pPr algn="ctr"/>
+          </a:p>
+        </p:txBody>
+      </p:sp>
+      <p:sp>
+        <p:nvSpPr>
+          <p:cNvPr id="18" name="Rectangle 17"/>
+          <p:cNvSpPr/>
+          <p:nvPr/>
+        </p:nvSpPr>
+        <p:spPr>
+          <a:xfrm>
+            <a:off x="8183880" y="1170432"/>
+            <a:ext cx="73152" cy="2148840"/>
+          </a:xfrm>
+          <a:prstGeom prst="rect">
+            <a:avLst/>
+          </a:prstGeom>
+          <a:solidFill>
+            <a:srgbClr val="8A6D3B"/>
+          </a:solidFill>
+          <a:ln>
+            <a:noFill/>
+          </a:ln>
+        </p:spPr>
+        <p:style>
+          <a:lnRef idx="1">
+            <a:schemeClr val="accent1"/>
+          </a:lnRef>
+          <a:fillRef idx="3">
+            <a:schemeClr val="accent1"/>
+          </a:fillRef>
+          <a:effectRef idx="2">
+            <a:schemeClr val="accent1"/>
+          </a:effectRef>
+          <a:fontRef idx="minor">
+            <a:schemeClr val="lt1"/>
+          </a:fontRef>
+        </p:style>
+        <p:txBody>
+          <a:bodyPr rtlCol="0" anchor="ctr"/>
+          <a:lstStyle/>
+          <a:p>
+            <a:pPr algn="ctr"/>
+          </a:p>
+        </p:txBody>
+      </p:sp>
+      <p:sp>
+        <p:nvSpPr>
+          <p:cNvPr id="19" name="TextBox 18"/>
+          <p:cNvSpPr txBox="1"/>
+          <p:nvPr/>
+        </p:nvSpPr>
+        <p:spPr>
+          <a:xfrm>
+            <a:off x="8385048" y="1298448"/>
+            <a:ext cx="3337560" cy="320040"/>
+          </a:xfrm>
+          <a:prstGeom prst="rect">
+            <a:avLst/>
+          </a:prstGeom>
+          <a:noFill/>
+        </p:spPr>
+        <p:txBody>
+          <a:bodyPr wrap="square" anchor="t"/>
+          <a:lstStyle/>
+          <a:p>
+            <a:pPr algn="l"/>
+            <a:r>
+              <a:rPr sz="1500" b="1" i="0">
+                <a:solidFill>
+                  <a:srgbClr val="0B1F33"/>
+                </a:solidFill>
+                <a:latin typeface="Georgia"/>
+              </a:rPr>
+              <a:t>Gavin Ding</a:t>
+            </a:r>
+          </a:p>
+        </p:txBody>
+      </p:sp>
+      <p:sp>
+        <p:nvSpPr>
           <p:cNvPr id="20" name="TextBox 19"/>
           <p:cNvSpPr txBox="1"/>
           <p:nvPr/>
         </p:nvSpPr>
         <p:spPr>
           <a:xfrm>
-            <a:off x="685800" y="4663440"/>
-            <a:ext cx="3657600" cy="256032"/>
-          </a:xfrm>
-          <a:prstGeom prst="rect">
-            <a:avLst/>
-          </a:prstGeom>
-          <a:noFill/>
-        </p:spPr>
-        <p:txBody>
-          <a:bodyPr wrap="square" anchor="t"/>
-          <a:lstStyle/>
-          <a:p>
-            <a:pPr algn="l"/>
-            <a:r>
-              <a:rPr sz="1100" b="1" i="0">
+            <a:off x="8385048" y="1609344"/>
+            <a:ext cx="3337560" cy="256032"/>
+          </a:xfrm>
+          <a:prstGeom prst="rect">
+            <a:avLst/>
+          </a:prstGeom>
+          <a:noFill/>
+        </p:spPr>
+        <p:txBody>
+          <a:bodyPr wrap="square" anchor="t"/>
+          <a:lstStyle/>
+          <a:p>
+            <a:pPr algn="l"/>
+            <a:r>
+              <a:rPr sz="1000" b="1" i="0">
+                <a:solidFill>
+                  <a:srgbClr val="0A6B63"/>
+                </a:solidFill>
+                <a:latin typeface="Segoe UI"/>
+              </a:rPr>
+              <a:t>CO-FOUNDER, CTO &amp; COO</a:t>
+            </a:r>
+          </a:p>
+        </p:txBody>
+      </p:sp>
+      <p:sp>
+        <p:nvSpPr>
+          <p:cNvPr id="21" name="TextBox 20"/>
+          <p:cNvSpPr txBox="1"/>
+          <p:nvPr/>
+        </p:nvSpPr>
+        <p:spPr>
+          <a:xfrm>
+            <a:off x="8385048" y="1947672"/>
+            <a:ext cx="3310128" cy="594360"/>
+          </a:xfrm>
+          <a:prstGeom prst="rect">
+            <a:avLst/>
+          </a:prstGeom>
+          <a:noFill/>
+        </p:spPr>
+        <p:txBody>
+          <a:bodyPr wrap="square" anchor="t"/>
+          <a:lstStyle/>
+          <a:p>
+            <a:pPr algn="l"/>
+            <a:r>
+              <a:rPr sz="1000" b="0" i="0">
+                <a:solidFill>
+                  <a:srgbClr val="2C3A4B"/>
+                </a:solidFill>
+                <a:latin typeface="Segoe UI"/>
+              </a:rPr>
+              <a:t>▸  Serial entrepreneur (10+ yrs) across SaaS, AI, and digital business; B.S. Computer Science, ECUST</a:t>
+            </a:r>
+          </a:p>
+        </p:txBody>
+      </p:sp>
+      <p:sp>
+        <p:nvSpPr>
+          <p:cNvPr id="22" name="TextBox 21"/>
+          <p:cNvSpPr txBox="1"/>
+          <p:nvPr/>
+        </p:nvSpPr>
+        <p:spPr>
+          <a:xfrm>
+            <a:off x="8385048" y="2569464"/>
+            <a:ext cx="3310128" cy="594360"/>
+          </a:xfrm>
+          <a:prstGeom prst="rect">
+            <a:avLst/>
+          </a:prstGeom>
+          <a:noFill/>
+        </p:spPr>
+        <p:txBody>
+          <a:bodyPr wrap="square" anchor="t"/>
+          <a:lstStyle/>
+          <a:p>
+            <a:pPr algn="l"/>
+            <a:r>
+              <a:rPr sz="1000" b="0" i="0">
+                <a:solidFill>
+                  <a:srgbClr val="2C3A4B"/>
+                </a:solidFill>
+                <a:latin typeface="Segoe UI"/>
+              </a:rPr>
+              <a:t>▸  Prior CTO roles (Youpindao, Roubeibei) and multiple co-founded ventures; leads technology, operations, and AI strategy</a:t>
+            </a:r>
+          </a:p>
+        </p:txBody>
+      </p:sp>
+      <p:sp>
+        <p:nvSpPr>
+          <p:cNvPr id="23" name="Rounded Rectangle 22"/>
+          <p:cNvSpPr/>
+          <p:nvPr/>
+        </p:nvSpPr>
+        <p:spPr>
+          <a:xfrm>
+            <a:off x="502920" y="3483864"/>
+            <a:ext cx="3657600" cy="2148840"/>
+          </a:xfrm>
+          <a:prstGeom prst="roundRect">
+            <a:avLst>
+              <a:gd name="adj" fmla="val 8000"/>
+            </a:avLst>
+          </a:prstGeom>
+          <a:solidFill>
+            <a:srgbClr val="FFFFFF"/>
+          </a:solidFill>
+          <a:ln w="12700">
+            <a:solidFill>
+              <a:srgbClr val="D4DEE8"/>
+            </a:solidFill>
+          </a:ln>
+        </p:spPr>
+        <p:style>
+          <a:lnRef idx="1">
+            <a:schemeClr val="accent1"/>
+          </a:lnRef>
+          <a:fillRef idx="3">
+            <a:schemeClr val="accent1"/>
+          </a:fillRef>
+          <a:effectRef idx="2">
+            <a:schemeClr val="accent1"/>
+          </a:effectRef>
+          <a:fontRef idx="minor">
+            <a:schemeClr val="lt1"/>
+          </a:fontRef>
+        </p:style>
+        <p:txBody>
+          <a:bodyPr rtlCol="0" anchor="ctr"/>
+          <a:lstStyle/>
+          <a:p>
+            <a:pPr algn="ctr"/>
+          </a:p>
+        </p:txBody>
+      </p:sp>
+      <p:sp>
+        <p:nvSpPr>
+          <p:cNvPr id="24" name="Rectangle 23"/>
+          <p:cNvSpPr/>
+          <p:nvPr/>
+        </p:nvSpPr>
+        <p:spPr>
+          <a:xfrm>
+            <a:off x="502920" y="3483864"/>
+            <a:ext cx="73152" cy="2148840"/>
+          </a:xfrm>
+          <a:prstGeom prst="rect">
+            <a:avLst/>
+          </a:prstGeom>
+          <a:solidFill>
+            <a:srgbClr val="0A6B63"/>
+          </a:solidFill>
+          <a:ln>
+            <a:noFill/>
+          </a:ln>
+        </p:spPr>
+        <p:style>
+          <a:lnRef idx="1">
+            <a:schemeClr val="accent1"/>
+          </a:lnRef>
+          <a:fillRef idx="3">
+            <a:schemeClr val="accent1"/>
+          </a:fillRef>
+          <a:effectRef idx="2">
+            <a:schemeClr val="accent1"/>
+          </a:effectRef>
+          <a:fontRef idx="minor">
+            <a:schemeClr val="lt1"/>
+          </a:fontRef>
+        </p:style>
+        <p:txBody>
+          <a:bodyPr rtlCol="0" anchor="ctr"/>
+          <a:lstStyle/>
+          <a:p>
+            <a:pPr algn="ctr"/>
+          </a:p>
+        </p:txBody>
+      </p:sp>
+      <p:sp>
+        <p:nvSpPr>
+          <p:cNvPr id="25" name="TextBox 24"/>
+          <p:cNvSpPr txBox="1"/>
+          <p:nvPr/>
+        </p:nvSpPr>
+        <p:spPr>
+          <a:xfrm>
+            <a:off x="704088" y="3611880"/>
+            <a:ext cx="3337560" cy="320040"/>
+          </a:xfrm>
+          <a:prstGeom prst="rect">
+            <a:avLst/>
+          </a:prstGeom>
+          <a:noFill/>
+        </p:spPr>
+        <p:txBody>
+          <a:bodyPr wrap="square" anchor="t"/>
+          <a:lstStyle/>
+          <a:p>
+            <a:pPr algn="l"/>
+            <a:r>
+              <a:rPr sz="1500" b="1" i="0">
                 <a:solidFill>
                   <a:srgbClr val="0B1F33"/>
                 </a:solidFill>
-                <a:latin typeface="Segoe UI"/>
-              </a:rPr>
-              <a:t>Illustrative hub presence</a:t>
-            </a:r>
-          </a:p>
-        </p:txBody>
-      </p:sp>
-      <p:graphicFrame>
-        <p:nvGraphicFramePr>
-          <p:cNvPr id="21" name="Chart 20"/>
-          <p:cNvGraphicFramePr>
-            <a:graphicFrameLocks noGrp="1"/>
-          </p:cNvGraphicFramePr>
-          <p:nvPr/>
-        </p:nvGraphicFramePr>
-        <p:xfrm>
-          <a:off x="4114800" y="4572000"/>
-          <a:ext cx="7406640" cy="1188720"/>
-        </p:xfrm>
-        <a:graphic>
-          <a:graphicData uri="http://schemas.openxmlformats.org/drawingml/2006/chart">
-            <c:chart xmlns:c="http://schemas.openxmlformats.org/drawingml/2006/chart" r:id="rId2"/>
-          </a:graphicData>
-        </a:graphic>
-      </p:graphicFrame>
-      <p:sp>
-        <p:nvSpPr>
-          <p:cNvPr id="22" name="TextBox 21"/>
-          <p:cNvSpPr txBox="1"/>
-          <p:nvPr/>
-        </p:nvSpPr>
-        <p:spPr>
-          <a:xfrm>
-            <a:off x="502920" y="5852160"/>
-            <a:ext cx="10972800" cy="228600"/>
-          </a:xfrm>
-          <a:prstGeom prst="rect">
-            <a:avLst/>
-          </a:prstGeom>
-          <a:noFill/>
-        </p:spPr>
-        <p:txBody>
-          <a:bodyPr wrap="square" anchor="t"/>
-          <a:lstStyle/>
-          <a:p>
-            <a:pPr algn="l"/>
-            <a:r>
-              <a:rPr sz="800" b="0" i="0">
+                <a:latin typeface="Georgia"/>
+              </a:rPr>
+              <a:t>Robin Zhu</a:t>
+            </a:r>
+          </a:p>
+        </p:txBody>
+      </p:sp>
+      <p:sp>
+        <p:nvSpPr>
+          <p:cNvPr id="26" name="TextBox 25"/>
+          <p:cNvSpPr txBox="1"/>
+          <p:nvPr/>
+        </p:nvSpPr>
+        <p:spPr>
+          <a:xfrm>
+            <a:off x="704088" y="3922776"/>
+            <a:ext cx="3337560" cy="256032"/>
+          </a:xfrm>
+          <a:prstGeom prst="rect">
+            <a:avLst/>
+          </a:prstGeom>
+          <a:noFill/>
+        </p:spPr>
+        <p:txBody>
+          <a:bodyPr wrap="square" anchor="t"/>
+          <a:lstStyle/>
+          <a:p>
+            <a:pPr algn="l"/>
+            <a:r>
+              <a:rPr sz="1000" b="1" i="0">
+                <a:solidFill>
+                  <a:srgbClr val="0A6B63"/>
+                </a:solidFill>
+                <a:latin typeface="Segoe UI"/>
+              </a:rPr>
+              <a:t>HEAD OF PRODUCT</a:t>
+            </a:r>
+          </a:p>
+        </p:txBody>
+      </p:sp>
+      <p:sp>
+        <p:nvSpPr>
+          <p:cNvPr id="27" name="TextBox 26"/>
+          <p:cNvSpPr txBox="1"/>
+          <p:nvPr/>
+        </p:nvSpPr>
+        <p:spPr>
+          <a:xfrm>
+            <a:off x="704088" y="4261104"/>
+            <a:ext cx="3310128" cy="594360"/>
+          </a:xfrm>
+          <a:prstGeom prst="rect">
+            <a:avLst/>
+          </a:prstGeom>
+          <a:noFill/>
+        </p:spPr>
+        <p:txBody>
+          <a:bodyPr wrap="square" anchor="t"/>
+          <a:lstStyle/>
+          <a:p>
+            <a:pPr algn="l"/>
+            <a:r>
+              <a:rPr sz="1000" b="0" i="0">
+                <a:solidFill>
+                  <a:srgbClr val="2C3A4B"/>
+                </a:solidFill>
+                <a:latin typeface="Segoe UI"/>
+              </a:rPr>
+              <a:t>▸  Leads product strategy, architecture, and development of the AI-powered platform</a:t>
+            </a:r>
+          </a:p>
+        </p:txBody>
+      </p:sp>
+      <p:sp>
+        <p:nvSpPr>
+          <p:cNvPr id="28" name="TextBox 27"/>
+          <p:cNvSpPr txBox="1"/>
+          <p:nvPr/>
+        </p:nvSpPr>
+        <p:spPr>
+          <a:xfrm>
+            <a:off x="704088" y="4882896"/>
+            <a:ext cx="3310128" cy="594360"/>
+          </a:xfrm>
+          <a:prstGeom prst="rect">
+            <a:avLst/>
+          </a:prstGeom>
+          <a:noFill/>
+        </p:spPr>
+        <p:txBody>
+          <a:bodyPr wrap="square" anchor="t"/>
+          <a:lstStyle/>
+          <a:p>
+            <a:pPr algn="l"/>
+            <a:r>
+              <a:rPr sz="1000" b="0" i="0">
+                <a:solidFill>
+                  <a:srgbClr val="2C3A4B"/>
+                </a:solidFill>
+                <a:latin typeface="Segoe UI"/>
+              </a:rPr>
+              <a:t>▸  Former CTO &amp; Director of Product, Ci Finance; senior product/tech roles at CPIC, Allinpay, Noah Holdings, and Tianrang Intelligence</a:t>
+            </a:r>
+          </a:p>
+        </p:txBody>
+      </p:sp>
+      <p:sp>
+        <p:nvSpPr>
+          <p:cNvPr id="29" name="Rounded Rectangle 28"/>
+          <p:cNvSpPr/>
+          <p:nvPr/>
+        </p:nvSpPr>
+        <p:spPr>
+          <a:xfrm>
+            <a:off x="4343400" y="3483864"/>
+            <a:ext cx="3657600" cy="2148840"/>
+          </a:xfrm>
+          <a:prstGeom prst="roundRect">
+            <a:avLst>
+              <a:gd name="adj" fmla="val 8000"/>
+            </a:avLst>
+          </a:prstGeom>
+          <a:solidFill>
+            <a:srgbClr val="FFFFFF"/>
+          </a:solidFill>
+          <a:ln w="12700">
+            <a:solidFill>
+              <a:srgbClr val="D4DEE8"/>
+            </a:solidFill>
+          </a:ln>
+        </p:spPr>
+        <p:style>
+          <a:lnRef idx="1">
+            <a:schemeClr val="accent1"/>
+          </a:lnRef>
+          <a:fillRef idx="3">
+            <a:schemeClr val="accent1"/>
+          </a:fillRef>
+          <a:effectRef idx="2">
+            <a:schemeClr val="accent1"/>
+          </a:effectRef>
+          <a:fontRef idx="minor">
+            <a:schemeClr val="lt1"/>
+          </a:fontRef>
+        </p:style>
+        <p:txBody>
+          <a:bodyPr rtlCol="0" anchor="ctr"/>
+          <a:lstStyle/>
+          <a:p>
+            <a:pPr algn="ctr"/>
+          </a:p>
+        </p:txBody>
+      </p:sp>
+      <p:sp>
+        <p:nvSpPr>
+          <p:cNvPr id="30" name="Rectangle 29"/>
+          <p:cNvSpPr/>
+          <p:nvPr/>
+        </p:nvSpPr>
+        <p:spPr>
+          <a:xfrm>
+            <a:off x="4343400" y="3483864"/>
+            <a:ext cx="73152" cy="2148840"/>
+          </a:xfrm>
+          <a:prstGeom prst="rect">
+            <a:avLst/>
+          </a:prstGeom>
+          <a:solidFill>
+            <a:srgbClr val="2F5D8A"/>
+          </a:solidFill>
+          <a:ln>
+            <a:noFill/>
+          </a:ln>
+        </p:spPr>
+        <p:style>
+          <a:lnRef idx="1">
+            <a:schemeClr val="accent1"/>
+          </a:lnRef>
+          <a:fillRef idx="3">
+            <a:schemeClr val="accent1"/>
+          </a:fillRef>
+          <a:effectRef idx="2">
+            <a:schemeClr val="accent1"/>
+          </a:effectRef>
+          <a:fontRef idx="minor">
+            <a:schemeClr val="lt1"/>
+          </a:fontRef>
+        </p:style>
+        <p:txBody>
+          <a:bodyPr rtlCol="0" anchor="ctr"/>
+          <a:lstStyle/>
+          <a:p>
+            <a:pPr algn="ctr"/>
+          </a:p>
+        </p:txBody>
+      </p:sp>
+      <p:sp>
+        <p:nvSpPr>
+          <p:cNvPr id="31" name="TextBox 30"/>
+          <p:cNvSpPr txBox="1"/>
+          <p:nvPr/>
+        </p:nvSpPr>
+        <p:spPr>
+          <a:xfrm>
+            <a:off x="4544568" y="3611880"/>
+            <a:ext cx="3337560" cy="320040"/>
+          </a:xfrm>
+          <a:prstGeom prst="rect">
+            <a:avLst/>
+          </a:prstGeom>
+          <a:noFill/>
+        </p:spPr>
+        <p:txBody>
+          <a:bodyPr wrap="square" anchor="t"/>
+          <a:lstStyle/>
+          <a:p>
+            <a:pPr algn="l"/>
+            <a:r>
+              <a:rPr sz="1500" b="1" i="0">
+                <a:solidFill>
+                  <a:srgbClr val="0B1F33"/>
+                </a:solidFill>
+                <a:latin typeface="Georgia"/>
+              </a:rPr>
+              <a:t>Chris Lin</a:t>
+            </a:r>
+          </a:p>
+        </p:txBody>
+      </p:sp>
+      <p:sp>
+        <p:nvSpPr>
+          <p:cNvPr id="32" name="TextBox 31"/>
+          <p:cNvSpPr txBox="1"/>
+          <p:nvPr/>
+        </p:nvSpPr>
+        <p:spPr>
+          <a:xfrm>
+            <a:off x="4544568" y="3922776"/>
+            <a:ext cx="3337560" cy="256032"/>
+          </a:xfrm>
+          <a:prstGeom prst="rect">
+            <a:avLst/>
+          </a:prstGeom>
+          <a:noFill/>
+        </p:spPr>
+        <p:txBody>
+          <a:bodyPr wrap="square" anchor="t"/>
+          <a:lstStyle/>
+          <a:p>
+            <a:pPr algn="l"/>
+            <a:r>
+              <a:rPr sz="1000" b="1" i="0">
+                <a:solidFill>
+                  <a:srgbClr val="0A6B63"/>
+                </a:solidFill>
+                <a:latin typeface="Segoe UI"/>
+              </a:rPr>
+              <a:t>NORTH AMERICAN PARTNER</a:t>
+            </a:r>
+          </a:p>
+        </p:txBody>
+      </p:sp>
+      <p:sp>
+        <p:nvSpPr>
+          <p:cNvPr id="33" name="TextBox 32"/>
+          <p:cNvSpPr txBox="1"/>
+          <p:nvPr/>
+        </p:nvSpPr>
+        <p:spPr>
+          <a:xfrm>
+            <a:off x="4544568" y="4261104"/>
+            <a:ext cx="3310128" cy="594360"/>
+          </a:xfrm>
+          <a:prstGeom prst="rect">
+            <a:avLst/>
+          </a:prstGeom>
+          <a:noFill/>
+        </p:spPr>
+        <p:txBody>
+          <a:bodyPr wrap="square" anchor="t"/>
+          <a:lstStyle/>
+          <a:p>
+            <a:pPr algn="l"/>
+            <a:r>
+              <a:rPr sz="1000" b="0" i="0">
+                <a:solidFill>
+                  <a:srgbClr val="2C3A4B"/>
+                </a:solidFill>
+                <a:latin typeface="Segoe UI"/>
+              </a:rPr>
+              <a:t>▸  Full-stack engineer; previously at Amazon Web Services (AWS) on mission-critical systems</a:t>
+            </a:r>
+          </a:p>
+        </p:txBody>
+      </p:sp>
+      <p:sp>
+        <p:nvSpPr>
+          <p:cNvPr id="34" name="TextBox 33"/>
+          <p:cNvSpPr txBox="1"/>
+          <p:nvPr/>
+        </p:nvSpPr>
+        <p:spPr>
+          <a:xfrm>
+            <a:off x="4544568" y="4882896"/>
+            <a:ext cx="3310128" cy="594360"/>
+          </a:xfrm>
+          <a:prstGeom prst="rect">
+            <a:avLst/>
+          </a:prstGeom>
+          <a:noFill/>
+        </p:spPr>
+        <p:txBody>
+          <a:bodyPr wrap="square" anchor="t"/>
+          <a:lstStyle/>
+          <a:p>
+            <a:pPr algn="l"/>
+            <a:r>
+              <a:rPr sz="1000" b="0" i="0">
+                <a:solidFill>
+                  <a:srgbClr val="2C3A4B"/>
+                </a:solidFill>
+                <a:latin typeface="Segoe UI"/>
+              </a:rPr>
+              <a:t>▸  B.S. Mechanical Engineering (Northwestern), M.S. Robotics; extensive hiring-panel experience and career mentorship</a:t>
+            </a:r>
+          </a:p>
+        </p:txBody>
+      </p:sp>
+      <p:sp>
+        <p:nvSpPr>
+          <p:cNvPr id="35" name="Rounded Rectangle 34"/>
+          <p:cNvSpPr/>
+          <p:nvPr/>
+        </p:nvSpPr>
+        <p:spPr>
+          <a:xfrm>
+            <a:off x="8183880" y="3483864"/>
+            <a:ext cx="3657600" cy="2148840"/>
+          </a:xfrm>
+          <a:prstGeom prst="roundRect">
+            <a:avLst>
+              <a:gd name="adj" fmla="val 8000"/>
+            </a:avLst>
+          </a:prstGeom>
+          <a:solidFill>
+            <a:srgbClr val="FFFFFF"/>
+          </a:solidFill>
+          <a:ln w="12700">
+            <a:solidFill>
+              <a:srgbClr val="D4DEE8"/>
+            </a:solidFill>
+          </a:ln>
+        </p:spPr>
+        <p:style>
+          <a:lnRef idx="1">
+            <a:schemeClr val="accent1"/>
+          </a:lnRef>
+          <a:fillRef idx="3">
+            <a:schemeClr val="accent1"/>
+          </a:fillRef>
+          <a:effectRef idx="2">
+            <a:schemeClr val="accent1"/>
+          </a:effectRef>
+          <a:fontRef idx="minor">
+            <a:schemeClr val="lt1"/>
+          </a:fontRef>
+        </p:style>
+        <p:txBody>
+          <a:bodyPr rtlCol="0" anchor="ctr"/>
+          <a:lstStyle/>
+          <a:p>
+            <a:pPr algn="ctr"/>
+          </a:p>
+        </p:txBody>
+      </p:sp>
+      <p:sp>
+        <p:nvSpPr>
+          <p:cNvPr id="36" name="Rectangle 35"/>
+          <p:cNvSpPr/>
+          <p:nvPr/>
+        </p:nvSpPr>
+        <p:spPr>
+          <a:xfrm>
+            <a:off x="8183880" y="3483864"/>
+            <a:ext cx="73152" cy="2148840"/>
+          </a:xfrm>
+          <a:prstGeom prst="rect">
+            <a:avLst/>
+          </a:prstGeom>
+          <a:solidFill>
+            <a:srgbClr val="8A6D3B"/>
+          </a:solidFill>
+          <a:ln>
+            <a:noFill/>
+          </a:ln>
+        </p:spPr>
+        <p:style>
+          <a:lnRef idx="1">
+            <a:schemeClr val="accent1"/>
+          </a:lnRef>
+          <a:fillRef idx="3">
+            <a:schemeClr val="accent1"/>
+          </a:fillRef>
+          <a:effectRef idx="2">
+            <a:schemeClr val="accent1"/>
+          </a:effectRef>
+          <a:fontRef idx="minor">
+            <a:schemeClr val="lt1"/>
+          </a:fontRef>
+        </p:style>
+        <p:txBody>
+          <a:bodyPr rtlCol="0" anchor="ctr"/>
+          <a:lstStyle/>
+          <a:p>
+            <a:pPr algn="ctr"/>
+          </a:p>
+        </p:txBody>
+      </p:sp>
+      <p:sp>
+        <p:nvSpPr>
+          <p:cNvPr id="37" name="TextBox 36"/>
+          <p:cNvSpPr txBox="1"/>
+          <p:nvPr/>
+        </p:nvSpPr>
+        <p:spPr>
+          <a:xfrm>
+            <a:off x="8385048" y="3611880"/>
+            <a:ext cx="3337560" cy="320040"/>
+          </a:xfrm>
+          <a:prstGeom prst="rect">
+            <a:avLst/>
+          </a:prstGeom>
+          <a:noFill/>
+        </p:spPr>
+        <p:txBody>
+          <a:bodyPr wrap="square" anchor="t"/>
+          <a:lstStyle/>
+          <a:p>
+            <a:pPr algn="l"/>
+            <a:r>
+              <a:rPr sz="1500" b="1" i="0">
+                <a:solidFill>
+                  <a:srgbClr val="0B1F33"/>
+                </a:solidFill>
+                <a:latin typeface="Georgia"/>
+              </a:rPr>
+              <a:t>Jon Serbin</a:t>
+            </a:r>
+          </a:p>
+        </p:txBody>
+      </p:sp>
+      <p:sp>
+        <p:nvSpPr>
+          <p:cNvPr id="38" name="TextBox 37"/>
+          <p:cNvSpPr txBox="1"/>
+          <p:nvPr/>
+        </p:nvSpPr>
+        <p:spPr>
+          <a:xfrm>
+            <a:off x="8385048" y="3922776"/>
+            <a:ext cx="3337560" cy="256032"/>
+          </a:xfrm>
+          <a:prstGeom prst="rect">
+            <a:avLst/>
+          </a:prstGeom>
+          <a:noFill/>
+        </p:spPr>
+        <p:txBody>
+          <a:bodyPr wrap="square" anchor="t"/>
+          <a:lstStyle/>
+          <a:p>
+            <a:pPr algn="l"/>
+            <a:r>
+              <a:rPr sz="1000" b="1" i="0">
+                <a:solidFill>
+                  <a:srgbClr val="0A6B63"/>
+                </a:solidFill>
+                <a:latin typeface="Segoe UI"/>
+              </a:rPr>
+              <a:t>SENIOR ADVISOR</a:t>
+            </a:r>
+          </a:p>
+        </p:txBody>
+      </p:sp>
+      <p:sp>
+        <p:nvSpPr>
+          <p:cNvPr id="39" name="TextBox 38"/>
+          <p:cNvSpPr txBox="1"/>
+          <p:nvPr/>
+        </p:nvSpPr>
+        <p:spPr>
+          <a:xfrm>
+            <a:off x="8385048" y="4261104"/>
+            <a:ext cx="3310128" cy="594360"/>
+          </a:xfrm>
+          <a:prstGeom prst="rect">
+            <a:avLst/>
+          </a:prstGeom>
+          <a:noFill/>
+        </p:spPr>
+        <p:txBody>
+          <a:bodyPr wrap="square" anchor="t"/>
+          <a:lstStyle/>
+          <a:p>
+            <a:pPr algn="l"/>
+            <a:r>
+              <a:rPr sz="1000" b="0" i="0">
+                <a:solidFill>
+                  <a:srgbClr val="2C3A4B"/>
+                </a:solidFill>
+                <a:latin typeface="Segoe UI"/>
+              </a:rPr>
+              <a:t>▸  Harvard &amp; MIT; former senior executive at Morgan Stanley; founder of Cedar (Wall Street investment banking)</a:t>
+            </a:r>
+          </a:p>
+        </p:txBody>
+      </p:sp>
+      <p:sp>
+        <p:nvSpPr>
+          <p:cNvPr id="40" name="TextBox 39"/>
+          <p:cNvSpPr txBox="1"/>
+          <p:nvPr/>
+        </p:nvSpPr>
+        <p:spPr>
+          <a:xfrm>
+            <a:off x="8385048" y="4882896"/>
+            <a:ext cx="3310128" cy="594360"/>
+          </a:xfrm>
+          <a:prstGeom prst="rect">
+            <a:avLst/>
+          </a:prstGeom>
+          <a:noFill/>
+        </p:spPr>
+        <p:txBody>
+          <a:bodyPr wrap="square" anchor="t"/>
+          <a:lstStyle/>
+          <a:p>
+            <a:pPr algn="l"/>
+            <a:r>
+              <a:rPr sz="1000" b="0" i="0">
+                <a:solidFill>
+                  <a:srgbClr val="2C3A4B"/>
+                </a:solidFill>
+                <a:latin typeface="Segoe UI"/>
+              </a:rPr>
+              <a:t>▸  40+ years advising tech M&amp;A, capital raising, and listings; advises 51Careers.AI on growth, capital markets, and expansion</a:t>
+            </a:r>
+          </a:p>
+        </p:txBody>
+      </p:sp>
+      <p:sp>
+        <p:nvSpPr>
+          <p:cNvPr id="41" name="TextBox 40"/>
+          <p:cNvSpPr txBox="1"/>
+          <p:nvPr/>
+        </p:nvSpPr>
+        <p:spPr>
+          <a:xfrm>
+            <a:off x="502920" y="5760720"/>
+            <a:ext cx="11155680" cy="274320"/>
+          </a:xfrm>
+          <a:prstGeom prst="rect">
+            <a:avLst/>
+          </a:prstGeom>
+          <a:noFill/>
+        </p:spPr>
+        <p:txBody>
+          <a:bodyPr wrap="square" anchor="t"/>
+          <a:lstStyle/>
+          <a:p>
+            <a:pPr algn="l"/>
+            <a:r>
+              <a:rPr sz="900" b="0" i="0">
                 <a:solidFill>
                   <a:srgbClr val="5E6E80"/>
                 </a:solidFill>
                 <a:latin typeface="Segoe UI"/>
               </a:rPr>
-              <a:t>† Headcount per third-party estimates (2025); to be confirmed in due diligence.</a:t>
-            </a:r>
-          </a:p>
-        </p:txBody>
-      </p:sp>
-      <p:sp>
-        <p:nvSpPr>
-          <p:cNvPr id="23" name="Rectangle 22"/>
+              <a:t>Supported by ≈50 professionals across New York, Shanghai, London, Singapore, Seoul, Toronto, and Delhi. Full biographies available in the data room.</a:t>
+            </a:r>
+          </a:p>
+        </p:txBody>
+      </p:sp>
+      <p:sp>
+        <p:nvSpPr>
+          <p:cNvPr id="42" name="Rectangle 41"/>
           <p:cNvSpPr/>
           <p:nvPr/>
         </p:nvSpPr>
@@ -10958,7 +11500,7 @@
       </p:sp>
       <p:sp>
         <p:nvSpPr>
-          <p:cNvPr id="24" name="Rectangle 23"/>
+          <p:cNvPr id="43" name="Rectangle 42"/>
           <p:cNvSpPr/>
           <p:nvPr/>
         </p:nvSpPr>
@@ -11001,7 +11543,7 @@
       </p:sp>
       <p:sp>
         <p:nvSpPr>
-          <p:cNvPr id="25" name="TextBox 24"/>
+          <p:cNvPr id="44" name="TextBox 43"/>
           <p:cNvSpPr txBox="1"/>
           <p:nvPr/>
         </p:nvSpPr>
@@ -11034,7 +11576,7 @@
       </p:sp>
       <p:sp>
         <p:nvSpPr>
-          <p:cNvPr id="26" name="TextBox 25"/>
+          <p:cNvPr id="45" name="TextBox 44"/>
           <p:cNvSpPr txBox="1"/>
           <p:nvPr/>
         </p:nvSpPr>

</xml_diff>

<commit_message>
Align deck to free AI platform narrative and LLM comparison
Correct platform revenue to US$0, emphasize who we are and the product
(mock interviews, 100K+ questions, AI résumé builder), use global market
sizing, add OpenAI/Gemini/Claude comparison, and frame monetization via
membership, consulting, and education fees as users scale.

Co-authored-by: anthonyleedu <anthonyleedu@users.noreply.github.com>
</commit_message>
<xml_diff>
--- a/51Careers_AI_Investor_Presentation.pptx
+++ b/51Careers_AI_Investor_Presentation.pptx
@@ -139,7 +139,7 @@
               <c:strCache>
                 <c:ptCount val="1"/>
                 <c:pt idx="0">
-                  <c:v>AI hiring tech</c:v>
+                  <c:v>Global AI hiring &amp; career tech</c:v>
                 </c:pt>
               </c:strCache>
             </c:strRef>
@@ -187,16 +187,16 @@
                   <c:v>18</c:v>
                 </c:pt>
                 <c:pt idx="1">
-                  <c:v>22</c:v>
+                  <c:v>23</c:v>
                 </c:pt>
                 <c:pt idx="2">
-                  <c:v>27</c:v>
+                  <c:v>29</c:v>
                 </c:pt>
                 <c:pt idx="3">
-                  <c:v>33</c:v>
+                  <c:v>37</c:v>
                 </c:pt>
                 <c:pt idx="4">
-                  <c:v>40</c:v>
+                  <c:v>46</c:v>
                 </c:pt>
               </c:numCache>
             </c:numRef>
@@ -321,7 +321,7 @@
               <c:strCache>
                 <c:ptCount val="1"/>
                 <c:pt idx="0">
-                  <c:v>Premium services</c:v>
+                  <c:v>Membership fees</c:v>
                 </c:pt>
               </c:strCache>
             </c:strRef>
@@ -342,7 +342,7 @@
               <c:strCache>
                 <c:ptCount val="3"/>
                 <c:pt idx="0">
-                  <c:v>Today</c:v>
+                  <c:v>Launch</c:v>
                 </c:pt>
                 <c:pt idx="1">
                   <c:v>2027E</c:v>
@@ -360,13 +360,13 @@
                 <c:formatCode>General</c:formatCode>
                 <c:ptCount val="3"/>
                 <c:pt idx="0">
-                  <c:v>70</c:v>
+                  <c:v>0</c:v>
                 </c:pt>
                 <c:pt idx="1">
-                  <c:v>45</c:v>
+                  <c:v>55</c:v>
                 </c:pt>
                 <c:pt idx="2">
-                  <c:v>25</c:v>
+                  <c:v>50</c:v>
                 </c:pt>
               </c:numCache>
             </c:numRef>
@@ -381,7 +381,7 @@
               <c:strCache>
                 <c:ptCount val="1"/>
                 <c:pt idx="0">
-                  <c:v>Consumer platform</c:v>
+                  <c:v>Consulting fees</c:v>
                 </c:pt>
               </c:strCache>
             </c:strRef>
@@ -402,7 +402,7 @@
               <c:strCache>
                 <c:ptCount val="3"/>
                 <c:pt idx="0">
-                  <c:v>Today</c:v>
+                  <c:v>Launch</c:v>
                 </c:pt>
                 <c:pt idx="1">
                   <c:v>2027E</c:v>
@@ -420,13 +420,13 @@
                 <c:formatCode>General</c:formatCode>
                 <c:ptCount val="3"/>
                 <c:pt idx="0">
-                  <c:v>25</c:v>
+                  <c:v>0</c:v>
                 </c:pt>
                 <c:pt idx="1">
-                  <c:v>35</c:v>
+                  <c:v>30</c:v>
                 </c:pt>
                 <c:pt idx="2">
-                  <c:v>40</c:v>
+                  <c:v>30</c:v>
                 </c:pt>
               </c:numCache>
             </c:numRef>
@@ -441,7 +441,7 @@
               <c:strCache>
                 <c:ptCount val="1"/>
                 <c:pt idx="0">
-                  <c:v>Employer SaaS</c:v>
+                  <c:v>Education fees</c:v>
                 </c:pt>
               </c:strCache>
             </c:strRef>
@@ -462,7 +462,7 @@
               <c:strCache>
                 <c:ptCount val="3"/>
                 <c:pt idx="0">
-                  <c:v>Today</c:v>
+                  <c:v>Launch</c:v>
                 </c:pt>
                 <c:pt idx="1">
                   <c:v>2027E</c:v>
@@ -480,13 +480,13 @@
                 <c:formatCode>General</c:formatCode>
                 <c:ptCount val="3"/>
                 <c:pt idx="0">
-                  <c:v>5</c:v>
+                  <c:v>0</c:v>
                 </c:pt>
                 <c:pt idx="1">
-                  <c:v>20</c:v>
+                  <c:v>15</c:v>
                 </c:pt>
                 <c:pt idx="2">
-                  <c:v>35</c:v>
+                  <c:v>20</c:v>
                 </c:pt>
               </c:numCache>
             </c:numRef>
@@ -630,7 +630,7 @@
               <c:strCache>
                 <c:ptCount val="1"/>
                 <c:pt idx="0">
-                  <c:v>Coverage (0–6)</c:v>
+                  <c:v>Career AI depth</c:v>
                 </c:pt>
               </c:strCache>
             </c:strRef>
@@ -654,16 +654,16 @@
                   <c:v>51Careers.AI</c:v>
                 </c:pt>
                 <c:pt idx="1">
-                  <c:v>Job Boards</c:v>
+                  <c:v>ChatGPT / OpenAI</c:v>
                 </c:pt>
                 <c:pt idx="2">
-                  <c:v>Prep Apps</c:v>
+                  <c:v>Google Gemini</c:v>
                 </c:pt>
                 <c:pt idx="3">
-                  <c:v>Coaching Firms</c:v>
+                  <c:v>Claude</c:v>
                 </c:pt>
                 <c:pt idx="4">
-                  <c:v>Staffing Agencies</c:v>
+                  <c:v>Generic prep apps</c:v>
                 </c:pt>
               </c:strCache>
             </c:strRef>
@@ -678,16 +678,16 @@
                   <c:v>6</c:v>
                 </c:pt>
                 <c:pt idx="1">
-                  <c:v>1</c:v>
+                  <c:v>2</c:v>
                 </c:pt>
                 <c:pt idx="2">
                   <c:v>2</c:v>
                 </c:pt>
                 <c:pt idx="3">
-                  <c:v>3</c:v>
+                  <c:v>2</c:v>
                 </c:pt>
                 <c:pt idx="4">
-                  <c:v>2</c:v>
+                  <c:v>3</c:v>
                 </c:pt>
               </c:numCache>
             </c:numRef>
@@ -812,7 +812,7 @@
               <c:strCache>
                 <c:ptCount val="1"/>
                 <c:pt idx="0">
-                  <c:v>Active markets</c:v>
+                  <c:v>Active users (index)</c:v>
                 </c:pt>
               </c:strCache>
             </c:strRef>
@@ -857,19 +857,19 @@
                 <c:formatCode>General</c:formatCode>
                 <c:ptCount val="5"/>
                 <c:pt idx="0">
-                  <c:v>3</c:v>
+                  <c:v>10</c:v>
                 </c:pt>
                 <c:pt idx="1">
-                  <c:v>4</c:v>
+                  <c:v>35</c:v>
                 </c:pt>
                 <c:pt idx="2">
-                  <c:v>8</c:v>
+                  <c:v>80</c:v>
                 </c:pt>
                 <c:pt idx="3">
-                  <c:v>8</c:v>
+                  <c:v>140</c:v>
                 </c:pt>
                 <c:pt idx="4">
-                  <c:v>10</c:v>
+                  <c:v>220</c:v>
                 </c:pt>
               </c:numCache>
             </c:numRef>
@@ -989,7 +989,7 @@
     <c:plotArea>
       <c:barChart>
         <c:barDir val="col"/>
-        <c:grouping val="stacked"/>
+        <c:grouping val="clustered"/>
         <c:ser>
           <c:idx val="0"/>
           <c:order val="0"/>
@@ -999,7 +999,7 @@
               <c:strCache>
                 <c:ptCount val="1"/>
                 <c:pt idx="0">
-                  <c:v>Estimated base</c:v>
+                  <c:v>Platform revenue</c:v>
                 </c:pt>
               </c:strCache>
             </c:strRef>
@@ -1020,7 +1020,7 @@
               <c:strCache>
                 <c:ptCount val="5"/>
                 <c:pt idx="0">
-                  <c:v>2025E</c:v>
+                  <c:v>2025A</c:v>
                 </c:pt>
                 <c:pt idx="1">
                   <c:v>2026E</c:v>
@@ -1044,82 +1044,24 @@
                 <c:formatCode>General</c:formatCode>
                 <c:ptCount val="5"/>
                 <c:pt idx="0">
-                  <c:v>10</c:v>
+                  <c:v>0</c:v>
+                </c:pt>
+                <c:pt idx="1">
+                  <c:v>0.8</c:v>
+                </c:pt>
+                <c:pt idx="2">
+                  <c:v>3.5</c:v>
+                </c:pt>
+                <c:pt idx="3">
+                  <c:v>9.0</c:v>
+                </c:pt>
+                <c:pt idx="4">
+                  <c:v>18.0</c:v>
                 </c:pt>
               </c:numCache>
             </c:numRef>
           </c:val>
         </c:ser>
-        <c:ser>
-          <c:idx val="1"/>
-          <c:order val="1"/>
-          <c:tx>
-            <c:strRef>
-              <c:f>Sheet1!$C$1</c:f>
-              <c:strCache>
-                <c:ptCount val="1"/>
-                <c:pt idx="0">
-                  <c:v>Projected</c:v>
-                </c:pt>
-              </c:strCache>
-            </c:strRef>
-          </c:tx>
-          <c:spPr>
-            <a:solidFill>
-              <a:srgbClr val="2F5D8A"/>
-            </a:solidFill>
-            <a:ln>
-              <a:solidFill>
-                <a:srgbClr val="2F5D8A"/>
-              </a:solidFill>
-            </a:ln>
-          </c:spPr>
-          <c:cat>
-            <c:strRef>
-              <c:f>Sheet1!$A$2:$A$6</c:f>
-              <c:strCache>
-                <c:ptCount val="5"/>
-                <c:pt idx="0">
-                  <c:v>2025E</c:v>
-                </c:pt>
-                <c:pt idx="1">
-                  <c:v>2026E</c:v>
-                </c:pt>
-                <c:pt idx="2">
-                  <c:v>2027E</c:v>
-                </c:pt>
-                <c:pt idx="3">
-                  <c:v>2028E</c:v>
-                </c:pt>
-                <c:pt idx="4">
-                  <c:v>2029E</c:v>
-                </c:pt>
-              </c:strCache>
-            </c:strRef>
-          </c:cat>
-          <c:val>
-            <c:numRef>
-              <c:f>Sheet1!$C$2:$C$6</c:f>
-              <c:numCache>
-                <c:formatCode>General</c:formatCode>
-                <c:ptCount val="5"/>
-                <c:pt idx="1">
-                  <c:v>14.5</c:v>
-                </c:pt>
-                <c:pt idx="2">
-                  <c:v>22.5</c:v>
-                </c:pt>
-                <c:pt idx="3">
-                  <c:v>34</c:v>
-                </c:pt>
-                <c:pt idx="4">
-                  <c:v>52</c:v>
-                </c:pt>
-              </c:numCache>
-            </c:numRef>
-          </c:val>
-        </c:ser>
-        <c:overlap val="100"/>
         <c:axId val="-2068027336"/>
         <c:axId val="-2113994440"/>
       </c:barChart>
@@ -1203,24 +1145,6 @@
         <c:crosses val="autoZero"/>
       </c:valAx>
     </c:plotArea>
-    <c:legend>
-      <c:legendPos val="b"/>
-      <c:overlay val="0"/>
-      <c:txPr>
-        <a:bodyPr/>
-        <a:lstStyle/>
-        <a:p>
-          <a:pPr>
-            <a:defRPr sz="900">
-              <a:solidFill>
-                <a:srgbClr val="5E6E80"/>
-              </a:solidFill>
-              <a:latin typeface="Segoe UI"/>
-            </a:defRPr>
-          </a:pPr>
-        </a:p>
-      </c:txPr>
-    </c:legend>
     <c:dispBlanksAs val="gap"/>
   </c:chart>
   <c:txPr>
@@ -1257,7 +1181,7 @@
               <c:strCache>
                 <c:ptCount val="1"/>
                 <c:pt idx="0">
-                  <c:v>Gross margin</c:v>
+                  <c:v>Paid conversion</c:v>
                 </c:pt>
               </c:strCache>
             </c:strRef>
@@ -1278,7 +1202,7 @@
               <c:strCache>
                 <c:ptCount val="5"/>
                 <c:pt idx="0">
-                  <c:v>2025E</c:v>
+                  <c:v>2025A</c:v>
                 </c:pt>
                 <c:pt idx="1">
                   <c:v>2026E</c:v>
@@ -1302,19 +1226,19 @@
                 <c:formatCode>General</c:formatCode>
                 <c:ptCount val="5"/>
                 <c:pt idx="0">
-                  <c:v>42</c:v>
+                  <c:v>0</c:v>
                 </c:pt>
                 <c:pt idx="1">
-                  <c:v>48</c:v>
+                  <c:v>2</c:v>
                 </c:pt>
                 <c:pt idx="2">
-                  <c:v>55</c:v>
+                  <c:v>5</c:v>
                 </c:pt>
                 <c:pt idx="3">
-                  <c:v>60</c:v>
+                  <c:v>8</c:v>
                 </c:pt>
                 <c:pt idx="4">
-                  <c:v>65</c:v>
+                  <c:v>12</c:v>
                 </c:pt>
               </c:numCache>
             </c:numRef>
@@ -4717,7 +4641,139 @@
         </p:nvSpPr>
         <p:spPr>
           <a:xfrm>
-            <a:off x="640080" y="502920"/>
+            <a:off x="640080" y="457200"/>
+            <a:ext cx="9144000" cy="274320"/>
+          </a:xfrm>
+          <a:prstGeom prst="rect">
+            <a:avLst/>
+          </a:prstGeom>
+          <a:noFill/>
+        </p:spPr>
+        <p:txBody>
+          <a:bodyPr wrap="square" anchor="t"/>
+          <a:lstStyle/>
+          <a:p>
+            <a:pPr algn="l"/>
+            <a:r>
+              <a:rPr sz="1100" b="1" i="0">
+                <a:solidFill>
+                  <a:srgbClr val="D7EBE8"/>
+                </a:solidFill>
+                <a:latin typeface="Segoe UI"/>
+              </a:rPr>
+              <a:t>CONFIDENTIAL INVESTOR PRESENTATION</a:t>
+            </a:r>
+          </a:p>
+        </p:txBody>
+      </p:sp>
+      <p:sp>
+        <p:nvSpPr>
+          <p:cNvPr id="6" name="TextBox 5"/>
+          <p:cNvSpPr txBox="1"/>
+          <p:nvPr/>
+        </p:nvSpPr>
+        <p:spPr>
+          <a:xfrm>
+            <a:off x="640080" y="1051560"/>
+            <a:ext cx="10058400" cy="685800"/>
+          </a:xfrm>
+          <a:prstGeom prst="rect">
+            <a:avLst/>
+          </a:prstGeom>
+          <a:noFill/>
+        </p:spPr>
+        <p:txBody>
+          <a:bodyPr wrap="square" anchor="t"/>
+          <a:lstStyle/>
+          <a:p>
+            <a:pPr algn="l"/>
+            <a:r>
+              <a:rPr sz="4600" b="1" i="0">
+                <a:solidFill>
+                  <a:srgbClr val="FFFFFF"/>
+                </a:solidFill>
+                <a:latin typeface="Georgia"/>
+              </a:rPr>
+              <a:t>51CAREERS.AI</a:t>
+            </a:r>
+          </a:p>
+        </p:txBody>
+      </p:sp>
+      <p:sp>
+        <p:nvSpPr>
+          <p:cNvPr id="7" name="TextBox 6"/>
+          <p:cNvSpPr txBox="1"/>
+          <p:nvPr/>
+        </p:nvSpPr>
+        <p:spPr>
+          <a:xfrm>
+            <a:off x="640080" y="1783080"/>
+            <a:ext cx="10058400" cy="365760"/>
+          </a:xfrm>
+          <a:prstGeom prst="rect">
+            <a:avLst/>
+          </a:prstGeom>
+          <a:noFill/>
+        </p:spPr>
+        <p:txBody>
+          <a:bodyPr wrap="square" anchor="t"/>
+          <a:lstStyle/>
+          <a:p>
+            <a:pPr algn="l"/>
+            <a:r>
+              <a:rPr sz="1800" b="0" i="0">
+                <a:solidFill>
+                  <a:srgbClr val="C5D5E0"/>
+                </a:solidFill>
+                <a:latin typeface="Segoe UI"/>
+              </a:rPr>
+              <a:t>The AI-Powered Global Career Platform</a:t>
+            </a:r>
+          </a:p>
+        </p:txBody>
+      </p:sp>
+      <p:sp>
+        <p:nvSpPr>
+          <p:cNvPr id="8" name="TextBox 7"/>
+          <p:cNvSpPr txBox="1"/>
+          <p:nvPr/>
+        </p:nvSpPr>
+        <p:spPr>
+          <a:xfrm>
+            <a:off x="640080" y="2240280"/>
+            <a:ext cx="10515600" cy="502920"/>
+          </a:xfrm>
+          <a:prstGeom prst="rect">
+            <a:avLst/>
+          </a:prstGeom>
+          <a:noFill/>
+        </p:spPr>
+        <p:txBody>
+          <a:bodyPr wrap="square" anchor="t"/>
+          <a:lstStyle/>
+          <a:p>
+            <a:pPr algn="l"/>
+            <a:r>
+              <a:rPr sz="1300" b="0" i="0">
+                <a:solidFill>
+                  <a:srgbClr val="A8BECC"/>
+                </a:solidFill>
+                <a:latin typeface="Segoe UI"/>
+              </a:rPr>
+              <a:t>Who we are — An AI career platform from the 51 Careers team: mock interviews, a 100K+ question bank, and a new AI résumé builder — free today, built for global professionals.</a:t>
+            </a:r>
+          </a:p>
+        </p:txBody>
+      </p:sp>
+      <p:sp>
+        <p:nvSpPr>
+          <p:cNvPr id="9" name="TextBox 8"/>
+          <p:cNvSpPr txBox="1"/>
+          <p:nvPr/>
+        </p:nvSpPr>
+        <p:spPr>
+          <a:xfrm>
+            <a:off x="640080" y="2880360"/>
             <a:ext cx="7315200" cy="274320"/>
           </a:xfrm>
           <a:prstGeom prst="rect">
@@ -4731,144 +4787,45 @@
           <a:p>
             <a:pPr algn="l"/>
             <a:r>
-              <a:rPr sz="1100" b="1" i="0">
-                <a:solidFill>
-                  <a:srgbClr val="D7EBE8"/>
+              <a:rPr sz="1300" b="1" i="0">
+                <a:solidFill>
+                  <a:srgbClr val="0A6B63"/>
                 </a:solidFill>
                 <a:latin typeface="Segoe UI"/>
               </a:rPr>
-              <a:t>CONFIDENTIAL INVESTOR PRESENTATION</a:t>
-            </a:r>
-          </a:p>
-        </p:txBody>
-      </p:sp>
-      <p:sp>
-        <p:nvSpPr>
-          <p:cNvPr id="6" name="TextBox 5"/>
-          <p:cNvSpPr txBox="1"/>
-          <p:nvPr/>
-        </p:nvSpPr>
-        <p:spPr>
-          <a:xfrm>
-            <a:off x="640080" y="1234440"/>
-            <a:ext cx="9144000" cy="777240"/>
-          </a:xfrm>
-          <a:prstGeom prst="rect">
-            <a:avLst/>
-          </a:prstGeom>
-          <a:noFill/>
-        </p:spPr>
-        <p:txBody>
-          <a:bodyPr wrap="square" anchor="t"/>
-          <a:lstStyle/>
-          <a:p>
-            <a:pPr algn="l"/>
-            <a:r>
-              <a:rPr sz="4800" b="1" i="0">
+              <a:t>Growth Financing</a:t>
+            </a:r>
+          </a:p>
+        </p:txBody>
+      </p:sp>
+      <p:sp>
+        <p:nvSpPr>
+          <p:cNvPr id="10" name="TextBox 9"/>
+          <p:cNvSpPr txBox="1"/>
+          <p:nvPr/>
+        </p:nvSpPr>
+        <p:spPr>
+          <a:xfrm>
+            <a:off x="640080" y="3154680"/>
+            <a:ext cx="8229600" cy="274320"/>
+          </a:xfrm>
+          <a:prstGeom prst="rect">
+            <a:avLst/>
+          </a:prstGeom>
+          <a:noFill/>
+        </p:spPr>
+        <p:txBody>
+          <a:bodyPr wrap="square" anchor="t"/>
+          <a:lstStyle/>
+          <a:p>
+            <a:pPr algn="l"/>
+            <a:r>
+              <a:rPr sz="1400" b="0" i="0">
                 <a:solidFill>
                   <a:srgbClr val="FFFFFF"/>
                 </a:solidFill>
-                <a:latin typeface="Georgia"/>
-              </a:rPr>
-              <a:t>51CAREERS.AI</a:t>
-            </a:r>
-          </a:p>
-        </p:txBody>
-      </p:sp>
-      <p:sp>
-        <p:nvSpPr>
-          <p:cNvPr id="7" name="TextBox 6"/>
-          <p:cNvSpPr txBox="1"/>
-          <p:nvPr/>
-        </p:nvSpPr>
-        <p:spPr>
-          <a:xfrm>
-            <a:off x="640080" y="2011680"/>
-            <a:ext cx="9144000" cy="365760"/>
-          </a:xfrm>
-          <a:prstGeom prst="rect">
-            <a:avLst/>
-          </a:prstGeom>
-          <a:noFill/>
-        </p:spPr>
-        <p:txBody>
-          <a:bodyPr wrap="square" anchor="t"/>
-          <a:lstStyle/>
-          <a:p>
-            <a:pPr algn="l"/>
-            <a:r>
-              <a:rPr sz="1800" b="0" i="0">
-                <a:solidFill>
-                  <a:srgbClr val="C5D5E0"/>
-                </a:solidFill>
                 <a:latin typeface="Segoe UI"/>
               </a:rPr>
-              <a:t>The AI-Powered Global Career Platform</a:t>
-            </a:r>
-          </a:p>
-        </p:txBody>
-      </p:sp>
-      <p:sp>
-        <p:nvSpPr>
-          <p:cNvPr id="8" name="TextBox 7"/>
-          <p:cNvSpPr txBox="1"/>
-          <p:nvPr/>
-        </p:nvSpPr>
-        <p:spPr>
-          <a:xfrm>
-            <a:off x="640080" y="2743200"/>
-            <a:ext cx="7315200" cy="320040"/>
-          </a:xfrm>
-          <a:prstGeom prst="rect">
-            <a:avLst/>
-          </a:prstGeom>
-          <a:noFill/>
-        </p:spPr>
-        <p:txBody>
-          <a:bodyPr wrap="square" anchor="t"/>
-          <a:lstStyle/>
-          <a:p>
-            <a:pPr algn="l"/>
-            <a:r>
-              <a:rPr sz="1400" b="1" i="0">
-                <a:solidFill>
-                  <a:srgbClr val="0A6B63"/>
-                </a:solidFill>
-                <a:latin typeface="Segoe UI"/>
-              </a:rPr>
-              <a:t>Growth Financing</a:t>
-            </a:r>
-          </a:p>
-        </p:txBody>
-      </p:sp>
-      <p:sp>
-        <p:nvSpPr>
-          <p:cNvPr id="9" name="TextBox 8"/>
-          <p:cNvSpPr txBox="1"/>
-          <p:nvPr/>
-        </p:nvSpPr>
-        <p:spPr>
-          <a:xfrm>
-            <a:off x="640080" y="3063240"/>
-            <a:ext cx="8229600" cy="320040"/>
-          </a:xfrm>
-          <a:prstGeom prst="rect">
-            <a:avLst/>
-          </a:prstGeom>
-          <a:noFill/>
-        </p:spPr>
-        <p:txBody>
-          <a:bodyPr wrap="square" anchor="t"/>
-          <a:lstStyle/>
-          <a:p>
-            <a:pPr algn="l"/>
-            <a:r>
-              <a:rPr sz="1400" b="0" i="0">
-                <a:solidFill>
-                  <a:srgbClr val="FFFFFF"/>
-                </a:solidFill>
-                <a:latin typeface="Segoe UI"/>
-              </a:rPr>
               <a:t>US$5.0 Million Private Placement   ·   July 2026</a:t>
             </a:r>
           </a:p>
@@ -4876,14 +4833,14 @@
       </p:sp>
       <p:sp>
         <p:nvSpPr>
-          <p:cNvPr id="10" name="Rounded Rectangle 9"/>
+          <p:cNvPr id="11" name="Rounded Rectangle 10"/>
           <p:cNvSpPr/>
           <p:nvPr/>
         </p:nvSpPr>
         <p:spPr>
           <a:xfrm>
-            <a:off x="640080" y="3840480"/>
-            <a:ext cx="3200400" cy="1234440"/>
+            <a:off x="502920" y="3794760"/>
+            <a:ext cx="2697480" cy="1234440"/>
           </a:xfrm>
           <a:prstGeom prst="roundRect">
             <a:avLst>
@@ -4921,47 +4878,47 @@
       </p:sp>
       <p:sp>
         <p:nvSpPr>
-          <p:cNvPr id="11" name="TextBox 10"/>
-          <p:cNvSpPr txBox="1"/>
-          <p:nvPr/>
-        </p:nvSpPr>
-        <p:spPr>
-          <a:xfrm>
-            <a:off x="868680" y="3977639"/>
-            <a:ext cx="2743200" cy="548640"/>
-          </a:xfrm>
-          <a:prstGeom prst="rect">
-            <a:avLst/>
-          </a:prstGeom>
-          <a:noFill/>
-        </p:spPr>
-        <p:txBody>
-          <a:bodyPr wrap="square" anchor="t"/>
-          <a:lstStyle/>
-          <a:p>
-            <a:pPr algn="l"/>
-            <a:r>
-              <a:rPr sz="3200" b="1" i="0">
+          <p:cNvPr id="12" name="TextBox 11"/>
+          <p:cNvSpPr txBox="1"/>
+          <p:nvPr/>
+        </p:nvSpPr>
+        <p:spPr>
+          <a:xfrm>
+            <a:off x="667512" y="3931920"/>
+            <a:ext cx="2377440" cy="502920"/>
+          </a:xfrm>
+          <a:prstGeom prst="rect">
+            <a:avLst/>
+          </a:prstGeom>
+          <a:noFill/>
+        </p:spPr>
+        <p:txBody>
+          <a:bodyPr wrap="square" anchor="t"/>
+          <a:lstStyle/>
+          <a:p>
+            <a:pPr algn="l"/>
+            <a:r>
+              <a:rPr sz="2600" b="1" i="0">
                 <a:solidFill>
                   <a:srgbClr val="FFFFFF"/>
                 </a:solidFill>
                 <a:latin typeface="Georgia"/>
               </a:rPr>
-              <a:t>2016</a:t>
-            </a:r>
-          </a:p>
-        </p:txBody>
-      </p:sp>
-      <p:sp>
-        <p:nvSpPr>
-          <p:cNvPr id="12" name="TextBox 11"/>
-          <p:cNvSpPr txBox="1"/>
-          <p:nvPr/>
-        </p:nvSpPr>
-        <p:spPr>
-          <a:xfrm>
-            <a:off x="868680" y="4617720"/>
-            <a:ext cx="2743200" cy="320040"/>
+              <a:t>2025</a:t>
+            </a:r>
+          </a:p>
+        </p:txBody>
+      </p:sp>
+      <p:sp>
+        <p:nvSpPr>
+          <p:cNvPr id="13" name="TextBox 12"/>
+          <p:cNvSpPr txBox="1"/>
+          <p:nvPr/>
+        </p:nvSpPr>
+        <p:spPr>
+          <a:xfrm>
+            <a:off x="667512" y="4526280"/>
+            <a:ext cx="2377440" cy="365760"/>
           </a:xfrm>
           <a:prstGeom prst="rect">
             <a:avLst/>
@@ -4980,21 +4937,21 @@
                 </a:solidFill>
                 <a:latin typeface="Segoe UI"/>
               </a:rPr>
-              <a:t>FOUNDED · NEW YORK CITY</a:t>
-            </a:r>
-          </a:p>
-        </p:txBody>
-      </p:sp>
-      <p:sp>
-        <p:nvSpPr>
-          <p:cNvPr id="13" name="Rounded Rectangle 12"/>
+              <a:t>AI PLATFORM LAUNCHED</a:t>
+            </a:r>
+          </a:p>
+        </p:txBody>
+      </p:sp>
+      <p:sp>
+        <p:nvSpPr>
+          <p:cNvPr id="14" name="Rounded Rectangle 13"/>
           <p:cNvSpPr/>
           <p:nvPr/>
         </p:nvSpPr>
         <p:spPr>
           <a:xfrm>
-            <a:off x="4069080" y="3840480"/>
-            <a:ext cx="3200400" cy="1234440"/>
+            <a:off x="3383280" y="3794760"/>
+            <a:ext cx="2697480" cy="1234440"/>
           </a:xfrm>
           <a:prstGeom prst="roundRect">
             <a:avLst>
@@ -5032,47 +4989,47 @@
       </p:sp>
       <p:sp>
         <p:nvSpPr>
-          <p:cNvPr id="14" name="TextBox 13"/>
-          <p:cNvSpPr txBox="1"/>
-          <p:nvPr/>
-        </p:nvSpPr>
-        <p:spPr>
-          <a:xfrm>
-            <a:off x="4297680" y="3977639"/>
-            <a:ext cx="2743200" cy="548640"/>
-          </a:xfrm>
-          <a:prstGeom prst="rect">
-            <a:avLst/>
-          </a:prstGeom>
-          <a:noFill/>
-        </p:spPr>
-        <p:txBody>
-          <a:bodyPr wrap="square" anchor="t"/>
-          <a:lstStyle/>
-          <a:p>
-            <a:pPr algn="l"/>
-            <a:r>
-              <a:rPr sz="3200" b="1" i="0">
+          <p:cNvPr id="15" name="TextBox 14"/>
+          <p:cNvSpPr txBox="1"/>
+          <p:nvPr/>
+        </p:nvSpPr>
+        <p:spPr>
+          <a:xfrm>
+            <a:off x="3547872" y="3931920"/>
+            <a:ext cx="2377440" cy="502920"/>
+          </a:xfrm>
+          <a:prstGeom prst="rect">
+            <a:avLst/>
+          </a:prstGeom>
+          <a:noFill/>
+        </p:spPr>
+        <p:txBody>
+          <a:bodyPr wrap="square" anchor="t"/>
+          <a:lstStyle/>
+          <a:p>
+            <a:pPr algn="l"/>
+            <a:r>
+              <a:rPr sz="2600" b="1" i="0">
                 <a:solidFill>
                   <a:srgbClr val="FFFFFF"/>
                 </a:solidFill>
                 <a:latin typeface="Georgia"/>
               </a:rPr>
-              <a:t>8+</a:t>
-            </a:r>
-          </a:p>
-        </p:txBody>
-      </p:sp>
-      <p:sp>
-        <p:nvSpPr>
-          <p:cNvPr id="15" name="TextBox 14"/>
-          <p:cNvSpPr txBox="1"/>
-          <p:nvPr/>
-        </p:nvSpPr>
-        <p:spPr>
-          <a:xfrm>
-            <a:off x="4297680" y="4617720"/>
-            <a:ext cx="2743200" cy="320040"/>
+              <a:t>10,000+</a:t>
+            </a:r>
+          </a:p>
+        </p:txBody>
+      </p:sp>
+      <p:sp>
+        <p:nvSpPr>
+          <p:cNvPr id="16" name="TextBox 15"/>
+          <p:cNvSpPr txBox="1"/>
+          <p:nvPr/>
+        </p:nvSpPr>
+        <p:spPr>
+          <a:xfrm>
+            <a:off x="3547872" y="4526280"/>
+            <a:ext cx="2377440" cy="365760"/>
           </a:xfrm>
           <a:prstGeom prst="rect">
             <a:avLst/>
@@ -5091,21 +5048,21 @@
                 </a:solidFill>
                 <a:latin typeface="Segoe UI"/>
               </a:rPr>
-              <a:t>COUNTRIES OF OPERATION</a:t>
-            </a:r>
-          </a:p>
-        </p:txBody>
-      </p:sp>
-      <p:sp>
-        <p:nvSpPr>
-          <p:cNvPr id="16" name="Rounded Rectangle 15"/>
+              <a:t>CANDIDATES HELPED · 8 YRS</a:t>
+            </a:r>
+          </a:p>
+        </p:txBody>
+      </p:sp>
+      <p:sp>
+        <p:nvSpPr>
+          <p:cNvPr id="17" name="Rounded Rectangle 16"/>
           <p:cNvSpPr/>
           <p:nvPr/>
         </p:nvSpPr>
         <p:spPr>
           <a:xfrm>
-            <a:off x="7498080" y="3840480"/>
-            <a:ext cx="3200400" cy="1234440"/>
+            <a:off x="6263640" y="3794760"/>
+            <a:ext cx="2697480" cy="1234440"/>
           </a:xfrm>
           <a:prstGeom prst="roundRect">
             <a:avLst>
@@ -5143,47 +5100,47 @@
       </p:sp>
       <p:sp>
         <p:nvSpPr>
-          <p:cNvPr id="17" name="TextBox 16"/>
-          <p:cNvSpPr txBox="1"/>
-          <p:nvPr/>
-        </p:nvSpPr>
-        <p:spPr>
-          <a:xfrm>
-            <a:off x="7726680" y="3977639"/>
-            <a:ext cx="2743200" cy="548640"/>
-          </a:xfrm>
-          <a:prstGeom prst="rect">
-            <a:avLst/>
-          </a:prstGeom>
-          <a:noFill/>
-        </p:spPr>
-        <p:txBody>
-          <a:bodyPr wrap="square" anchor="t"/>
-          <a:lstStyle/>
-          <a:p>
-            <a:pPr algn="l"/>
-            <a:r>
-              <a:rPr sz="3200" b="1" i="0">
+          <p:cNvPr id="18" name="TextBox 17"/>
+          <p:cNvSpPr txBox="1"/>
+          <p:nvPr/>
+        </p:nvSpPr>
+        <p:spPr>
+          <a:xfrm>
+            <a:off x="6428232" y="3931920"/>
+            <a:ext cx="2377440" cy="502920"/>
+          </a:xfrm>
+          <a:prstGeom prst="rect">
+            <a:avLst/>
+          </a:prstGeom>
+          <a:noFill/>
+        </p:spPr>
+        <p:txBody>
+          <a:bodyPr wrap="square" anchor="t"/>
+          <a:lstStyle/>
+          <a:p>
+            <a:pPr algn="l"/>
+            <a:r>
+              <a:rPr sz="2600" b="1" i="0">
                 <a:solidFill>
                   <a:srgbClr val="FFFFFF"/>
                 </a:solidFill>
                 <a:latin typeface="Georgia"/>
               </a:rPr>
-              <a:t>US$10M+</a:t>
-            </a:r>
-          </a:p>
-        </p:txBody>
-      </p:sp>
-      <p:sp>
-        <p:nvSpPr>
-          <p:cNvPr id="18" name="TextBox 17"/>
-          <p:cNvSpPr txBox="1"/>
-          <p:nvPr/>
-        </p:nvSpPr>
-        <p:spPr>
-          <a:xfrm>
-            <a:off x="7726680" y="4617720"/>
-            <a:ext cx="2743200" cy="320040"/>
+              <a:t>100K+</a:t>
+            </a:r>
+          </a:p>
+        </p:txBody>
+      </p:sp>
+      <p:sp>
+        <p:nvSpPr>
+          <p:cNvPr id="19" name="TextBox 18"/>
+          <p:cNvSpPr txBox="1"/>
+          <p:nvPr/>
+        </p:nvSpPr>
+        <p:spPr>
+          <a:xfrm>
+            <a:off x="6428232" y="4526280"/>
+            <a:ext cx="2377440" cy="365760"/>
           </a:xfrm>
           <a:prstGeom prst="rect">
             <a:avLst/>
@@ -5202,47 +5159,158 @@
                 </a:solidFill>
                 <a:latin typeface="Segoe UI"/>
               </a:rPr>
-              <a:t>ANNUAL REVENUE (EST.)†</a:t>
-            </a:r>
-          </a:p>
-        </p:txBody>
-      </p:sp>
-      <p:sp>
-        <p:nvSpPr>
-          <p:cNvPr id="19" name="TextBox 18"/>
-          <p:cNvSpPr txBox="1"/>
-          <p:nvPr/>
-        </p:nvSpPr>
-        <p:spPr>
-          <a:xfrm>
-            <a:off x="640080" y="5257800"/>
-            <a:ext cx="9144000" cy="228600"/>
-          </a:xfrm>
-          <a:prstGeom prst="rect">
-            <a:avLst/>
-          </a:prstGeom>
-          <a:noFill/>
-        </p:spPr>
-        <p:txBody>
-          <a:bodyPr wrap="square" anchor="t"/>
-          <a:lstStyle/>
-          <a:p>
-            <a:pPr algn="l"/>
-            <a:r>
-              <a:rPr sz="800" b="0" i="0">
+              <a:t>MOCK INTERVIEW QUESTIONS</a:t>
+            </a:r>
+          </a:p>
+        </p:txBody>
+      </p:sp>
+      <p:sp>
+        <p:nvSpPr>
+          <p:cNvPr id="20" name="Rounded Rectangle 19"/>
+          <p:cNvSpPr/>
+          <p:nvPr/>
+        </p:nvSpPr>
+        <p:spPr>
+          <a:xfrm>
+            <a:off x="9144000" y="3794760"/>
+            <a:ext cx="2697480" cy="1234440"/>
+          </a:xfrm>
+          <a:prstGeom prst="roundRect">
+            <a:avLst>
+              <a:gd name="adj" fmla="val 8000"/>
+            </a:avLst>
+          </a:prstGeom>
+          <a:solidFill>
+            <a:srgbClr val="122A40"/>
+          </a:solidFill>
+          <a:ln>
+            <a:noFill/>
+          </a:ln>
+        </p:spPr>
+        <p:style>
+          <a:lnRef idx="1">
+            <a:schemeClr val="accent1"/>
+          </a:lnRef>
+          <a:fillRef idx="3">
+            <a:schemeClr val="accent1"/>
+          </a:fillRef>
+          <a:effectRef idx="2">
+            <a:schemeClr val="accent1"/>
+          </a:effectRef>
+          <a:fontRef idx="minor">
+            <a:schemeClr val="lt1"/>
+          </a:fontRef>
+        </p:style>
+        <p:txBody>
+          <a:bodyPr rtlCol="0" anchor="ctr"/>
+          <a:lstStyle/>
+          <a:p>
+            <a:pPr algn="ctr"/>
+          </a:p>
+        </p:txBody>
+      </p:sp>
+      <p:sp>
+        <p:nvSpPr>
+          <p:cNvPr id="21" name="TextBox 20"/>
+          <p:cNvSpPr txBox="1"/>
+          <p:nvPr/>
+        </p:nvSpPr>
+        <p:spPr>
+          <a:xfrm>
+            <a:off x="9308592" y="3931920"/>
+            <a:ext cx="2377440" cy="502920"/>
+          </a:xfrm>
+          <a:prstGeom prst="rect">
+            <a:avLst/>
+          </a:prstGeom>
+          <a:noFill/>
+        </p:spPr>
+        <p:txBody>
+          <a:bodyPr wrap="square" anchor="t"/>
+          <a:lstStyle/>
+          <a:p>
+            <a:pPr algn="l"/>
+            <a:r>
+              <a:rPr sz="2600" b="1" i="0">
+                <a:solidFill>
+                  <a:srgbClr val="FFFFFF"/>
+                </a:solidFill>
+                <a:latin typeface="Georgia"/>
+              </a:rPr>
+              <a:t>US$0</a:t>
+            </a:r>
+          </a:p>
+        </p:txBody>
+      </p:sp>
+      <p:sp>
+        <p:nvSpPr>
+          <p:cNvPr id="22" name="TextBox 21"/>
+          <p:cNvSpPr txBox="1"/>
+          <p:nvPr/>
+        </p:nvSpPr>
+        <p:spPr>
+          <a:xfrm>
+            <a:off x="9308592" y="4526280"/>
+            <a:ext cx="2377440" cy="365760"/>
+          </a:xfrm>
+          <a:prstGeom prst="rect">
+            <a:avLst/>
+          </a:prstGeom>
+          <a:noFill/>
+        </p:spPr>
+        <p:txBody>
+          <a:bodyPr wrap="square" anchor="t"/>
+          <a:lstStyle/>
+          <a:p>
+            <a:pPr algn="l"/>
+            <a:r>
+              <a:rPr sz="900" b="1" i="0">
+                <a:solidFill>
+                  <a:srgbClr val="D7EBE8"/>
+                </a:solidFill>
+                <a:latin typeface="Segoe UI"/>
+              </a:rPr>
+              <a:t>PLATFORM REVENUE TODAY</a:t>
+            </a:r>
+          </a:p>
+        </p:txBody>
+      </p:sp>
+      <p:sp>
+        <p:nvSpPr>
+          <p:cNvPr id="23" name="TextBox 22"/>
+          <p:cNvSpPr txBox="1"/>
+          <p:nvPr/>
+        </p:nvSpPr>
+        <p:spPr>
+          <a:xfrm>
+            <a:off x="640080" y="5212080"/>
+            <a:ext cx="10058400" cy="228600"/>
+          </a:xfrm>
+          <a:prstGeom prst="rect">
+            <a:avLst/>
+          </a:prstGeom>
+          <a:noFill/>
+        </p:spPr>
+        <p:txBody>
+          <a:bodyPr wrap="square" anchor="t"/>
+          <a:lstStyle/>
+          <a:p>
+            <a:pPr algn="l"/>
+            <a:r>
+              <a:rPr sz="1100" b="0" i="0">
                 <a:solidFill>
                   <a:srgbClr val="6B7C8F"/>
                 </a:solidFill>
                 <a:latin typeface="Segoe UI"/>
               </a:rPr>
-              <a:t>† Third-party estimates; see p.9</a:t>
-            </a:r>
-          </a:p>
-        </p:txBody>
-      </p:sp>
-      <p:sp>
-        <p:nvSpPr>
-          <p:cNvPr id="20" name="TextBox 19"/>
+              <a:t>Currently free to grow active users · Monetization via membership, consulting &amp; education fees</a:t>
+            </a:r>
+          </a:p>
+        </p:txBody>
+      </p:sp>
+      <p:sp>
+        <p:nvSpPr>
+          <p:cNvPr id="24" name="TextBox 23"/>
           <p:cNvSpPr txBox="1"/>
           <p:nvPr/>
         </p:nvSpPr>
@@ -5403,7 +5471,7 @@
                 </a:solidFill>
                 <a:latin typeface="Georgia"/>
               </a:rPr>
-              <a:t>Differentiated at the Intersection of AI and Outcomes</a:t>
+              <a:t>Purpose-Built Career AI vs. General LLMs</a:t>
             </a:r>
           </a:p>
         </p:txBody>
@@ -5417,7 +5485,7 @@
         <p:spPr>
           <a:xfrm>
             <a:off x="502920" y="1188720"/>
-            <a:ext cx="5212080" cy="3291840"/>
+            <a:ext cx="5212080" cy="3246120"/>
           </a:xfrm>
           <a:prstGeom prst="roundRect">
             <a:avLst>
@@ -5483,7 +5551,7 @@
                 </a:solidFill>
                 <a:latin typeface="Segoe UI"/>
               </a:rPr>
-              <a:t>Capability coverage score (illustrative)</a:t>
+              <a:t>Career-domain capability score (illustrative, 0–6)</a:t>
             </a:r>
           </a:p>
         </p:txBody>
@@ -5498,7 +5566,7 @@
         </p:nvGraphicFramePr>
         <p:xfrm>
           <a:off x="594360" y="1600200"/>
-          <a:ext cx="4983480" cy="2697480"/>
+          <a:ext cx="4983480" cy="2651760"/>
         </p:xfrm>
         <a:graphic>
           <a:graphicData uri="http://schemas.openxmlformats.org/drawingml/2006/chart">
@@ -5516,7 +5584,7 @@
         </p:nvGraphicFramePr>
         <p:xfrm>
           <a:off x="5897880" y="1188720"/>
-          <a:ext cx="5806440" cy="3291840"/>
+          <a:ext cx="5806440" cy="3246120"/>
         </p:xfrm>
         <a:graphic>
           <a:graphicData uri="http://schemas.openxmlformats.org/drawingml/2006/table">
@@ -5525,14 +5593,13 @@
                 <a:tableStyleId>{5C22544A-7EE6-4342-B048-85BDC9FD1C3A}</a:tableStyleId>
               </a:tblPr>
               <a:tblGrid>
-                <a:gridCol w="967740"/>
-                <a:gridCol w="967740"/>
-                <a:gridCol w="967740"/>
-                <a:gridCol w="967740"/>
-                <a:gridCol w="967740"/>
-                <a:gridCol w="967740"/>
+                <a:gridCol w="1161288"/>
+                <a:gridCol w="1161288"/>
+                <a:gridCol w="1161288"/>
+                <a:gridCol w="1161288"/>
+                <a:gridCol w="1161288"/>
               </a:tblGrid>
-              <a:tr h="470262">
+              <a:tr h="463731">
                 <a:tc>
                   <a:txBody>
                     <a:bodyPr/>
@@ -5592,7 +5659,7 @@
                           </a:solidFill>
                           <a:latin typeface="Segoe UI"/>
                         </a:rPr>
-                        <a:t>Job Boards</a:t>
+                        <a:t>ChatGPT</a:t>
                       </a:r>
                     </a:p>
                   </a:txBody>
@@ -5615,7 +5682,7 @@
                           </a:solidFill>
                           <a:latin typeface="Segoe UI"/>
                         </a:rPr>
-                        <a:t>Prep Apps</a:t>
+                        <a:t>Gemini</a:t>
                       </a:r>
                     </a:p>
                   </a:txBody>
@@ -5638,30 +5705,7 @@
                           </a:solidFill>
                           <a:latin typeface="Segoe UI"/>
                         </a:rPr>
-                        <a:t>Coaching</a:t>
-                      </a:r>
-                    </a:p>
-                  </a:txBody>
-                  <a:tcPr>
-                    <a:solidFill>
-                      <a:srgbClr val="0B1F33"/>
-                    </a:solidFill>
-                  </a:tcPr>
-                </a:tc>
-                <a:tc>
-                  <a:txBody>
-                    <a:bodyPr/>
-                    <a:lstStyle/>
-                    <a:p>
-                      <a:pPr algn="ctr"/>
-                      <a:r>
-                        <a:rPr sz="900" b="1">
-                          <a:solidFill>
-                            <a:srgbClr val="FFFFFF"/>
-                          </a:solidFill>
-                          <a:latin typeface="Segoe UI"/>
-                        </a:rPr>
-                        <a:t>Staffing</a:t>
+                        <a:t>Claude</a:t>
                       </a:r>
                     </a:p>
                   </a:txBody>
@@ -5672,7 +5716,7 @@
                   </a:tcPr>
                 </a:tc>
               </a:tr>
-              <a:tr h="470262">
+              <a:tr h="463731">
                 <a:tc>
                   <a:txBody>
                     <a:bodyPr/>
@@ -5686,7 +5730,7 @@
                           </a:solidFill>
                           <a:latin typeface="Segoe UI"/>
                         </a:rPr>
-                        <a:t>AI interview practice</a:t>
+                        <a:t>Career-specific mock interviews</a:t>
                       </a:r>
                     </a:p>
                   </a:txBody>
@@ -5710,29 +5754,6 @@
                           <a:latin typeface="Segoe UI"/>
                         </a:rPr>
                         <a:t>●</a:t>
-                      </a:r>
-                    </a:p>
-                  </a:txBody>
-                  <a:tcPr>
-                    <a:solidFill>
-                      <a:srgbClr val="FFFFFF"/>
-                    </a:solidFill>
-                  </a:tcPr>
-                </a:tc>
-                <a:tc>
-                  <a:txBody>
-                    <a:bodyPr/>
-                    <a:lstStyle/>
-                    <a:p>
-                      <a:pPr algn="ctr"/>
-                      <a:r>
-                        <a:rPr sz="1000" b="0">
-                          <a:solidFill>
-                            <a:srgbClr val="5E6E80"/>
-                          </a:solidFill>
-                          <a:latin typeface="Segoe UI"/>
-                        </a:rPr>
-                        <a:t>—</a:t>
                       </a:r>
                     </a:p>
                   </a:txBody>
@@ -5801,7 +5822,7 @@
                           </a:solidFill>
                           <a:latin typeface="Segoe UI"/>
                         </a:rPr>
-                        <a:t>—</a:t>
+                        <a:t>○</a:t>
                       </a:r>
                     </a:p>
                   </a:txBody>
@@ -5812,7 +5833,7 @@
                   </a:tcPr>
                 </a:tc>
               </a:tr>
-              <a:tr h="470262">
+              <a:tr h="463731">
                 <a:tc>
                   <a:txBody>
                     <a:bodyPr/>
@@ -5826,287 +5847,7 @@
                           </a:solidFill>
                           <a:latin typeface="Segoe UI"/>
                         </a:rPr>
-                        <a:t>Real-question banks</a:t>
-                      </a:r>
-                    </a:p>
-                  </a:txBody>
-                  <a:tcPr>
-                    <a:solidFill>
-                      <a:srgbClr val="EEF3F8"/>
-                    </a:solidFill>
-                  </a:tcPr>
-                </a:tc>
-                <a:tc>
-                  <a:txBody>
-                    <a:bodyPr/>
-                    <a:lstStyle/>
-                    <a:p>
-                      <a:pPr algn="ctr"/>
-                      <a:r>
-                        <a:rPr sz="1000" b="1">
-                          <a:solidFill>
-                            <a:srgbClr val="0A6B63"/>
-                          </a:solidFill>
-                          <a:latin typeface="Segoe UI"/>
-                        </a:rPr>
-                        <a:t>●</a:t>
-                      </a:r>
-                    </a:p>
-                  </a:txBody>
-                  <a:tcPr>
-                    <a:solidFill>
-                      <a:srgbClr val="EEF3F8"/>
-                    </a:solidFill>
-                  </a:tcPr>
-                </a:tc>
-                <a:tc>
-                  <a:txBody>
-                    <a:bodyPr/>
-                    <a:lstStyle/>
-                    <a:p>
-                      <a:pPr algn="ctr"/>
-                      <a:r>
-                        <a:rPr sz="1000" b="0">
-                          <a:solidFill>
-                            <a:srgbClr val="5E6E80"/>
-                          </a:solidFill>
-                          <a:latin typeface="Segoe UI"/>
-                        </a:rPr>
-                        <a:t>—</a:t>
-                      </a:r>
-                    </a:p>
-                  </a:txBody>
-                  <a:tcPr>
-                    <a:solidFill>
-                      <a:srgbClr val="EEF3F8"/>
-                    </a:solidFill>
-                  </a:tcPr>
-                </a:tc>
-                <a:tc>
-                  <a:txBody>
-                    <a:bodyPr/>
-                    <a:lstStyle/>
-                    <a:p>
-                      <a:pPr algn="ctr"/>
-                      <a:r>
-                        <a:rPr sz="1000" b="0">
-                          <a:solidFill>
-                            <a:srgbClr val="5E6E80"/>
-                          </a:solidFill>
-                          <a:latin typeface="Segoe UI"/>
-                        </a:rPr>
-                        <a:t>○</a:t>
-                      </a:r>
-                    </a:p>
-                  </a:txBody>
-                  <a:tcPr>
-                    <a:solidFill>
-                      <a:srgbClr val="EEF3F8"/>
-                    </a:solidFill>
-                  </a:tcPr>
-                </a:tc>
-                <a:tc>
-                  <a:txBody>
-                    <a:bodyPr/>
-                    <a:lstStyle/>
-                    <a:p>
-                      <a:pPr algn="ctr"/>
-                      <a:r>
-                        <a:rPr sz="1000" b="0">
-                          <a:solidFill>
-                            <a:srgbClr val="5E6E80"/>
-                          </a:solidFill>
-                          <a:latin typeface="Segoe UI"/>
-                        </a:rPr>
-                        <a:t>○</a:t>
-                      </a:r>
-                    </a:p>
-                  </a:txBody>
-                  <a:tcPr>
-                    <a:solidFill>
-                      <a:srgbClr val="EEF3F8"/>
-                    </a:solidFill>
-                  </a:tcPr>
-                </a:tc>
-                <a:tc>
-                  <a:txBody>
-                    <a:bodyPr/>
-                    <a:lstStyle/>
-                    <a:p>
-                      <a:pPr algn="ctr"/>
-                      <a:r>
-                        <a:rPr sz="1000" b="0">
-                          <a:solidFill>
-                            <a:srgbClr val="5E6E80"/>
-                          </a:solidFill>
-                          <a:latin typeface="Segoe UI"/>
-                        </a:rPr>
-                        <a:t>—</a:t>
-                      </a:r>
-                    </a:p>
-                  </a:txBody>
-                  <a:tcPr>
-                    <a:solidFill>
-                      <a:srgbClr val="EEF3F8"/>
-                    </a:solidFill>
-                  </a:tcPr>
-                </a:tc>
-              </a:tr>
-              <a:tr h="470262">
-                <a:tc>
-                  <a:txBody>
-                    <a:bodyPr/>
-                    <a:lstStyle/>
-                    <a:p>
-                      <a:pPr algn="l"/>
-                      <a:r>
-                        <a:rPr sz="1000" b="0">
-                          <a:solidFill>
-                            <a:srgbClr val="2C3A4B"/>
-                          </a:solidFill>
-                          <a:latin typeface="Segoe UI"/>
-                        </a:rPr>
-                        <a:t>Human mentor network</a:t>
-                      </a:r>
-                    </a:p>
-                  </a:txBody>
-                  <a:tcPr>
-                    <a:solidFill>
-                      <a:srgbClr val="FFFFFF"/>
-                    </a:solidFill>
-                  </a:tcPr>
-                </a:tc>
-                <a:tc>
-                  <a:txBody>
-                    <a:bodyPr/>
-                    <a:lstStyle/>
-                    <a:p>
-                      <a:pPr algn="ctr"/>
-                      <a:r>
-                        <a:rPr sz="1000" b="1">
-                          <a:solidFill>
-                            <a:srgbClr val="0A6B63"/>
-                          </a:solidFill>
-                          <a:latin typeface="Segoe UI"/>
-                        </a:rPr>
-                        <a:t>●</a:t>
-                      </a:r>
-                    </a:p>
-                  </a:txBody>
-                  <a:tcPr>
-                    <a:solidFill>
-                      <a:srgbClr val="FFFFFF"/>
-                    </a:solidFill>
-                  </a:tcPr>
-                </a:tc>
-                <a:tc>
-                  <a:txBody>
-                    <a:bodyPr/>
-                    <a:lstStyle/>
-                    <a:p>
-                      <a:pPr algn="ctr"/>
-                      <a:r>
-                        <a:rPr sz="1000" b="0">
-                          <a:solidFill>
-                            <a:srgbClr val="5E6E80"/>
-                          </a:solidFill>
-                          <a:latin typeface="Segoe UI"/>
-                        </a:rPr>
-                        <a:t>—</a:t>
-                      </a:r>
-                    </a:p>
-                  </a:txBody>
-                  <a:tcPr>
-                    <a:solidFill>
-                      <a:srgbClr val="FFFFFF"/>
-                    </a:solidFill>
-                  </a:tcPr>
-                </a:tc>
-                <a:tc>
-                  <a:txBody>
-                    <a:bodyPr/>
-                    <a:lstStyle/>
-                    <a:p>
-                      <a:pPr algn="ctr"/>
-                      <a:r>
-                        <a:rPr sz="1000" b="0">
-                          <a:solidFill>
-                            <a:srgbClr val="5E6E80"/>
-                          </a:solidFill>
-                          <a:latin typeface="Segoe UI"/>
-                        </a:rPr>
-                        <a:t>—</a:t>
-                      </a:r>
-                    </a:p>
-                  </a:txBody>
-                  <a:tcPr>
-                    <a:solidFill>
-                      <a:srgbClr val="FFFFFF"/>
-                    </a:solidFill>
-                  </a:tcPr>
-                </a:tc>
-                <a:tc>
-                  <a:txBody>
-                    <a:bodyPr/>
-                    <a:lstStyle/>
-                    <a:p>
-                      <a:pPr algn="ctr"/>
-                      <a:r>
-                        <a:rPr sz="1000" b="0">
-                          <a:solidFill>
-                            <a:srgbClr val="0A6B63"/>
-                          </a:solidFill>
-                          <a:latin typeface="Segoe UI"/>
-                        </a:rPr>
-                        <a:t>●</a:t>
-                      </a:r>
-                    </a:p>
-                  </a:txBody>
-                  <a:tcPr>
-                    <a:solidFill>
-                      <a:srgbClr val="FFFFFF"/>
-                    </a:solidFill>
-                  </a:tcPr>
-                </a:tc>
-                <a:tc>
-                  <a:txBody>
-                    <a:bodyPr/>
-                    <a:lstStyle/>
-                    <a:p>
-                      <a:pPr algn="ctr"/>
-                      <a:r>
-                        <a:rPr sz="1000" b="0">
-                          <a:solidFill>
-                            <a:srgbClr val="5E6E80"/>
-                          </a:solidFill>
-                          <a:latin typeface="Segoe UI"/>
-                        </a:rPr>
-                        <a:t>○</a:t>
-                      </a:r>
-                    </a:p>
-                  </a:txBody>
-                  <a:tcPr>
-                    <a:solidFill>
-                      <a:srgbClr val="FFFFFF"/>
-                    </a:solidFill>
-                  </a:tcPr>
-                </a:tc>
-              </a:tr>
-              <a:tr h="470262">
-                <a:tc>
-                  <a:txBody>
-                    <a:bodyPr/>
-                    <a:lstStyle/>
-                    <a:p>
-                      <a:pPr algn="l"/>
-                      <a:r>
-                        <a:rPr sz="1000" b="0">
-                          <a:solidFill>
-                            <a:srgbClr val="2C3A4B"/>
-                          </a:solidFill>
-                          <a:latin typeface="Segoe UI"/>
-                        </a:rPr>
-                        <a:t>Outcome placement</a:t>
+                        <a:t>100K+ proprietary question bank</a:t>
                       </a:r>
                     </a:p>
                   </a:txBody>
@@ -6198,30 +5939,7 @@
                           </a:solidFill>
                           <a:latin typeface="Segoe UI"/>
                         </a:rPr>
-                        <a:t>○</a:t>
-                      </a:r>
-                    </a:p>
-                  </a:txBody>
-                  <a:tcPr>
-                    <a:solidFill>
-                      <a:srgbClr val="EEF3F8"/>
-                    </a:solidFill>
-                  </a:tcPr>
-                </a:tc>
-                <a:tc>
-                  <a:txBody>
-                    <a:bodyPr/>
-                    <a:lstStyle/>
-                    <a:p>
-                      <a:pPr algn="ctr"/>
-                      <a:r>
-                        <a:rPr sz="1000" b="0">
-                          <a:solidFill>
-                            <a:srgbClr val="0A6B63"/>
-                          </a:solidFill>
-                          <a:latin typeface="Segoe UI"/>
-                        </a:rPr>
-                        <a:t>●</a:t>
+                        <a:t>—</a:t>
                       </a:r>
                     </a:p>
                   </a:txBody>
@@ -6232,7 +5950,7 @@
                   </a:tcPr>
                 </a:tc>
               </a:tr>
-              <a:tr h="470262">
+              <a:tr h="463731">
                 <a:tc>
                   <a:txBody>
                     <a:bodyPr/>
@@ -6246,7 +5964,7 @@
                           </a:solidFill>
                           <a:latin typeface="Segoe UI"/>
                         </a:rPr>
-                        <a:t>Employer AI screening</a:t>
+                        <a:t>AI résumé builder (hiring-tuned)</a:t>
                       </a:r>
                     </a:p>
                   </a:txBody>
@@ -6315,6 +6033,217 @@
                           </a:solidFill>
                           <a:latin typeface="Segoe UI"/>
                         </a:rPr>
+                        <a:t>○</a:t>
+                      </a:r>
+                    </a:p>
+                  </a:txBody>
+                  <a:tcPr>
+                    <a:solidFill>
+                      <a:srgbClr val="FFFFFF"/>
+                    </a:solidFill>
+                  </a:tcPr>
+                </a:tc>
+                <a:tc>
+                  <a:txBody>
+                    <a:bodyPr/>
+                    <a:lstStyle/>
+                    <a:p>
+                      <a:pPr algn="ctr"/>
+                      <a:r>
+                        <a:rPr sz="1000" b="0">
+                          <a:solidFill>
+                            <a:srgbClr val="5E6E80"/>
+                          </a:solidFill>
+                          <a:latin typeface="Segoe UI"/>
+                        </a:rPr>
+                        <a:t>○</a:t>
+                      </a:r>
+                    </a:p>
+                  </a:txBody>
+                  <a:tcPr>
+                    <a:solidFill>
+                      <a:srgbClr val="FFFFFF"/>
+                    </a:solidFill>
+                  </a:tcPr>
+                </a:tc>
+              </a:tr>
+              <a:tr h="463731">
+                <a:tc>
+                  <a:txBody>
+                    <a:bodyPr/>
+                    <a:lstStyle/>
+                    <a:p>
+                      <a:pPr algn="l"/>
+                      <a:r>
+                        <a:rPr sz="1000" b="0">
+                          <a:solidFill>
+                            <a:srgbClr val="2C3A4B"/>
+                          </a:solidFill>
+                          <a:latin typeface="Segoe UI"/>
+                        </a:rPr>
+                        <a:t>8-year coaching / candidate data</a:t>
+                      </a:r>
+                    </a:p>
+                  </a:txBody>
+                  <a:tcPr>
+                    <a:solidFill>
+                      <a:srgbClr val="EEF3F8"/>
+                    </a:solidFill>
+                  </a:tcPr>
+                </a:tc>
+                <a:tc>
+                  <a:txBody>
+                    <a:bodyPr/>
+                    <a:lstStyle/>
+                    <a:p>
+                      <a:pPr algn="ctr"/>
+                      <a:r>
+                        <a:rPr sz="1000" b="1">
+                          <a:solidFill>
+                            <a:srgbClr val="0A6B63"/>
+                          </a:solidFill>
+                          <a:latin typeface="Segoe UI"/>
+                        </a:rPr>
+                        <a:t>●</a:t>
+                      </a:r>
+                    </a:p>
+                  </a:txBody>
+                  <a:tcPr>
+                    <a:solidFill>
+                      <a:srgbClr val="EEF3F8"/>
+                    </a:solidFill>
+                  </a:tcPr>
+                </a:tc>
+                <a:tc>
+                  <a:txBody>
+                    <a:bodyPr/>
+                    <a:lstStyle/>
+                    <a:p>
+                      <a:pPr algn="ctr"/>
+                      <a:r>
+                        <a:rPr sz="1000" b="0">
+                          <a:solidFill>
+                            <a:srgbClr val="5E6E80"/>
+                          </a:solidFill>
+                          <a:latin typeface="Segoe UI"/>
+                        </a:rPr>
+                        <a:t>—</a:t>
+                      </a:r>
+                    </a:p>
+                  </a:txBody>
+                  <a:tcPr>
+                    <a:solidFill>
+                      <a:srgbClr val="EEF3F8"/>
+                    </a:solidFill>
+                  </a:tcPr>
+                </a:tc>
+                <a:tc>
+                  <a:txBody>
+                    <a:bodyPr/>
+                    <a:lstStyle/>
+                    <a:p>
+                      <a:pPr algn="ctr"/>
+                      <a:r>
+                        <a:rPr sz="1000" b="0">
+                          <a:solidFill>
+                            <a:srgbClr val="5E6E80"/>
+                          </a:solidFill>
+                          <a:latin typeface="Segoe UI"/>
+                        </a:rPr>
+                        <a:t>—</a:t>
+                      </a:r>
+                    </a:p>
+                  </a:txBody>
+                  <a:tcPr>
+                    <a:solidFill>
+                      <a:srgbClr val="EEF3F8"/>
+                    </a:solidFill>
+                  </a:tcPr>
+                </a:tc>
+                <a:tc>
+                  <a:txBody>
+                    <a:bodyPr/>
+                    <a:lstStyle/>
+                    <a:p>
+                      <a:pPr algn="ctr"/>
+                      <a:r>
+                        <a:rPr sz="1000" b="0">
+                          <a:solidFill>
+                            <a:srgbClr val="5E6E80"/>
+                          </a:solidFill>
+                          <a:latin typeface="Segoe UI"/>
+                        </a:rPr>
+                        <a:t>—</a:t>
+                      </a:r>
+                    </a:p>
+                  </a:txBody>
+                  <a:tcPr>
+                    <a:solidFill>
+                      <a:srgbClr val="EEF3F8"/>
+                    </a:solidFill>
+                  </a:tcPr>
+                </a:tc>
+              </a:tr>
+              <a:tr h="463731">
+                <a:tc>
+                  <a:txBody>
+                    <a:bodyPr/>
+                    <a:lstStyle/>
+                    <a:p>
+                      <a:pPr algn="l"/>
+                      <a:r>
+                        <a:rPr sz="1000" b="0">
+                          <a:solidFill>
+                            <a:srgbClr val="2C3A4B"/>
+                          </a:solidFill>
+                          <a:latin typeface="Segoe UI"/>
+                        </a:rPr>
+                        <a:t>Membership / consulting path</a:t>
+                      </a:r>
+                    </a:p>
+                  </a:txBody>
+                  <a:tcPr>
+                    <a:solidFill>
+                      <a:srgbClr val="FFFFFF"/>
+                    </a:solidFill>
+                  </a:tcPr>
+                </a:tc>
+                <a:tc>
+                  <a:txBody>
+                    <a:bodyPr/>
+                    <a:lstStyle/>
+                    <a:p>
+                      <a:pPr algn="ctr"/>
+                      <a:r>
+                        <a:rPr sz="1000" b="1">
+                          <a:solidFill>
+                            <a:srgbClr val="0A6B63"/>
+                          </a:solidFill>
+                          <a:latin typeface="Segoe UI"/>
+                        </a:rPr>
+                        <a:t>●</a:t>
+                      </a:r>
+                    </a:p>
+                  </a:txBody>
+                  <a:tcPr>
+                    <a:solidFill>
+                      <a:srgbClr val="FFFFFF"/>
+                    </a:solidFill>
+                  </a:tcPr>
+                </a:tc>
+                <a:tc>
+                  <a:txBody>
+                    <a:bodyPr/>
+                    <a:lstStyle/>
+                    <a:p>
+                      <a:pPr algn="ctr"/>
+                      <a:r>
+                        <a:rPr sz="1000" b="0">
+                          <a:solidFill>
+                            <a:srgbClr val="5E6E80"/>
+                          </a:solidFill>
+                          <a:latin typeface="Segoe UI"/>
+                        </a:rPr>
                         <a:t>—</a:t>
                       </a:r>
                     </a:p>
@@ -6361,7 +6290,7 @@
                           </a:solidFill>
                           <a:latin typeface="Segoe UI"/>
                         </a:rPr>
-                        <a:t>○</a:t>
+                        <a:t>—</a:t>
                       </a:r>
                     </a:p>
                   </a:txBody>
@@ -6372,7 +6301,7 @@
                   </a:tcPr>
                 </a:tc>
               </a:tr>
-              <a:tr h="470268">
+              <a:tr h="463734">
                 <a:tc>
                   <a:txBody>
                     <a:bodyPr/>
@@ -6386,30 +6315,7 @@
                           </a:solidFill>
                           <a:latin typeface="Segoe UI"/>
                         </a:rPr>
-                        <a:t>Cross-border focus</a:t>
-                      </a:r>
-                    </a:p>
-                  </a:txBody>
-                  <a:tcPr>
-                    <a:solidFill>
-                      <a:srgbClr val="EEF3F8"/>
-                    </a:solidFill>
-                  </a:tcPr>
-                </a:tc>
-                <a:tc>
-                  <a:txBody>
-                    <a:bodyPr/>
-                    <a:lstStyle/>
-                    <a:p>
-                      <a:pPr algn="ctr"/>
-                      <a:r>
-                        <a:rPr sz="1000" b="1">
-                          <a:solidFill>
-                            <a:srgbClr val="0A6B63"/>
-                          </a:solidFill>
-                          <a:latin typeface="Segoe UI"/>
-                        </a:rPr>
-                        <a:t>●</a:t>
+                        <a:t>General conversational AI</a:t>
                       </a:r>
                     </a:p>
                   </a:txBody>
@@ -6451,11 +6357,11 @@
                       <a:r>
                         <a:rPr sz="1000" b="0">
                           <a:solidFill>
-                            <a:srgbClr val="5E6E80"/>
+                            <a:srgbClr val="0A6B63"/>
                           </a:solidFill>
                           <a:latin typeface="Segoe UI"/>
                         </a:rPr>
-                        <a:t>—</a:t>
+                        <a:t>●</a:t>
                       </a:r>
                     </a:p>
                   </a:txBody>
@@ -6474,11 +6380,11 @@
                       <a:r>
                         <a:rPr sz="1000" b="0">
                           <a:solidFill>
-                            <a:srgbClr val="5E6E80"/>
+                            <a:srgbClr val="0A6B63"/>
                           </a:solidFill>
                           <a:latin typeface="Segoe UI"/>
                         </a:rPr>
-                        <a:t>○</a:t>
+                        <a:t>●</a:t>
                       </a:r>
                     </a:p>
                   </a:txBody>
@@ -6497,11 +6403,11 @@
                       <a:r>
                         <a:rPr sz="1000" b="0">
                           <a:solidFill>
-                            <a:srgbClr val="5E6E80"/>
+                            <a:srgbClr val="0A6B63"/>
                           </a:solidFill>
                           <a:latin typeface="Segoe UI"/>
                         </a:rPr>
-                        <a:t>○</a:t>
+                        <a:t>●</a:t>
                       </a:r>
                     </a:p>
                   </a:txBody>
@@ -6524,8 +6430,8 @@
         </p:nvSpPr>
         <p:spPr>
           <a:xfrm>
-            <a:off x="502920" y="4663440"/>
-            <a:ext cx="11155680" cy="320040"/>
+            <a:off x="502920" y="4617720"/>
+            <a:ext cx="11155680" cy="274320"/>
           </a:xfrm>
           <a:prstGeom prst="rect">
             <a:avLst/>
@@ -6544,7 +6450,7 @@
                 </a:solidFill>
                 <a:latin typeface="Segoe UI"/>
               </a:rPr>
-              <a:t>●  Full capability      ○  Partial      —  Not offered</a:t>
+              <a:t>●  Full / native capability      ○  Partial / generic      —  Not offered</a:t>
             </a:r>
           </a:p>
         </p:txBody>
@@ -6557,8 +6463,8 @@
         </p:nvSpPr>
         <p:spPr>
           <a:xfrm>
-            <a:off x="502920" y="5029200"/>
-            <a:ext cx="11201400" cy="777240"/>
+            <a:off x="502920" y="4937760"/>
+            <a:ext cx="11201400" cy="868680"/>
           </a:xfrm>
           <a:prstGeom prst="roundRect">
             <a:avLst>
@@ -6602,8 +6508,8 @@
         </p:nvSpPr>
         <p:spPr>
           <a:xfrm>
-            <a:off x="685800" y="5166360"/>
-            <a:ext cx="10835640" cy="502920"/>
+            <a:off x="685800" y="5074920"/>
+            <a:ext cx="10835640" cy="640080"/>
           </a:xfrm>
           <a:prstGeom prst="rect">
             <a:avLst/>
@@ -6622,7 +6528,7 @@
                 </a:solidFill>
                 <a:latin typeface="Segoe UI"/>
               </a:rPr>
-              <a:t>51Careers.AI is the only platform combining AI-native preparation, human mentorship, and outcome-based placement across borders.</a:t>
+              <a:t>General models are powerful — but not career platforms. 51Careers.AI combines domain AI, a proprietary 100K+ question corpus, and an AI résumé builder purpose-built for global hiring outcomes.</a:t>
             </a:r>
           </a:p>
         </p:txBody>
@@ -6655,7 +6561,7 @@
                 </a:solidFill>
                 <a:latin typeface="Segoe UI"/>
               </a:rPr>
-              <a:t>Illustrative category comparison based on management assessment of publicly available offerings.</a:t>
+              <a:t>Illustrative comparison based on management assessment of publicly available general-purpose AI products.</a:t>
             </a:r>
           </a:p>
         </p:txBody>
@@ -6942,7 +6848,7 @@
                 </a:solidFill>
                 <a:latin typeface="Georgia"/>
               </a:rPr>
-              <a:t>A Phased Path to Global Scale</a:t>
+              <a:t>Users First, Then Monetize Globally</a:t>
             </a:r>
           </a:p>
         </p:txBody>
@@ -7098,7 +7004,7 @@
                 </a:solidFill>
                 <a:latin typeface="Segoe UI"/>
               </a:rPr>
-              <a:t>Strengthen the core</a:t>
+              <a:t>Grow free usage</a:t>
             </a:r>
           </a:p>
         </p:txBody>
@@ -7131,7 +7037,7 @@
                 </a:solidFill>
                 <a:latin typeface="Segoe UI"/>
               </a:rPr>
-              <a:t>▸  Scale the AI platform across the U.S. and Greater China</a:t>
+              <a:t>▸  Scale active users on free mock interviews, question bank, and AI résumé builder</a:t>
             </a:r>
           </a:p>
         </p:txBody>
@@ -7164,7 +7070,7 @@
                 </a:solidFill>
                 <a:latin typeface="Segoe UI"/>
               </a:rPr>
-              <a:t>▸  Migrate the coaching client base onto the platform</a:t>
+              <a:t>▸  Ship résumé-builder enhancements and expand question coverage globally</a:t>
             </a:r>
           </a:p>
         </p:txBody>
@@ -7197,7 +7103,7 @@
                 </a:solidFill>
                 <a:latin typeface="Segoe UI"/>
               </a:rPr>
-              <a:t>▸  Expand question-bank and assessment coverage by role and employer</a:t>
+              <a:t>▸  Instrument conversion funnels for membership pilots</a:t>
             </a:r>
           </a:p>
         </p:txBody>
@@ -7353,7 +7259,7 @@
                 </a:solidFill>
                 <a:latin typeface="Segoe UI"/>
               </a:rPr>
-              <a:t>Extend the footprint</a:t>
+              <a:t>Introduce paid tiers</a:t>
             </a:r>
           </a:p>
         </p:txBody>
@@ -7386,7 +7292,7 @@
                 </a:solidFill>
                 <a:latin typeface="Segoe UI"/>
               </a:rPr>
-              <a:t>▸  Full go-to-market in the U.K., Singapore, South Korea, Canada, and India</a:t>
+              <a:t>▸  Launch membership fees for premium AI practice and résumé tools</a:t>
             </a:r>
           </a:p>
         </p:txBody>
@@ -7419,7 +7325,7 @@
                 </a:solidFill>
                 <a:latin typeface="Segoe UI"/>
               </a:rPr>
-              <a:t>▸  University and institutional partnership programs</a:t>
+              <a:t>▸  Add consulting and education fee packages for high-intent users</a:t>
             </a:r>
           </a:p>
         </p:txBody>
@@ -7452,7 +7358,7 @@
                 </a:solidFill>
                 <a:latin typeface="Segoe UI"/>
               </a:rPr>
-              <a:t>▸  Convert employer pilots into paid SaaS relationships</a:t>
+              <a:t>▸  Expand language and market coverage worldwide</a:t>
             </a:r>
           </a:p>
         </p:txBody>
@@ -7608,7 +7514,7 @@
                 </a:solidFill>
                 <a:latin typeface="Segoe UI"/>
               </a:rPr>
-              <a:t>Compound the platform</a:t>
+              <a:t>Compound globally</a:t>
             </a:r>
           </a:p>
         </p:txBody>
@@ -7641,7 +7547,7 @@
                 </a:solidFill>
                 <a:latin typeface="Segoe UI"/>
               </a:rPr>
-              <a:t>▸  Employer SaaS at scale across core geographies</a:t>
+              <a:t>▸  Optimize paid conversion across membership, consulting, and education</a:t>
             </a:r>
           </a:p>
         </p:txBody>
@@ -7674,7 +7580,7 @@
                 </a:solidFill>
                 <a:latin typeface="Segoe UI"/>
               </a:rPr>
-              <a:t>▸  Additional languages, verticals, and seniority segments</a:t>
+              <a:t>▸  Deepen verticals and seniority segments globally</a:t>
             </a:r>
           </a:p>
         </p:txBody>
@@ -7707,7 +7613,7 @@
                 </a:solidFill>
                 <a:latin typeface="Segoe UI"/>
               </a:rPr>
-              <a:t>▸  Selective M&amp;A of regional career-services assets</a:t>
+              <a:t>▸  Selective partnerships with universities and employers</a:t>
             </a:r>
           </a:p>
         </p:txBody>
@@ -7768,7 +7674,7 @@
         <p:spPr>
           <a:xfrm>
             <a:off x="685800" y="4846320"/>
-            <a:ext cx="3657600" cy="256032"/>
+            <a:ext cx="4114800" cy="256032"/>
           </a:xfrm>
           <a:prstGeom prst="rect">
             <a:avLst/>
@@ -7787,7 +7693,7 @@
                 </a:solidFill>
                 <a:latin typeface="Segoe UI"/>
               </a:rPr>
-              <a:t>Geographic expansion intensity (illustrative)</a:t>
+              <a:t>Illustrative active-user growth (index)</a:t>
             </a:r>
           </a:p>
         </p:txBody>
@@ -7838,7 +7744,7 @@
                 </a:solidFill>
                 <a:latin typeface="Segoe UI"/>
               </a:rPr>
-              <a:t>Sequencing follows the existing footprint — new capital extends proven demand in markets the Company already serves, rather than funding market discovery.</a:t>
+              <a:t>Strategy: win global users with a free career AI product, then monetize engagement through membership, consulting, and education fees.</a:t>
             </a:r>
           </a:p>
         </p:txBody>
@@ -8125,7 +8031,7 @@
                 </a:solidFill>
                 <a:latin typeface="Georgia"/>
               </a:rPr>
-              <a:t>Illustrative Five-Year Trajectory</a:t>
+              <a:t>From Free Platform to Paid Scale</a:t>
             </a:r>
           </a:p>
         </p:txBody>
@@ -8186,7 +8092,7 @@
         <p:spPr>
           <a:xfrm>
             <a:off x="685800" y="1280160"/>
-            <a:ext cx="4572000" cy="256032"/>
+            <a:ext cx="5486400" cy="256032"/>
           </a:xfrm>
           <a:prstGeom prst="rect">
             <a:avLst/>
@@ -8205,7 +8111,7 @@
                 </a:solidFill>
                 <a:latin typeface="Segoe UI"/>
               </a:rPr>
-              <a:t>Revenue, US$ millions</a:t>
+              <a:t>Illustrative platform revenue, US$ millions</a:t>
             </a:r>
           </a:p>
         </p:txBody>
@@ -8284,7 +8190,7 @@
         <p:spPr>
           <a:xfrm>
             <a:off x="685800" y="4279392"/>
-            <a:ext cx="4572000" cy="228600"/>
+            <a:ext cx="5486400" cy="228600"/>
           </a:xfrm>
           <a:prstGeom prst="rect">
             <a:avLst/>
@@ -8303,7 +8209,7 @@
                 </a:solidFill>
                 <a:latin typeface="Segoe UI"/>
               </a:rPr>
-              <a:t>Illustrative gross margin (%)</a:t>
+              <a:t>Illustrative paid conversion of active users (%)</a:t>
             </a:r>
           </a:p>
         </p:txBody>
@@ -8380,26 +8286,26 @@
         <p:spPr>
           <a:xfrm>
             <a:off x="8092440" y="1325880"/>
-            <a:ext cx="3429000" cy="594360"/>
-          </a:xfrm>
-          <a:prstGeom prst="rect">
-            <a:avLst/>
-          </a:prstGeom>
-          <a:noFill/>
-        </p:spPr>
-        <p:txBody>
-          <a:bodyPr wrap="square" anchor="t"/>
-          <a:lstStyle/>
-          <a:p>
-            <a:pPr algn="l"/>
-            <a:r>
-              <a:rPr sz="3600" b="1" i="0">
+            <a:ext cx="3429000" cy="502920"/>
+          </a:xfrm>
+          <a:prstGeom prst="rect">
+            <a:avLst/>
+          </a:prstGeom>
+          <a:noFill/>
+        </p:spPr>
+        <p:txBody>
+          <a:bodyPr wrap="square" anchor="t"/>
+          <a:lstStyle/>
+          <a:p>
+            <a:pPr algn="l"/>
+            <a:r>
+              <a:rPr sz="3400" b="1" i="0">
                 <a:solidFill>
                   <a:srgbClr val="FFFFFF"/>
                 </a:solidFill>
                 <a:latin typeface="Georgia"/>
               </a:rPr>
-              <a:t>≈50%</a:t>
+              <a:t>US$0</a:t>
             </a:r>
           </a:p>
         </p:txBody>
@@ -8412,7 +8318,7 @@
         </p:nvSpPr>
         <p:spPr>
           <a:xfrm>
-            <a:off x="8092440" y="2011680"/>
+            <a:off x="8092440" y="1965960"/>
             <a:ext cx="3429000" cy="365760"/>
           </a:xfrm>
           <a:prstGeom prst="rect">
@@ -8432,7 +8338,7 @@
                 </a:solidFill>
                 <a:latin typeface="Segoe UI"/>
               </a:rPr>
-              <a:t>REVENUE CAGR, 2025E–2029E</a:t>
+              <a:t>PLATFORM REVENUE TODAY (FREE)</a:t>
             </a:r>
           </a:p>
         </p:txBody>
@@ -8512,7 +8418,7 @@
                 </a:solidFill>
                 <a:latin typeface="Segoe UI"/>
               </a:rPr>
-              <a:t>Key drivers</a:t>
+              <a:t>Revenue drivers</a:t>
             </a:r>
           </a:p>
         </p:txBody>
@@ -8526,7 +8432,7 @@
         <p:spPr>
           <a:xfrm>
             <a:off x="8092440" y="3291840"/>
-            <a:ext cx="3429000" cy="548640"/>
+            <a:ext cx="3429000" cy="502920"/>
           </a:xfrm>
           <a:prstGeom prst="rect">
             <a:avLst/>
@@ -8545,7 +8451,7 @@
                 </a:solidFill>
                 <a:latin typeface="Segoe UI"/>
               </a:rPr>
-              <a:t>▸  Self-serve platform subscriptions compounding across markets</a:t>
+              <a:t>▸  Grow free active users globally</a:t>
             </a:r>
           </a:p>
         </p:txBody>
@@ -8558,8 +8464,8 @@
         </p:nvSpPr>
         <p:spPr>
           <a:xfrm>
-            <a:off x="8092440" y="3840480"/>
-            <a:ext cx="3429000" cy="548640"/>
+            <a:off x="8092440" y="3794760"/>
+            <a:ext cx="3429000" cy="502920"/>
           </a:xfrm>
           <a:prstGeom prst="rect">
             <a:avLst/>
@@ -8578,7 +8484,7 @@
                 </a:solidFill>
                 <a:latin typeface="Segoe UI"/>
               </a:rPr>
-              <a:t>▸  Mix shift from services to software lifting gross margin toward 65%+</a:t>
+              <a:t>▸  Introduce membership fees for premium AI tools</a:t>
             </a:r>
           </a:p>
         </p:txBody>
@@ -8591,8 +8497,8 @@
         </p:nvSpPr>
         <p:spPr>
           <a:xfrm>
-            <a:off x="8092440" y="4389120"/>
-            <a:ext cx="3429000" cy="548640"/>
+            <a:off x="8092440" y="4297680"/>
+            <a:ext cx="3429000" cy="502920"/>
           </a:xfrm>
           <a:prstGeom prst="rect">
             <a:avLst/>
@@ -8611,7 +8517,7 @@
                 </a:solidFill>
                 <a:latin typeface="Segoe UI"/>
               </a:rPr>
-              <a:t>▸  Employer SaaS ramping from 2027</a:t>
+              <a:t>▸  Add consulting fees for high-touch guidance</a:t>
             </a:r>
           </a:p>
         </p:txBody>
@@ -8624,8 +8530,8 @@
         </p:nvSpPr>
         <p:spPr>
           <a:xfrm>
-            <a:off x="8092440" y="4937759"/>
-            <a:ext cx="3429000" cy="548640"/>
+            <a:off x="8092440" y="4800600"/>
+            <a:ext cx="3429000" cy="502920"/>
           </a:xfrm>
           <a:prstGeom prst="rect">
             <a:avLst/>
@@ -8644,7 +8550,7 @@
                 </a:solidFill>
                 <a:latin typeface="Segoe UI"/>
               </a:rPr>
-              <a:t>▸  AI-assisted delivery driving operating leverage</a:t>
+              <a:t>▸  Layer education fees for structured programs</a:t>
             </a:r>
           </a:p>
         </p:txBody>
@@ -8677,7 +8583,7 @@
                 </a:solidFill>
                 <a:latin typeface="Segoe UI"/>
               </a:rPr>
-              <a:t>Illustrative management projections, not a forecast; 2025 base reflects third-party revenue estimates. Actual results will differ.</a:t>
+              <a:t>Illustrative management projections only — not a forecast. 2025A platform revenue is US$0 (free product). Actual results will differ.</a:t>
             </a:r>
           </a:p>
         </p:txBody>
@@ -9798,7 +9704,7 @@
                 </a:solidFill>
                 <a:latin typeface="Segoe UI"/>
               </a:rPr>
-              <a:t>What this capital achieves — next-generation platform release · go-to-market in three additional countries · employer SaaS general availability · scaled global mentor network.</a:t>
+              <a:t>What this capital achieves — AI résumé builder &amp; mock-interview scale · global active-user growth · paid membership / consulting / education launch.</a:t>
             </a:r>
           </a:p>
         </p:txBody>
@@ -10241,7 +10147,7 @@
                 </a:solidFill>
                 <a:latin typeface="Segoe UI"/>
               </a:rPr>
-              <a:t>FOUNDER</a:t>
+              <a:t>FOUNDER &amp; CEO</a:t>
             </a:r>
           </a:p>
         </p:txBody>
@@ -12449,7 +12355,7 @@
                 </a:solidFill>
                 <a:latin typeface="Georgia"/>
               </a:rPr>
-              <a:t>Investment Highlights</a:t>
+              <a:t>Who We Are &amp; Why Now</a:t>
             </a:r>
           </a:p>
         </p:txBody>
@@ -12605,7 +12511,7 @@
                 </a:solidFill>
                 <a:latin typeface="Segoe UI"/>
               </a:rPr>
-              <a:t>Large &amp; Expanding Market</a:t>
+              <a:t>Who We Are</a:t>
             </a:r>
           </a:p>
         </p:txBody>
@@ -12638,7 +12544,7 @@
                 </a:solidFill>
                 <a:latin typeface="Segoe UI"/>
               </a:rPr>
-              <a:t>Global recruitment and career-development spend exceeds US$200B, with AI-enabled segments compounding at double-digit rates.</a:t>
+              <a:t>51Careers.AI is the AI-powered career platform from the 51 Careers team — helping professionals worldwide prepare, apply, and compete for great jobs.</a:t>
             </a:r>
           </a:p>
         </p:txBody>
@@ -12794,7 +12700,7 @@
                 </a:solidFill>
                 <a:latin typeface="Segoe UI"/>
               </a:rPr>
-              <a:t>A Decade of Operating Proof</a:t>
+              <a:t>Our Product</a:t>
             </a:r>
           </a:p>
         </p:txBody>
@@ -12827,7 +12733,7 @@
                 </a:solidFill>
                 <a:latin typeface="Segoe UI"/>
               </a:rPr>
-              <a:t>Founded in New York in 2016; an established, revenue-generating career-services franchise now scaling as an AI-first platform.</a:t>
+              <a:t>AI mock interviews, a proprietary 100K+ interview-question database, and a new AI résumé builder — plus coaching pathways as users grow.</a:t>
             </a:r>
           </a:p>
         </p:txBody>
@@ -12983,7 +12889,7 @@
                 </a:solidFill>
                 <a:latin typeface="Segoe UI"/>
               </a:rPr>
-              <a:t>AI-Native Product Suite</a:t>
+              <a:t>Proven Demand Base</a:t>
             </a:r>
           </a:p>
         </p:txBody>
@@ -13016,7 +12922,7 @@
                 </a:solidFill>
                 <a:latin typeface="Segoe UI"/>
               </a:rPr>
-              <a:t>Personalized mock interviews, proprietary question banks, online assessments, mentor coaching, and intelligent job matching.</a:t>
+              <a:t>Over 10,000 candidates helped across eight years of career-development operations; the AI platform launched in 2025 and is free today.</a:t>
             </a:r>
           </a:p>
         </p:txBody>
@@ -13172,7 +13078,7 @@
                 </a:solidFill>
                 <a:latin typeface="Segoe UI"/>
               </a:rPr>
-              <a:t>Global Footprint</a:t>
+              <a:t>Global Market</a:t>
             </a:r>
           </a:p>
         </p:txBody>
@@ -13205,7 +13111,7 @@
                 </a:solidFill>
                 <a:latin typeface="Segoe UI"/>
               </a:rPr>
-              <a:t>Teams and delivery capability across the U.S., China, U.K., Singapore, South Korea, Canada, and India.</a:t>
+              <a:t>A multi-hundred-billion-dollar global recruitment and career-development market shifting rapidly toward AI-native tools.</a:t>
             </a:r>
           </a:p>
         </p:txBody>
@@ -13361,7 +13267,7 @@
                 </a:solidFill>
                 <a:latin typeface="Segoe UI"/>
               </a:rPr>
-              <a:t>Strategic AI Partnership</a:t>
+              <a:t>Clear Monetization Path</a:t>
             </a:r>
           </a:p>
         </p:txBody>
@@ -13394,7 +13300,7 @@
                 </a:solidFill>
                 <a:latin typeface="Segoe UI"/>
               </a:rPr>
-              <a:t>Deep collaboration with Alibaba Cloud AI — Tongyi LLM, NLP, semantic search — powering advisor, matching, and screening systems.</a:t>
+              <a:t>Grow active users on a free product, then introduce membership fees, consulting fees, and education fees as engagement compounds.</a:t>
             </a:r>
           </a:p>
         </p:txBody>
@@ -13550,7 +13456,7 @@
                 </a:solidFill>
                 <a:latin typeface="Segoe UI"/>
               </a:rPr>
-              <a:t>Compelling Entry Point</a:t>
+              <a:t>Capital to Scale</a:t>
             </a:r>
           </a:p>
         </p:txBody>
@@ -13583,7 +13489,7 @@
                 </a:solidFill>
                 <a:latin typeface="Segoe UI"/>
               </a:rPr>
-              <a:t>US$5.0M primary round at a US$50.0M valuation to fund the product roadmap and global go-to-market.</a:t>
+              <a:t>US$5.0M primary round at a US$50.0M valuation to fund product, AI features, and global user growth.</a:t>
             </a:r>
           </a:p>
         </p:txBody>
@@ -14026,7 +13932,7 @@
                 </a:solidFill>
                 <a:latin typeface="Segoe UI"/>
               </a:rPr>
-              <a:t>Hiring processes are opaque and intensely competitive. Interview preparation remains fragmented across scattered resources, and quality human coaching is expensive and does not scale.</a:t>
+              <a:t>Hiring processes are opaque and intensely competitive worldwide. Interview preparation remains fragmented, and quality coaching is expensive and does not scale.</a:t>
             </a:r>
           </a:p>
         </p:txBody>
@@ -14149,7 +14055,7 @@
                 </a:solidFill>
                 <a:latin typeface="Segoe UI"/>
               </a:rPr>
-              <a:t>For international talent</a:t>
+              <a:t>For global talent</a:t>
             </a:r>
           </a:p>
         </p:txBody>
@@ -14182,7 +14088,7 @@
                 </a:solidFill>
                 <a:latin typeface="Segoe UI"/>
               </a:rPr>
-              <a:t>Language, cultural, and visa complexity compound an already difficult search — a large, motivated population is structurally underserved by generic tools.</a:t>
+              <a:t>Language, cultural, and cross-border complexity compound an already difficult search — hundreds of millions of professionals are underserved by generic AI chat tools.</a:t>
             </a:r>
           </a:p>
         </p:txBody>
@@ -14418,7 +14324,7 @@
                 </a:solidFill>
                 <a:latin typeface="Segoe UI"/>
               </a:rPr>
-              <a:t>Structural friction indicators</a:t>
+              <a:t>Global friction indicators</a:t>
             </a:r>
           </a:p>
         </p:txBody>
@@ -14484,7 +14390,7 @@
                 </a:solidFill>
                 <a:latin typeface="Segoe UI"/>
               </a:rPr>
-              <a:t>APPLICATIONS PER CORPORATE JOB OPENING</a:t>
+              <a:t>APPLICATIONS PER CORPORATE JOB OPENING (GLOBAL)</a:t>
             </a:r>
           </a:p>
         </p:txBody>
@@ -14603,7 +14509,7 @@
                 </a:solidFill>
                 <a:latin typeface="Georgia"/>
               </a:rPr>
-              <a:t>1.1M+</a:t>
+              <a:t>6M+</a:t>
             </a:r>
           </a:p>
         </p:txBody>
@@ -14636,7 +14542,7 @@
                 </a:solidFill>
                 <a:latin typeface="Segoe UI"/>
               </a:rPr>
-              <a:t>INTERNATIONAL STUDENTS IN THE U.S. ALONE</a:t>
+              <a:t>INTERNATIONAL STUDENTS WORLDWIDE (ANNUAL)</a:t>
             </a:r>
           </a:p>
         </p:txBody>
@@ -14693,7 +14599,7 @@
         <p:spPr>
           <a:xfrm>
             <a:off x="6812280" y="3749039"/>
-            <a:ext cx="4343400" cy="109728"/>
+            <a:ext cx="3886200" cy="109728"/>
           </a:xfrm>
           <a:prstGeom prst="rect">
             <a:avLst/>
@@ -14907,7 +14813,7 @@
                 </a:solidFill>
                 <a:latin typeface="Segoe UI"/>
               </a:rPr>
-              <a:t>Sources: Open Doors 2024; Glassdoor; industry estimates.</a:t>
+              <a:t>Sources: UNESCO / OECD mobility data; Glassdoor; industry estimates.</a:t>
             </a:r>
           </a:p>
         </p:txBody>
@@ -15194,7 +15100,7 @@
                 </a:solidFill>
                 <a:latin typeface="Georgia"/>
               </a:rPr>
-              <a:t>A US$200B+ Global Talent Market in Structural Shift</a:t>
+              <a:t>A Global Career Market in Structural Shift</a:t>
             </a:r>
           </a:p>
         </p:txBody>
@@ -15383,7 +15289,7 @@
                 </a:solidFill>
                 <a:latin typeface="Segoe UI"/>
               </a:rPr>
-              <a:t>Global recruitment, talent-acquisition, and career-development spend.</a:t>
+              <a:t>Global recruitment, talent-acquisition, and career-development spend worldwide.</a:t>
             </a:r>
           </a:p>
         </p:txBody>
@@ -15539,7 +15445,7 @@
                 </a:solidFill>
                 <a:latin typeface="Georgia"/>
               </a:rPr>
-              <a:t>US$30B</a:t>
+              <a:t>US$30B+</a:t>
             </a:r>
           </a:p>
         </p:txBody>
@@ -15572,7 +15478,7 @@
                 </a:solidFill>
                 <a:latin typeface="Segoe UI"/>
               </a:rPr>
-              <a:t>AI-enabled hiring technology and digital career preparation.</a:t>
+              <a:t>Global AI-enabled hiring technology and digital career preparation.</a:t>
             </a:r>
           </a:p>
         </p:txBody>
@@ -15633,7 +15539,7 @@
         <p:spPr>
           <a:xfrm>
             <a:off x="685800" y="4892040"/>
-            <a:ext cx="1510588" cy="146304"/>
+            <a:ext cx="1726387" cy="146304"/>
           </a:xfrm>
           <a:prstGeom prst="rect">
             <a:avLst/>
@@ -15695,7 +15601,7 @@
                 </a:solidFill>
                 <a:latin typeface="Segoe UI"/>
               </a:rPr>
-              <a:t>INITIAL TARGET SEGMENT</a:t>
+              <a:t>NEAR-TERM FOCUS</a:t>
             </a:r>
           </a:p>
         </p:txBody>
@@ -15728,7 +15634,7 @@
                 </a:solidFill>
                 <a:latin typeface="Georgia"/>
               </a:rPr>
-              <a:t>US$1.5B</a:t>
+              <a:t>US$5B+</a:t>
             </a:r>
           </a:p>
         </p:txBody>
@@ -15761,7 +15667,7 @@
                 </a:solidFill>
                 <a:latin typeface="Segoe UI"/>
               </a:rPr>
-              <a:t>Cross-border early-career talent across current Company markets.</a:t>
+              <a:t>Global early-career and mid-career professionals seeking AI prep, résumés, and interview readiness.</a:t>
             </a:r>
           </a:p>
         </p:txBody>
@@ -15841,7 +15747,7 @@
                 </a:solidFill>
                 <a:latin typeface="Segoe UI"/>
               </a:rPr>
-              <a:t>AI hiring &amp; career-tech spend (illustrative, US$B)</a:t>
+              <a:t>Global AI career-tech spend (illustrative, US$B)</a:t>
             </a:r>
           </a:p>
         </p:txBody>
@@ -15892,7 +15798,7 @@
                 </a:solidFill>
                 <a:latin typeface="Segoe UI"/>
               </a:rPr>
-              <a:t>Management estimates informed by public industry research; presented for illustration.</a:t>
+              <a:t>Management estimates informed by public global industry research; presented for illustration.</a:t>
             </a:r>
           </a:p>
         </p:txBody>
@@ -16146,7 +16052,7 @@
                 </a:solidFill>
                 <a:latin typeface="Segoe UI"/>
               </a:rPr>
-              <a:t>THE PLATFORM</a:t>
+              <a:t>OUR PRODUCT</a:t>
             </a:r>
           </a:p>
         </p:txBody>
@@ -16179,7 +16085,7 @@
                 </a:solidFill>
                 <a:latin typeface="Georgia"/>
               </a:rPr>
-              <a:t>One Platform Spanning Preparation, Placement &amp; Hiring</a:t>
+              <a:t>What 51Careers.AI Delivers Today</a:t>
             </a:r>
           </a:p>
         </p:txBody>
@@ -16192,8 +16098,86 @@
         </p:nvSpPr>
         <p:spPr>
           <a:xfrm>
-            <a:off x="502920" y="1234440"/>
-            <a:ext cx="5486400" cy="4160520"/>
+            <a:off x="502920" y="1170432"/>
+            <a:ext cx="11201400" cy="640080"/>
+          </a:xfrm>
+          <a:prstGeom prst="roundRect">
+            <a:avLst>
+              <a:gd name="adj" fmla="val 8000"/>
+            </a:avLst>
+          </a:prstGeom>
+          <a:solidFill>
+            <a:srgbClr val="D7EBE8"/>
+          </a:solidFill>
+          <a:ln>
+            <a:noFill/>
+          </a:ln>
+        </p:spPr>
+        <p:style>
+          <a:lnRef idx="1">
+            <a:schemeClr val="accent1"/>
+          </a:lnRef>
+          <a:fillRef idx="3">
+            <a:schemeClr val="accent1"/>
+          </a:fillRef>
+          <a:effectRef idx="2">
+            <a:schemeClr val="accent1"/>
+          </a:effectRef>
+          <a:fontRef idx="minor">
+            <a:schemeClr val="lt1"/>
+          </a:fontRef>
+        </p:style>
+        <p:txBody>
+          <a:bodyPr rtlCol="0" anchor="ctr"/>
+          <a:lstStyle/>
+          <a:p>
+            <a:pPr algn="ctr"/>
+          </a:p>
+        </p:txBody>
+      </p:sp>
+      <p:sp>
+        <p:nvSpPr>
+          <p:cNvPr id="6" name="TextBox 5"/>
+          <p:cNvSpPr txBox="1"/>
+          <p:nvPr/>
+        </p:nvSpPr>
+        <p:spPr>
+          <a:xfrm>
+            <a:off x="685800" y="1280160"/>
+            <a:ext cx="10835640" cy="457200"/>
+          </a:xfrm>
+          <a:prstGeom prst="rect">
+            <a:avLst/>
+          </a:prstGeom>
+          <a:noFill/>
+        </p:spPr>
+        <p:txBody>
+          <a:bodyPr wrap="square" anchor="t"/>
+          <a:lstStyle/>
+          <a:p>
+            <a:pPr algn="l"/>
+            <a:r>
+              <a:rPr sz="1300" b="1" i="0">
+                <a:solidFill>
+                  <a:srgbClr val="07524C"/>
+                </a:solidFill>
+                <a:latin typeface="Segoe UI"/>
+              </a:rPr>
+              <a:t>51Careers.AI is a free AI career platform — mock interviews, a 100K+ question database, and a new AI résumé builder — designed to help professionals worldwide compete for better jobs.</a:t>
+            </a:r>
+          </a:p>
+        </p:txBody>
+      </p:sp>
+      <p:sp>
+        <p:nvSpPr>
+          <p:cNvPr id="7" name="Rounded Rectangle 6"/>
+          <p:cNvSpPr/>
+          <p:nvPr/>
+        </p:nvSpPr>
+        <p:spPr>
+          <a:xfrm>
+            <a:off x="502920" y="2011680"/>
+            <a:ext cx="2743200" cy="3200400"/>
           </a:xfrm>
           <a:prstGeom prst="roundRect">
             <a:avLst>
@@ -16233,14 +16217,14 @@
       </p:sp>
       <p:sp>
         <p:nvSpPr>
-          <p:cNvPr id="6" name="Rectangle 5"/>
+          <p:cNvPr id="8" name="Rectangle 7"/>
           <p:cNvSpPr/>
           <p:nvPr/>
         </p:nvSpPr>
         <p:spPr>
           <a:xfrm>
-            <a:off x="502920" y="1234440"/>
-            <a:ext cx="5486400" cy="457200"/>
+            <a:off x="502920" y="2011680"/>
+            <a:ext cx="2743200" cy="109728"/>
           </a:xfrm>
           <a:prstGeom prst="rect">
             <a:avLst/>
@@ -16276,311 +16260,80 @@
       </p:sp>
       <p:sp>
         <p:nvSpPr>
-          <p:cNvPr id="7" name="TextBox 6"/>
-          <p:cNvSpPr txBox="1"/>
-          <p:nvPr/>
-        </p:nvSpPr>
-        <p:spPr>
-          <a:xfrm>
-            <a:off x="685800" y="1325880"/>
-            <a:ext cx="5120640" cy="320040"/>
-          </a:xfrm>
-          <a:prstGeom prst="rect">
-            <a:avLst/>
-          </a:prstGeom>
-          <a:noFill/>
-        </p:spPr>
-        <p:txBody>
-          <a:bodyPr wrap="square" anchor="t"/>
-          <a:lstStyle/>
-          <a:p>
-            <a:pPr algn="l"/>
-            <a:r>
-              <a:rPr sz="1200" b="1" i="0">
-                <a:solidFill>
-                  <a:srgbClr val="FFFFFF"/>
+          <p:cNvPr id="9" name="TextBox 8"/>
+          <p:cNvSpPr txBox="1"/>
+          <p:nvPr/>
+        </p:nvSpPr>
+        <p:spPr>
+          <a:xfrm>
+            <a:off x="667512" y="2286000"/>
+            <a:ext cx="2423160" cy="640080"/>
+          </a:xfrm>
+          <a:prstGeom prst="rect">
+            <a:avLst/>
+          </a:prstGeom>
+          <a:noFill/>
+        </p:spPr>
+        <p:txBody>
+          <a:bodyPr wrap="square" anchor="t"/>
+          <a:lstStyle/>
+          <a:p>
+            <a:pPr algn="l"/>
+            <a:r>
+              <a:rPr sz="1500" b="1" i="0">
+                <a:solidFill>
+                  <a:srgbClr val="0B1F33"/>
+                </a:solidFill>
+                <a:latin typeface="Georgia"/>
+              </a:rPr>
+              <a:t>AI Mock Interviews</a:t>
+            </a:r>
+          </a:p>
+        </p:txBody>
+      </p:sp>
+      <p:sp>
+        <p:nvSpPr>
+          <p:cNvPr id="10" name="TextBox 9"/>
+          <p:cNvSpPr txBox="1"/>
+          <p:nvPr/>
+        </p:nvSpPr>
+        <p:spPr>
+          <a:xfrm>
+            <a:off x="667512" y="3017520"/>
+            <a:ext cx="2423160" cy="1828800"/>
+          </a:xfrm>
+          <a:prstGeom prst="rect">
+            <a:avLst/>
+          </a:prstGeom>
+          <a:noFill/>
+        </p:spPr>
+        <p:txBody>
+          <a:bodyPr wrap="square" anchor="t"/>
+          <a:lstStyle/>
+          <a:p>
+            <a:pPr algn="l"/>
+            <a:r>
+              <a:rPr sz="1200" b="0" i="0">
+                <a:solidFill>
+                  <a:srgbClr val="2C3A4B"/>
                 </a:solidFill>
                 <a:latin typeface="Segoe UI"/>
               </a:rPr>
-              <a:t>FOR CANDIDATES</a:t>
-            </a:r>
-          </a:p>
-        </p:txBody>
-      </p:sp>
-      <p:sp>
-        <p:nvSpPr>
-          <p:cNvPr id="8" name="TextBox 7"/>
-          <p:cNvSpPr txBox="1"/>
-          <p:nvPr/>
-        </p:nvSpPr>
-        <p:spPr>
-          <a:xfrm>
-            <a:off x="777240" y="1874519"/>
-            <a:ext cx="4937760" cy="274320"/>
-          </a:xfrm>
-          <a:prstGeom prst="rect">
-            <a:avLst/>
-          </a:prstGeom>
-          <a:noFill/>
-        </p:spPr>
-        <p:txBody>
-          <a:bodyPr wrap="square" anchor="t"/>
-          <a:lstStyle/>
-          <a:p>
-            <a:pPr algn="l"/>
-            <a:r>
-              <a:rPr sz="1300" b="1" i="0">
-                <a:solidFill>
-                  <a:srgbClr val="0B1F33"/>
-                </a:solidFill>
-                <a:latin typeface="Segoe UI"/>
-              </a:rPr>
-              <a:t>AI Mock Interviews</a:t>
-            </a:r>
-          </a:p>
-        </p:txBody>
-      </p:sp>
-      <p:sp>
-        <p:nvSpPr>
-          <p:cNvPr id="9" name="TextBox 8"/>
-          <p:cNvSpPr txBox="1"/>
-          <p:nvPr/>
-        </p:nvSpPr>
-        <p:spPr>
-          <a:xfrm>
-            <a:off x="777240" y="2130552"/>
-            <a:ext cx="4937760" cy="365760"/>
-          </a:xfrm>
-          <a:prstGeom prst="rect">
-            <a:avLst/>
-          </a:prstGeom>
-          <a:noFill/>
-        </p:spPr>
-        <p:txBody>
-          <a:bodyPr wrap="square" anchor="t"/>
-          <a:lstStyle/>
-          <a:p>
-            <a:pPr algn="l"/>
-            <a:r>
-              <a:rPr sz="1100" b="0" i="0">
-                <a:solidFill>
-                  <a:srgbClr val="2C3A4B"/>
-                </a:solidFill>
-                <a:latin typeface="Segoe UI"/>
-              </a:rPr>
-              <a:t>Role- and company-specific practice with personalized, real-time feedback.</a:t>
-            </a:r>
-          </a:p>
-        </p:txBody>
-      </p:sp>
-      <p:sp>
-        <p:nvSpPr>
-          <p:cNvPr id="10" name="TextBox 9"/>
-          <p:cNvSpPr txBox="1"/>
-          <p:nvPr/>
-        </p:nvSpPr>
-        <p:spPr>
-          <a:xfrm>
-            <a:off x="777240" y="2651760"/>
-            <a:ext cx="4937760" cy="274320"/>
-          </a:xfrm>
-          <a:prstGeom prst="rect">
-            <a:avLst/>
-          </a:prstGeom>
-          <a:noFill/>
-        </p:spPr>
-        <p:txBody>
-          <a:bodyPr wrap="square" anchor="t"/>
-          <a:lstStyle/>
-          <a:p>
-            <a:pPr algn="l"/>
-            <a:r>
-              <a:rPr sz="1300" b="1" i="0">
-                <a:solidFill>
-                  <a:srgbClr val="0B1F33"/>
-                </a:solidFill>
-                <a:latin typeface="Segoe UI"/>
-              </a:rPr>
-              <a:t>Question Banks &amp; Assessments</a:t>
-            </a:r>
-          </a:p>
-        </p:txBody>
-      </p:sp>
-      <p:sp>
-        <p:nvSpPr>
-          <p:cNvPr id="11" name="TextBox 10"/>
-          <p:cNvSpPr txBox="1"/>
-          <p:nvPr/>
-        </p:nvSpPr>
-        <p:spPr>
-          <a:xfrm>
-            <a:off x="777240" y="2907791"/>
-            <a:ext cx="4937760" cy="365760"/>
-          </a:xfrm>
-          <a:prstGeom prst="rect">
-            <a:avLst/>
-          </a:prstGeom>
-          <a:noFill/>
-        </p:spPr>
-        <p:txBody>
-          <a:bodyPr wrap="square" anchor="t"/>
-          <a:lstStyle/>
-          <a:p>
-            <a:pPr algn="l"/>
-            <a:r>
-              <a:rPr sz="1100" b="0" i="0">
-                <a:solidFill>
-                  <a:srgbClr val="2C3A4B"/>
-                </a:solidFill>
-                <a:latin typeface="Segoe UI"/>
-              </a:rPr>
-              <a:t>Proprietary libraries of real interview questions and timed online assessments.</a:t>
-            </a:r>
-          </a:p>
-        </p:txBody>
-      </p:sp>
-      <p:sp>
-        <p:nvSpPr>
-          <p:cNvPr id="12" name="TextBox 11"/>
-          <p:cNvSpPr txBox="1"/>
-          <p:nvPr/>
-        </p:nvSpPr>
-        <p:spPr>
-          <a:xfrm>
-            <a:off x="777240" y="3429000"/>
-            <a:ext cx="4937760" cy="274320"/>
-          </a:xfrm>
-          <a:prstGeom prst="rect">
-            <a:avLst/>
-          </a:prstGeom>
-          <a:noFill/>
-        </p:spPr>
-        <p:txBody>
-          <a:bodyPr wrap="square" anchor="t"/>
-          <a:lstStyle/>
-          <a:p>
-            <a:pPr algn="l"/>
-            <a:r>
-              <a:rPr sz="1300" b="1" i="0">
-                <a:solidFill>
-                  <a:srgbClr val="0B1F33"/>
-                </a:solidFill>
-                <a:latin typeface="Segoe UI"/>
-              </a:rPr>
-              <a:t>Mentor Coaching</a:t>
-            </a:r>
-          </a:p>
-        </p:txBody>
-      </p:sp>
-      <p:sp>
-        <p:nvSpPr>
-          <p:cNvPr id="13" name="TextBox 12"/>
-          <p:cNvSpPr txBox="1"/>
-          <p:nvPr/>
-        </p:nvSpPr>
-        <p:spPr>
-          <a:xfrm>
-            <a:off x="777240" y="3685032"/>
-            <a:ext cx="4937760" cy="365760"/>
-          </a:xfrm>
-          <a:prstGeom prst="rect">
-            <a:avLst/>
-          </a:prstGeom>
-          <a:noFill/>
-        </p:spPr>
-        <p:txBody>
-          <a:bodyPr wrap="square" anchor="t"/>
-          <a:lstStyle/>
-          <a:p>
-            <a:pPr algn="l"/>
-            <a:r>
-              <a:rPr sz="1100" b="0" i="0">
-                <a:solidFill>
-                  <a:srgbClr val="2C3A4B"/>
-                </a:solidFill>
-                <a:latin typeface="Segoe UI"/>
-              </a:rPr>
-              <a:t>One-on-one guidance from practitioners at leading global employers.</a:t>
-            </a:r>
-          </a:p>
-        </p:txBody>
-      </p:sp>
-      <p:sp>
-        <p:nvSpPr>
-          <p:cNvPr id="14" name="TextBox 13"/>
-          <p:cNvSpPr txBox="1"/>
-          <p:nvPr/>
-        </p:nvSpPr>
-        <p:spPr>
-          <a:xfrm>
-            <a:off x="777240" y="4206240"/>
-            <a:ext cx="4937760" cy="274320"/>
-          </a:xfrm>
-          <a:prstGeom prst="rect">
-            <a:avLst/>
-          </a:prstGeom>
-          <a:noFill/>
-        </p:spPr>
-        <p:txBody>
-          <a:bodyPr wrap="square" anchor="t"/>
-          <a:lstStyle/>
-          <a:p>
-            <a:pPr algn="l"/>
-            <a:r>
-              <a:rPr sz="1300" b="1" i="0">
-                <a:solidFill>
-                  <a:srgbClr val="0B1F33"/>
-                </a:solidFill>
-                <a:latin typeface="Segoe UI"/>
-              </a:rPr>
-              <a:t>Referrals &amp; Placement</a:t>
-            </a:r>
-          </a:p>
-        </p:txBody>
-      </p:sp>
-      <p:sp>
-        <p:nvSpPr>
-          <p:cNvPr id="15" name="TextBox 14"/>
-          <p:cNvSpPr txBox="1"/>
-          <p:nvPr/>
-        </p:nvSpPr>
-        <p:spPr>
-          <a:xfrm>
-            <a:off x="777240" y="4462272"/>
-            <a:ext cx="4937760" cy="365760"/>
-          </a:xfrm>
-          <a:prstGeom prst="rect">
-            <a:avLst/>
-          </a:prstGeom>
-          <a:noFill/>
-        </p:spPr>
-        <p:txBody>
-          <a:bodyPr wrap="square" anchor="t"/>
-          <a:lstStyle/>
-          <a:p>
-            <a:pPr algn="l"/>
-            <a:r>
-              <a:rPr sz="1100" b="0" i="0">
-                <a:solidFill>
-                  <a:srgbClr val="2C3A4B"/>
-                </a:solidFill>
-                <a:latin typeface="Segoe UI"/>
-              </a:rPr>
-              <a:t>Internship and full-time referral programs, including outcome-based offerings.</a:t>
-            </a:r>
-          </a:p>
-        </p:txBody>
-      </p:sp>
-      <p:sp>
-        <p:nvSpPr>
-          <p:cNvPr id="16" name="Rounded Rectangle 15"/>
+              <a:t>Role- and company-specific practice with personalized feedback powered by career-domain intelligence.</a:t>
+            </a:r>
+          </a:p>
+        </p:txBody>
+      </p:sp>
+      <p:sp>
+        <p:nvSpPr>
+          <p:cNvPr id="11" name="Rounded Rectangle 10"/>
           <p:cNvSpPr/>
           <p:nvPr/>
         </p:nvSpPr>
         <p:spPr>
           <a:xfrm>
-            <a:off x="6217920" y="1234440"/>
-            <a:ext cx="5486400" cy="4160520"/>
+            <a:off x="3383280" y="2011680"/>
+            <a:ext cx="2743200" cy="3200400"/>
           </a:xfrm>
           <a:prstGeom prst="roundRect">
             <a:avLst>
@@ -16620,14 +16373,14 @@
       </p:sp>
       <p:sp>
         <p:nvSpPr>
-          <p:cNvPr id="17" name="Rectangle 16"/>
+          <p:cNvPr id="12" name="Rectangle 11"/>
           <p:cNvSpPr/>
           <p:nvPr/>
         </p:nvSpPr>
         <p:spPr>
           <a:xfrm>
-            <a:off x="6217920" y="1234440"/>
-            <a:ext cx="5486400" cy="457200"/>
+            <a:off x="3383280" y="2011680"/>
+            <a:ext cx="2743200" cy="109728"/>
           </a:xfrm>
           <a:prstGeom prst="rect">
             <a:avLst/>
@@ -16663,245 +16416,80 @@
       </p:sp>
       <p:sp>
         <p:nvSpPr>
-          <p:cNvPr id="18" name="TextBox 17"/>
-          <p:cNvSpPr txBox="1"/>
-          <p:nvPr/>
-        </p:nvSpPr>
-        <p:spPr>
-          <a:xfrm>
-            <a:off x="6400800" y="1325880"/>
-            <a:ext cx="5120640" cy="320040"/>
-          </a:xfrm>
-          <a:prstGeom prst="rect">
-            <a:avLst/>
-          </a:prstGeom>
-          <a:noFill/>
-        </p:spPr>
-        <p:txBody>
-          <a:bodyPr wrap="square" anchor="t"/>
-          <a:lstStyle/>
-          <a:p>
-            <a:pPr algn="l"/>
-            <a:r>
-              <a:rPr sz="1200" b="1" i="0">
-                <a:solidFill>
-                  <a:srgbClr val="FFFFFF"/>
+          <p:cNvPr id="13" name="TextBox 12"/>
+          <p:cNvSpPr txBox="1"/>
+          <p:nvPr/>
+        </p:nvSpPr>
+        <p:spPr>
+          <a:xfrm>
+            <a:off x="3547872" y="2286000"/>
+            <a:ext cx="2423160" cy="640080"/>
+          </a:xfrm>
+          <a:prstGeom prst="rect">
+            <a:avLst/>
+          </a:prstGeom>
+          <a:noFill/>
+        </p:spPr>
+        <p:txBody>
+          <a:bodyPr wrap="square" anchor="t"/>
+          <a:lstStyle/>
+          <a:p>
+            <a:pPr algn="l"/>
+            <a:r>
+              <a:rPr sz="1500" b="1" i="0">
+                <a:solidFill>
+                  <a:srgbClr val="0B1F33"/>
+                </a:solidFill>
+                <a:latin typeface="Georgia"/>
+              </a:rPr>
+              <a:t>100K+ Question Database</a:t>
+            </a:r>
+          </a:p>
+        </p:txBody>
+      </p:sp>
+      <p:sp>
+        <p:nvSpPr>
+          <p:cNvPr id="14" name="TextBox 13"/>
+          <p:cNvSpPr txBox="1"/>
+          <p:nvPr/>
+        </p:nvSpPr>
+        <p:spPr>
+          <a:xfrm>
+            <a:off x="3547872" y="3017520"/>
+            <a:ext cx="2423160" cy="1828800"/>
+          </a:xfrm>
+          <a:prstGeom prst="rect">
+            <a:avLst/>
+          </a:prstGeom>
+          <a:noFill/>
+        </p:spPr>
+        <p:txBody>
+          <a:bodyPr wrap="square" anchor="t"/>
+          <a:lstStyle/>
+          <a:p>
+            <a:pPr algn="l"/>
+            <a:r>
+              <a:rPr sz="1200" b="0" i="0">
+                <a:solidFill>
+                  <a:srgbClr val="2C3A4B"/>
                 </a:solidFill>
                 <a:latin typeface="Segoe UI"/>
               </a:rPr>
-              <a:t>FOR EMPLOYERS</a:t>
-            </a:r>
-          </a:p>
-        </p:txBody>
-      </p:sp>
-      <p:sp>
-        <p:nvSpPr>
-          <p:cNvPr id="19" name="TextBox 18"/>
-          <p:cNvSpPr txBox="1"/>
-          <p:nvPr/>
-        </p:nvSpPr>
-        <p:spPr>
-          <a:xfrm>
-            <a:off x="6492240" y="1965960"/>
-            <a:ext cx="4937760" cy="274320"/>
-          </a:xfrm>
-          <a:prstGeom prst="rect">
-            <a:avLst/>
-          </a:prstGeom>
-          <a:noFill/>
-        </p:spPr>
-        <p:txBody>
-          <a:bodyPr wrap="square" anchor="t"/>
-          <a:lstStyle/>
-          <a:p>
-            <a:pPr algn="l"/>
-            <a:r>
-              <a:rPr sz="1300" b="1" i="0">
-                <a:solidFill>
-                  <a:srgbClr val="0B1F33"/>
-                </a:solidFill>
-                <a:latin typeface="Segoe UI"/>
-              </a:rPr>
-              <a:t>AI Candidate Screening</a:t>
-            </a:r>
-          </a:p>
-        </p:txBody>
-      </p:sp>
-      <p:sp>
-        <p:nvSpPr>
-          <p:cNvPr id="20" name="TextBox 19"/>
-          <p:cNvSpPr txBox="1"/>
-          <p:nvPr/>
-        </p:nvSpPr>
-        <p:spPr>
-          <a:xfrm>
-            <a:off x="6492240" y="2221991"/>
-            <a:ext cx="4937760" cy="411480"/>
-          </a:xfrm>
-          <a:prstGeom prst="rect">
-            <a:avLst/>
-          </a:prstGeom>
-          <a:noFill/>
-        </p:spPr>
-        <p:txBody>
-          <a:bodyPr wrap="square" anchor="t"/>
-          <a:lstStyle/>
-          <a:p>
-            <a:pPr algn="l"/>
-            <a:r>
-              <a:rPr sz="1100" b="0" i="0">
-                <a:solidFill>
-                  <a:srgbClr val="2C3A4B"/>
-                </a:solidFill>
-                <a:latin typeface="Segoe UI"/>
-              </a:rPr>
-              <a:t>Semantic evaluation of fit, capability, and readiness at scale.</a:t>
-            </a:r>
-          </a:p>
-        </p:txBody>
-      </p:sp>
-      <p:sp>
-        <p:nvSpPr>
-          <p:cNvPr id="21" name="TextBox 20"/>
-          <p:cNvSpPr txBox="1"/>
-          <p:nvPr/>
-        </p:nvSpPr>
-        <p:spPr>
-          <a:xfrm>
-            <a:off x="6492240" y="2880360"/>
-            <a:ext cx="4937760" cy="274320"/>
-          </a:xfrm>
-          <a:prstGeom prst="rect">
-            <a:avLst/>
-          </a:prstGeom>
-          <a:noFill/>
-        </p:spPr>
-        <p:txBody>
-          <a:bodyPr wrap="square" anchor="t"/>
-          <a:lstStyle/>
-          <a:p>
-            <a:pPr algn="l"/>
-            <a:r>
-              <a:rPr sz="1300" b="1" i="0">
-                <a:solidFill>
-                  <a:srgbClr val="0B1F33"/>
-                </a:solidFill>
-                <a:latin typeface="Segoe UI"/>
-              </a:rPr>
-              <a:t>Job Posting Optimization</a:t>
-            </a:r>
-          </a:p>
-        </p:txBody>
-      </p:sp>
-      <p:sp>
-        <p:nvSpPr>
-          <p:cNvPr id="22" name="TextBox 21"/>
-          <p:cNvSpPr txBox="1"/>
-          <p:nvPr/>
-        </p:nvSpPr>
-        <p:spPr>
-          <a:xfrm>
-            <a:off x="6492240" y="3136391"/>
-            <a:ext cx="4937760" cy="411480"/>
-          </a:xfrm>
-          <a:prstGeom prst="rect">
-            <a:avLst/>
-          </a:prstGeom>
-          <a:noFill/>
-        </p:spPr>
-        <p:txBody>
-          <a:bodyPr wrap="square" anchor="t"/>
-          <a:lstStyle/>
-          <a:p>
-            <a:pPr algn="l"/>
-            <a:r>
-              <a:rPr sz="1100" b="0" i="0">
-                <a:solidFill>
-                  <a:srgbClr val="2C3A4B"/>
-                </a:solidFill>
-                <a:latin typeface="Segoe UI"/>
-              </a:rPr>
-              <a:t>AI-assisted role definition and sourcing precision.</a:t>
-            </a:r>
-          </a:p>
-        </p:txBody>
-      </p:sp>
-      <p:sp>
-        <p:nvSpPr>
-          <p:cNvPr id="23" name="TextBox 22"/>
-          <p:cNvSpPr txBox="1"/>
-          <p:nvPr/>
-        </p:nvSpPr>
-        <p:spPr>
-          <a:xfrm>
-            <a:off x="6492240" y="3794760"/>
-            <a:ext cx="4937760" cy="274320"/>
-          </a:xfrm>
-          <a:prstGeom prst="rect">
-            <a:avLst/>
-          </a:prstGeom>
-          <a:noFill/>
-        </p:spPr>
-        <p:txBody>
-          <a:bodyPr wrap="square" anchor="t"/>
-          <a:lstStyle/>
-          <a:p>
-            <a:pPr algn="l"/>
-            <a:r>
-              <a:rPr sz="1300" b="1" i="0">
-                <a:solidFill>
-                  <a:srgbClr val="0B1F33"/>
-                </a:solidFill>
-                <a:latin typeface="Segoe UI"/>
-              </a:rPr>
-              <a:t>Talent Evaluation</a:t>
-            </a:r>
-          </a:p>
-        </p:txBody>
-      </p:sp>
-      <p:sp>
-        <p:nvSpPr>
-          <p:cNvPr id="24" name="TextBox 23"/>
-          <p:cNvSpPr txBox="1"/>
-          <p:nvPr/>
-        </p:nvSpPr>
-        <p:spPr>
-          <a:xfrm>
-            <a:off x="6492240" y="4050792"/>
-            <a:ext cx="4937760" cy="411480"/>
-          </a:xfrm>
-          <a:prstGeom prst="rect">
-            <a:avLst/>
-          </a:prstGeom>
-          <a:noFill/>
-        </p:spPr>
-        <p:txBody>
-          <a:bodyPr wrap="square" anchor="t"/>
-          <a:lstStyle/>
-          <a:p>
-            <a:pPr algn="l"/>
-            <a:r>
-              <a:rPr sz="1100" b="0" i="0">
-                <a:solidFill>
-                  <a:srgbClr val="2C3A4B"/>
-                </a:solidFill>
-                <a:latin typeface="Segoe UI"/>
-              </a:rPr>
-              <a:t>Structured assessment and interview analytics for confident decisions.</a:t>
-            </a:r>
-          </a:p>
-        </p:txBody>
-      </p:sp>
-      <p:sp>
-        <p:nvSpPr>
-          <p:cNvPr id="25" name="Rounded Rectangle 24"/>
+              <a:t>Proprietary library of real interview questions built from years of coaching and candidate preparation.</a:t>
+            </a:r>
+          </a:p>
+        </p:txBody>
+      </p:sp>
+      <p:sp>
+        <p:nvSpPr>
+          <p:cNvPr id="15" name="Rounded Rectangle 14"/>
           <p:cNvSpPr/>
           <p:nvPr/>
         </p:nvSpPr>
         <p:spPr>
           <a:xfrm>
-            <a:off x="502920" y="5532120"/>
-            <a:ext cx="11201400" cy="502920"/>
+            <a:off x="6263640" y="2011680"/>
+            <a:ext cx="2743200" cy="3200400"/>
           </a:xfrm>
           <a:prstGeom prst="roundRect">
             <a:avLst>
@@ -16909,10 +16497,12 @@
             </a:avLst>
           </a:prstGeom>
           <a:solidFill>
-            <a:srgbClr val="D7EBE8"/>
+            <a:srgbClr val="FFFFFF"/>
           </a:solidFill>
-          <a:ln>
-            <a:noFill/>
+          <a:ln w="12700">
+            <a:solidFill>
+              <a:srgbClr val="D4DEE8"/>
+            </a:solidFill>
           </a:ln>
         </p:spPr>
         <p:style>
@@ -16939,40 +16529,352 @@
       </p:sp>
       <p:sp>
         <p:nvSpPr>
-          <p:cNvPr id="26" name="TextBox 25"/>
-          <p:cNvSpPr txBox="1"/>
-          <p:nvPr/>
-        </p:nvSpPr>
-        <p:spPr>
-          <a:xfrm>
-            <a:off x="685800" y="5623560"/>
-            <a:ext cx="10789920" cy="365760"/>
-          </a:xfrm>
-          <a:prstGeom prst="rect">
-            <a:avLst/>
-          </a:prstGeom>
-          <a:noFill/>
-        </p:spPr>
-        <p:txBody>
-          <a:bodyPr wrap="square" anchor="t"/>
-          <a:lstStyle/>
-          <a:p>
-            <a:pPr algn="l"/>
-            <a:r>
-              <a:rPr sz="1100" b="1" i="0">
-                <a:solidFill>
-                  <a:srgbClr val="07524C"/>
+          <p:cNvPr id="16" name="Rectangle 15"/>
+          <p:cNvSpPr/>
+          <p:nvPr/>
+        </p:nvSpPr>
+        <p:spPr>
+          <a:xfrm>
+            <a:off x="6263640" y="2011680"/>
+            <a:ext cx="2743200" cy="109728"/>
+          </a:xfrm>
+          <a:prstGeom prst="rect">
+            <a:avLst/>
+          </a:prstGeom>
+          <a:solidFill>
+            <a:srgbClr val="8A6D3B"/>
+          </a:solidFill>
+          <a:ln>
+            <a:noFill/>
+          </a:ln>
+        </p:spPr>
+        <p:style>
+          <a:lnRef idx="1">
+            <a:schemeClr val="accent1"/>
+          </a:lnRef>
+          <a:fillRef idx="3">
+            <a:schemeClr val="accent1"/>
+          </a:fillRef>
+          <a:effectRef idx="2">
+            <a:schemeClr val="accent1"/>
+          </a:effectRef>
+          <a:fontRef idx="minor">
+            <a:schemeClr val="lt1"/>
+          </a:fontRef>
+        </p:style>
+        <p:txBody>
+          <a:bodyPr rtlCol="0" anchor="ctr"/>
+          <a:lstStyle/>
+          <a:p>
+            <a:pPr algn="ctr"/>
+          </a:p>
+        </p:txBody>
+      </p:sp>
+      <p:sp>
+        <p:nvSpPr>
+          <p:cNvPr id="17" name="TextBox 16"/>
+          <p:cNvSpPr txBox="1"/>
+          <p:nvPr/>
+        </p:nvSpPr>
+        <p:spPr>
+          <a:xfrm>
+            <a:off x="6428231" y="2286000"/>
+            <a:ext cx="2423160" cy="640080"/>
+          </a:xfrm>
+          <a:prstGeom prst="rect">
+            <a:avLst/>
+          </a:prstGeom>
+          <a:noFill/>
+        </p:spPr>
+        <p:txBody>
+          <a:bodyPr wrap="square" anchor="t"/>
+          <a:lstStyle/>
+          <a:p>
+            <a:pPr algn="l"/>
+            <a:r>
+              <a:rPr sz="1500" b="1" i="0">
+                <a:solidFill>
+                  <a:srgbClr val="0B1F33"/>
+                </a:solidFill>
+                <a:latin typeface="Georgia"/>
+              </a:rPr>
+              <a:t>AI Résumé Builder</a:t>
+            </a:r>
+          </a:p>
+        </p:txBody>
+      </p:sp>
+      <p:sp>
+        <p:nvSpPr>
+          <p:cNvPr id="18" name="TextBox 17"/>
+          <p:cNvSpPr txBox="1"/>
+          <p:nvPr/>
+        </p:nvSpPr>
+        <p:spPr>
+          <a:xfrm>
+            <a:off x="6428231" y="3017520"/>
+            <a:ext cx="2423160" cy="1828800"/>
+          </a:xfrm>
+          <a:prstGeom prst="rect">
+            <a:avLst/>
+          </a:prstGeom>
+          <a:noFill/>
+        </p:spPr>
+        <p:txBody>
+          <a:bodyPr wrap="square" anchor="t"/>
+          <a:lstStyle/>
+          <a:p>
+            <a:pPr algn="l"/>
+            <a:r>
+              <a:rPr sz="1200" b="0" i="0">
+                <a:solidFill>
+                  <a:srgbClr val="2C3A4B"/>
                 </a:solidFill>
                 <a:latin typeface="Segoe UI"/>
               </a:rPr>
-              <a:t>The flywheel: candidate outcomes generate proprietary data that sharpens matching and screening for employers — a compounding advantage on both sides of the market.</a:t>
-            </a:r>
-          </a:p>
-        </p:txBody>
-      </p:sp>
-      <p:sp>
-        <p:nvSpPr>
-          <p:cNvPr id="27" name="Rectangle 26"/>
+              <a:t>New AI feature that drafts and refines résumés tailored to roles, industries, and hiring expectations.</a:t>
+            </a:r>
+          </a:p>
+        </p:txBody>
+      </p:sp>
+      <p:sp>
+        <p:nvSpPr>
+          <p:cNvPr id="19" name="Rounded Rectangle 18"/>
+          <p:cNvSpPr/>
+          <p:nvPr/>
+        </p:nvSpPr>
+        <p:spPr>
+          <a:xfrm>
+            <a:off x="9144000" y="2011680"/>
+            <a:ext cx="2743200" cy="3200400"/>
+          </a:xfrm>
+          <a:prstGeom prst="roundRect">
+            <a:avLst>
+              <a:gd name="adj" fmla="val 8000"/>
+            </a:avLst>
+          </a:prstGeom>
+          <a:solidFill>
+            <a:srgbClr val="FFFFFF"/>
+          </a:solidFill>
+          <a:ln w="12700">
+            <a:solidFill>
+              <a:srgbClr val="D4DEE8"/>
+            </a:solidFill>
+          </a:ln>
+        </p:spPr>
+        <p:style>
+          <a:lnRef idx="1">
+            <a:schemeClr val="accent1"/>
+          </a:lnRef>
+          <a:fillRef idx="3">
+            <a:schemeClr val="accent1"/>
+          </a:fillRef>
+          <a:effectRef idx="2">
+            <a:schemeClr val="accent1"/>
+          </a:effectRef>
+          <a:fontRef idx="minor">
+            <a:schemeClr val="lt1"/>
+          </a:fontRef>
+        </p:style>
+        <p:txBody>
+          <a:bodyPr rtlCol="0" anchor="ctr"/>
+          <a:lstStyle/>
+          <a:p>
+            <a:pPr algn="ctr"/>
+          </a:p>
+        </p:txBody>
+      </p:sp>
+      <p:sp>
+        <p:nvSpPr>
+          <p:cNvPr id="20" name="Rectangle 19"/>
+          <p:cNvSpPr/>
+          <p:nvPr/>
+        </p:nvSpPr>
+        <p:spPr>
+          <a:xfrm>
+            <a:off x="9144000" y="2011680"/>
+            <a:ext cx="2743200" cy="109728"/>
+          </a:xfrm>
+          <a:prstGeom prst="rect">
+            <a:avLst/>
+          </a:prstGeom>
+          <a:solidFill>
+            <a:srgbClr val="6B7C8F"/>
+          </a:solidFill>
+          <a:ln>
+            <a:noFill/>
+          </a:ln>
+        </p:spPr>
+        <p:style>
+          <a:lnRef idx="1">
+            <a:schemeClr val="accent1"/>
+          </a:lnRef>
+          <a:fillRef idx="3">
+            <a:schemeClr val="accent1"/>
+          </a:fillRef>
+          <a:effectRef idx="2">
+            <a:schemeClr val="accent1"/>
+          </a:effectRef>
+          <a:fontRef idx="minor">
+            <a:schemeClr val="lt1"/>
+          </a:fontRef>
+        </p:style>
+        <p:txBody>
+          <a:bodyPr rtlCol="0" anchor="ctr"/>
+          <a:lstStyle/>
+          <a:p>
+            <a:pPr algn="ctr"/>
+          </a:p>
+        </p:txBody>
+      </p:sp>
+      <p:sp>
+        <p:nvSpPr>
+          <p:cNvPr id="21" name="TextBox 20"/>
+          <p:cNvSpPr txBox="1"/>
+          <p:nvPr/>
+        </p:nvSpPr>
+        <p:spPr>
+          <a:xfrm>
+            <a:off x="9308592" y="2286000"/>
+            <a:ext cx="2423160" cy="640080"/>
+          </a:xfrm>
+          <a:prstGeom prst="rect">
+            <a:avLst/>
+          </a:prstGeom>
+          <a:noFill/>
+        </p:spPr>
+        <p:txBody>
+          <a:bodyPr wrap="square" anchor="t"/>
+          <a:lstStyle/>
+          <a:p>
+            <a:pPr algn="l"/>
+            <a:r>
+              <a:rPr sz="1500" b="1" i="0">
+                <a:solidFill>
+                  <a:srgbClr val="0B1F33"/>
+                </a:solidFill>
+                <a:latin typeface="Georgia"/>
+              </a:rPr>
+              <a:t>Career Pathways</a:t>
+            </a:r>
+          </a:p>
+        </p:txBody>
+      </p:sp>
+      <p:sp>
+        <p:nvSpPr>
+          <p:cNvPr id="22" name="TextBox 21"/>
+          <p:cNvSpPr txBox="1"/>
+          <p:nvPr/>
+        </p:nvSpPr>
+        <p:spPr>
+          <a:xfrm>
+            <a:off x="9308592" y="3017520"/>
+            <a:ext cx="2423160" cy="1828800"/>
+          </a:xfrm>
+          <a:prstGeom prst="rect">
+            <a:avLst/>
+          </a:prstGeom>
+          <a:noFill/>
+        </p:spPr>
+        <p:txBody>
+          <a:bodyPr wrap="square" anchor="t"/>
+          <a:lstStyle/>
+          <a:p>
+            <a:pPr algn="l"/>
+            <a:r>
+              <a:rPr sz="1200" b="0" i="0">
+                <a:solidFill>
+                  <a:srgbClr val="2C3A4B"/>
+                </a:solidFill>
+                <a:latin typeface="Segoe UI"/>
+              </a:rPr>
+              <a:t>Coaching and education pathways ready to monetize via membership, consulting, and education fees.</a:t>
+            </a:r>
+          </a:p>
+        </p:txBody>
+      </p:sp>
+      <p:sp>
+        <p:nvSpPr>
+          <p:cNvPr id="23" name="Rounded Rectangle 22"/>
+          <p:cNvSpPr/>
+          <p:nvPr/>
+        </p:nvSpPr>
+        <p:spPr>
+          <a:xfrm>
+            <a:off x="502920" y="5394960"/>
+            <a:ext cx="11201400" cy="640080"/>
+          </a:xfrm>
+          <a:prstGeom prst="roundRect">
+            <a:avLst>
+              <a:gd name="adj" fmla="val 8000"/>
+            </a:avLst>
+          </a:prstGeom>
+          <a:solidFill>
+            <a:srgbClr val="FFFFFF"/>
+          </a:solidFill>
+          <a:ln w="12700">
+            <a:solidFill>
+              <a:srgbClr val="D4DEE8"/>
+            </a:solidFill>
+          </a:ln>
+        </p:spPr>
+        <p:style>
+          <a:lnRef idx="1">
+            <a:schemeClr val="accent1"/>
+          </a:lnRef>
+          <a:fillRef idx="3">
+            <a:schemeClr val="accent1"/>
+          </a:fillRef>
+          <a:effectRef idx="2">
+            <a:schemeClr val="accent1"/>
+          </a:effectRef>
+          <a:fontRef idx="minor">
+            <a:schemeClr val="lt1"/>
+          </a:fontRef>
+        </p:style>
+        <p:txBody>
+          <a:bodyPr rtlCol="0" anchor="ctr"/>
+          <a:lstStyle/>
+          <a:p>
+            <a:pPr algn="ctr"/>
+          </a:p>
+        </p:txBody>
+      </p:sp>
+      <p:sp>
+        <p:nvSpPr>
+          <p:cNvPr id="24" name="TextBox 23"/>
+          <p:cNvSpPr txBox="1"/>
+          <p:nvPr/>
+        </p:nvSpPr>
+        <p:spPr>
+          <a:xfrm>
+            <a:off x="685800" y="5532120"/>
+            <a:ext cx="10835640" cy="411480"/>
+          </a:xfrm>
+          <a:prstGeom prst="rect">
+            <a:avLst/>
+          </a:prstGeom>
+          <a:noFill/>
+        </p:spPr>
+        <p:txBody>
+          <a:bodyPr wrap="square" anchor="t"/>
+          <a:lstStyle/>
+          <a:p>
+            <a:pPr algn="l"/>
+            <a:r>
+              <a:rPr sz="1300" b="1" i="0">
+                <a:solidFill>
+                  <a:srgbClr val="0B1F33"/>
+                </a:solidFill>
+                <a:latin typeface="Segoe UI"/>
+              </a:rPr>
+              <a:t>Pricing today: Free  ·  Next: membership tiers · consulting fees · education fees as active users scale globally</a:t>
+            </a:r>
+          </a:p>
+        </p:txBody>
+      </p:sp>
+      <p:sp>
+        <p:nvSpPr>
+          <p:cNvPr id="25" name="Rectangle 24"/>
           <p:cNvSpPr/>
           <p:nvPr/>
         </p:nvSpPr>
@@ -17015,7 +16917,7 @@
       </p:sp>
       <p:sp>
         <p:nvSpPr>
-          <p:cNvPr id="28" name="Rectangle 27"/>
+          <p:cNvPr id="26" name="Rectangle 25"/>
           <p:cNvSpPr/>
           <p:nvPr/>
         </p:nvSpPr>
@@ -17058,7 +16960,7 @@
       </p:sp>
       <p:sp>
         <p:nvSpPr>
-          <p:cNvPr id="29" name="TextBox 28"/>
+          <p:cNvPr id="27" name="TextBox 26"/>
           <p:cNvSpPr txBox="1"/>
           <p:nvPr/>
         </p:nvSpPr>
@@ -17091,7 +16993,7 @@
       </p:sp>
       <p:sp>
         <p:nvSpPr>
-          <p:cNvPr id="30" name="TextBox 29"/>
+          <p:cNvPr id="28" name="TextBox 27"/>
           <p:cNvSpPr txBox="1"/>
           <p:nvPr/>
         </p:nvSpPr>
@@ -17575,7 +17477,7 @@
                 </a:solidFill>
                 <a:latin typeface="Segoe UI"/>
               </a:rPr>
-              <a:t>A decade of accumulated interview questions, outcome-labeled placement data, and mentor feedback loops — assets that generic models and job boards cannot readily replicate.</a:t>
+              <a:t>100K+ proprietary interview questions and eight years of candidate-prep insight — assets that general-purpose models like ChatGPT or Gemini cannot readily replicate.</a:t>
             </a:r>
           </a:p>
         </p:txBody>
@@ -17764,7 +17666,7 @@
                 </a:solidFill>
                 <a:latin typeface="Segoe UI"/>
               </a:rPr>
-              <a:t>Mock Interviews · Career Advisor · Matching · Screening</a:t>
+              <a:t>Mock Interviews · AI Résumé Builder · Career Advisor · Question Bank</a:t>
             </a:r>
           </a:p>
         </p:txBody>
@@ -18076,7 +17978,7 @@
                 </a:solidFill>
                 <a:latin typeface="Segoe UI"/>
               </a:rPr>
-              <a:t>Proprietary question corpus · Outcome data · Alibaba Cloud</a:t>
+              <a:t>100K+ question corpus · 8-year coaching data · Alibaba Cloud</a:t>
             </a:r>
           </a:p>
         </p:txBody>
@@ -18363,7 +18265,7 @@
                 </a:solidFill>
                 <a:latin typeface="Georgia"/>
               </a:rPr>
-              <a:t>Diversified, Outcome-Aligned Revenue</a:t>
+              <a:t>Free Today — Paid as Users Scale</a:t>
             </a:r>
           </a:p>
         </p:txBody>
@@ -18486,7 +18388,7 @@
                 </a:solidFill>
                 <a:latin typeface="Segoe UI"/>
               </a:rPr>
-              <a:t>01 · CONSUMER PLATFORM</a:t>
+              <a:t>01 · TODAY</a:t>
             </a:r>
           </a:p>
         </p:txBody>
@@ -18519,7 +18421,7 @@
                 </a:solidFill>
                 <a:latin typeface="Georgia"/>
               </a:rPr>
-              <a:t>Subscriptions &amp; Prep</a:t>
+              <a:t>Free Platform</a:t>
             </a:r>
           </a:p>
         </p:txBody>
@@ -18552,7 +18454,7 @@
                 </a:solidFill>
                 <a:latin typeface="Segoe UI"/>
               </a:rPr>
-              <a:t>Self-serve AI interview practice, question banks, and assessments sold as subscriptions and credit packs.</a:t>
+              <a:t>51Careers.AI is free to maximize active users: AI mock interviews, the 100K+ question bank, and the new AI résumé builder.</a:t>
             </a:r>
           </a:p>
         </p:txBody>
@@ -18585,7 +18487,7 @@
                 </a:solidFill>
                 <a:latin typeface="Segoe UI"/>
               </a:rPr>
-              <a:t>Recurring · High margin · Scales globally</a:t>
+              <a:t>Acquire · Engage · Build habit</a:t>
             </a:r>
           </a:p>
         </p:txBody>
@@ -18708,7 +18610,7 @@
                 </a:solidFill>
                 <a:latin typeface="Segoe UI"/>
               </a:rPr>
-              <a:t>02 · PREMIUM SERVICES</a:t>
+              <a:t>02 · NEXT</a:t>
             </a:r>
           </a:p>
         </p:txBody>
@@ -18741,7 +18643,7 @@
                 </a:solidFill>
                 <a:latin typeface="Georgia"/>
               </a:rPr>
-              <a:t>Coaching &amp; Placement</a:t>
+              <a:t>Membership Fees</a:t>
             </a:r>
           </a:p>
         </p:txBody>
@@ -18774,7 +18676,7 @@
                 </a:solidFill>
                 <a:latin typeface="Segoe UI"/>
               </a:rPr>
-              <a:t>Mentor-led programs and outcome-based placement offerings — the Company’s proven, high-ARPU franchise since 2016.</a:t>
+              <a:t>Tiered memberships unlock advanced practice, premium résumé tools, deeper question packs, and progress analytics.</a:t>
             </a:r>
           </a:p>
         </p:txBody>
@@ -18807,7 +18709,7 @@
                 </a:solidFill>
                 <a:latin typeface="Segoe UI"/>
               </a:rPr>
-              <a:t>High ARPU · Proven demand · Cash generative</a:t>
+              <a:t>Recurring · Scalable · Global</a:t>
             </a:r>
           </a:p>
         </p:txBody>
@@ -18930,7 +18832,7 @@
                 </a:solidFill>
                 <a:latin typeface="Segoe UI"/>
               </a:rPr>
-              <a:t>03 · ENTERPRISE &amp; INSTITUTIONS</a:t>
+              <a:t>03 · EXPAND</a:t>
             </a:r>
           </a:p>
         </p:txBody>
@@ -18963,7 +18865,7 @@
                 </a:solidFill>
                 <a:latin typeface="Georgia"/>
               </a:rPr>
-              <a:t>Employer SaaS</a:t>
+              <a:t>Consulting &amp; Education</a:t>
             </a:r>
           </a:p>
         </p:txBody>
@@ -18996,7 +18898,7 @@
                 </a:solidFill>
                 <a:latin typeface="Segoe UI"/>
               </a:rPr>
-              <a:t>AI screening, talent evaluation, and posting optimization for employers; partnerships with universities and institutions.</a:t>
+              <a:t>Higher-ARPU consulting, coaching, and education programs for users who want human guidance and structured career curricula.</a:t>
             </a:r>
           </a:p>
         </p:txBody>
@@ -19029,7 +18931,7 @@
                 </a:solidFill>
                 <a:latin typeface="Segoe UI"/>
               </a:rPr>
-              <a:t>B2B · Land-and-expand · Data flywheel</a:t>
+              <a:t>High ARPU · Proven demand</a:t>
             </a:r>
           </a:p>
         </p:txBody>
@@ -19090,7 +18992,7 @@
         <p:spPr>
           <a:xfrm>
             <a:off x="685800" y="4160520"/>
-            <a:ext cx="4572000" cy="274320"/>
+            <a:ext cx="5486400" cy="274320"/>
           </a:xfrm>
           <a:prstGeom prst="rect">
             <a:avLst/>
@@ -19109,7 +19011,7 @@
                 </a:solidFill>
                 <a:latin typeface="Segoe UI"/>
               </a:rPr>
-              <a:t>Illustrative revenue mix evolution (%)</a:t>
+              <a:t>Illustrative monetization mix once paid conversion begins (%)</a:t>
             </a:r>
           </a:p>
         </p:txBody>
@@ -19140,8 +19042,8 @@
         </p:nvSpPr>
         <p:spPr>
           <a:xfrm>
-            <a:off x="8321040" y="4709160"/>
-            <a:ext cx="3108960" cy="1097280"/>
+            <a:off x="8321040" y="4663440"/>
+            <a:ext cx="3108960" cy="1188720"/>
           </a:xfrm>
           <a:prstGeom prst="rect">
             <a:avLst/>
@@ -19164,7 +19066,7 @@
                 </a:solidFill>
                 <a:latin typeface="Segoe UI"/>
               </a:rPr>
-              <a:t>Model evolution</a:t>
+              <a:t>Path to revenue</a:t>
             </a:r>
           </a:p>
           <a:p>
@@ -19176,7 +19078,7 @@
                 </a:solidFill>
                 <a:latin typeface="Segoe UI"/>
               </a:rPr>
-              <a:t>Services-led today → blended by 2027 → software-led by 2029, expanding gross margin as the platform scales.</a:t>
+              <a:t>Platform revenue is US$0 today. Grow active users on free access, then introduce membership, consulting, and education fees.</a:t>
             </a:r>
           </a:p>
         </p:txBody>
@@ -19463,7 +19365,7 @@
                 </a:solidFill>
                 <a:latin typeface="Georgia"/>
               </a:rPr>
-              <a:t>A Real Business, Not a Concept</a:t>
+              <a:t>Built on Real Candidate Outcomes</a:t>
             </a:r>
           </a:p>
         </p:txBody>
@@ -19537,13 +19439,13 @@
           <a:p>
             <a:pPr algn="l"/>
             <a:r>
-              <a:rPr sz="2600" b="1" i="0">
+              <a:rPr sz="2400" b="1" i="0">
                 <a:solidFill>
                   <a:srgbClr val="0B1F33"/>
                 </a:solidFill>
                 <a:latin typeface="Georgia"/>
               </a:rPr>
-              <a:t>10 yrs</a:t>
+              <a:t>10,000+</a:t>
             </a:r>
           </a:p>
         </p:txBody>
@@ -19576,7 +19478,7 @@
                 </a:solidFill>
                 <a:latin typeface="Segoe UI"/>
               </a:rPr>
-              <a:t>OPERATING HISTORY SINCE 2016</a:t>
+              <a:t>CANDIDATES HELPED · 8 YEARS</a:t>
             </a:r>
           </a:p>
         </p:txBody>
@@ -19650,13 +19552,13 @@
           <a:p>
             <a:pPr algn="l"/>
             <a:r>
-              <a:rPr sz="2600" b="1" i="0">
+              <a:rPr sz="2400" b="1" i="0">
                 <a:solidFill>
                   <a:srgbClr val="0B1F33"/>
                 </a:solidFill>
                 <a:latin typeface="Georgia"/>
               </a:rPr>
-              <a:t>US$10M+</a:t>
+              <a:t>100K+</a:t>
             </a:r>
           </a:p>
         </p:txBody>
@@ -19689,7 +19591,7 @@
                 </a:solidFill>
                 <a:latin typeface="Segoe UI"/>
               </a:rPr>
-              <a:t>ANNUAL REVENUE (2025, EST.)†</a:t>
+              <a:t>MOCK INTERVIEW QUESTIONS</a:t>
             </a:r>
           </a:p>
         </p:txBody>
@@ -19763,13 +19665,13 @@
           <a:p>
             <a:pPr algn="l"/>
             <a:r>
-              <a:rPr sz="2600" b="1" i="0">
+              <a:rPr sz="2400" b="1" i="0">
                 <a:solidFill>
                   <a:srgbClr val="0B1F33"/>
                 </a:solidFill>
                 <a:latin typeface="Georgia"/>
               </a:rPr>
-              <a:t>≈50</a:t>
+              <a:t>2025</a:t>
             </a:r>
           </a:p>
         </p:txBody>
@@ -19802,7 +19704,7 @@
                 </a:solidFill>
                 <a:latin typeface="Segoe UI"/>
               </a:rPr>
-              <a:t>PROFESSIONALS WORLDWIDE†</a:t>
+              <a:t>AI PLATFORM LAUNCH</a:t>
             </a:r>
           </a:p>
         </p:txBody>
@@ -19876,13 +19778,13 @@
           <a:p>
             <a:pPr algn="l"/>
             <a:r>
-              <a:rPr sz="2600" b="1" i="0">
+              <a:rPr sz="2400" b="1" i="0">
                 <a:solidFill>
                   <a:srgbClr val="0B1F33"/>
                 </a:solidFill>
                 <a:latin typeface="Georgia"/>
               </a:rPr>
-              <a:t>8+</a:t>
+              <a:t>US$0</a:t>
             </a:r>
           </a:p>
         </p:txBody>
@@ -19915,7 +19817,7 @@
                 </a:solidFill>
                 <a:latin typeface="Segoe UI"/>
               </a:rPr>
-              <a:t>COUNTRIES OF OPERATION</a:t>
+              <a:t>PLATFORM REVENUE (FREE)</a:t>
             </a:r>
           </a:p>
         </p:txBody>
@@ -20147,7 +20049,7 @@
                 </a:solidFill>
                 <a:latin typeface="Segoe UI"/>
               </a:rPr>
-              <a:t>Founded in New York as a premium career-consulting firm for international students</a:t>
+              <a:t>51 Careers founded — premium career development for global professionals</a:t>
             </a:r>
           </a:p>
         </p:txBody>
@@ -20256,7 +20158,7 @@
                 </a:solidFill>
                 <a:latin typeface="Segoe UI"/>
               </a:rPr>
-              <a:t>Scaled the coaching, referral, and placement franchise across the U.S. and Greater China</a:t>
+              <a:t>Helped 10,000+ candidates; built deep interview &amp; résumé expertise</a:t>
             </a:r>
           </a:p>
         </p:txBody>
@@ -20332,7 +20234,7 @@
                 </a:solidFill>
                 <a:latin typeface="Segoe UI"/>
               </a:rPr>
-              <a:t>Jul 2025</a:t>
+              <a:t>2025</a:t>
             </a:r>
           </a:p>
         </p:txBody>
@@ -20365,7 +20267,7 @@
                 </a:solidFill>
                 <a:latin typeface="Segoe UI"/>
               </a:rPr>
-              <a:t>Strategic AI partnership with Alibaba Cloud (Tongyi LLM, NLP, semantic search)</a:t>
+              <a:t>Launched 51Careers.AI — free AI platform with mock interviews &amp; 100K+ questions</a:t>
             </a:r>
           </a:p>
         </p:txBody>
@@ -20441,7 +20343,7 @@
                 </a:solidFill>
                 <a:latin typeface="Segoe UI"/>
               </a:rPr>
-              <a:t>2025</a:t>
+              <a:t>2025–26</a:t>
             </a:r>
           </a:p>
         </p:txBody>
@@ -20474,7 +20376,7 @@
                 </a:solidFill>
                 <a:latin typeface="Segoe UI"/>
               </a:rPr>
-              <a:t>Launched 51Careers.AI — the Company’s AI-powered global career platform</a:t>
+              <a:t>Developing AI résumé builder; growing active users globally</a:t>
             </a:r>
           </a:p>
         </p:txBody>
@@ -20550,7 +20452,7 @@
                 </a:solidFill>
                 <a:latin typeface="Segoe UI"/>
               </a:rPr>
-              <a:t>2026</a:t>
+              <a:t>Next</a:t>
             </a:r>
           </a:p>
         </p:txBody>
@@ -20583,7 +20485,7 @@
                 </a:solidFill>
                 <a:latin typeface="Segoe UI"/>
               </a:rPr>
-              <a:t>Global platform expansion underway across eight-plus countries</a:t>
+              <a:t>Introduce membership, consulting, and education fees as usage scales</a:t>
             </a:r>
           </a:p>
         </p:txBody>
@@ -20677,7 +20579,7 @@
         <p:spPr>
           <a:xfrm>
             <a:off x="7726679" y="3063240"/>
-            <a:ext cx="3794760" cy="502920"/>
+            <a:ext cx="3794760" cy="548640"/>
           </a:xfrm>
           <a:prstGeom prst="rect">
             <a:avLst/>
@@ -20696,7 +20598,7 @@
                 </a:solidFill>
                 <a:latin typeface="Segoe UI"/>
               </a:rPr>
-              <a:t>▸  Durable, decade-long demand with proven willingness to pay</a:t>
+              <a:t>▸  Eight years of real candidate-prep insight behind the AI product</a:t>
             </a:r>
           </a:p>
         </p:txBody>
@@ -20709,8 +20611,8 @@
         </p:nvSpPr>
         <p:spPr>
           <a:xfrm>
-            <a:off x="7726679" y="3566160"/>
-            <a:ext cx="3794760" cy="502920"/>
+            <a:off x="7726679" y="3657600"/>
+            <a:ext cx="3794760" cy="548640"/>
           </a:xfrm>
           <a:prstGeom prst="rect">
             <a:avLst/>
@@ -20729,7 +20631,7 @@
                 </a:solidFill>
                 <a:latin typeface="Segoe UI"/>
               </a:rPr>
-              <a:t>▸  Cross-border delivery capability that is difficult to replicate</a:t>
+              <a:t>▸  100K+ proprietary questions create a durable data advantage vs. generic LLMs</a:t>
             </a:r>
           </a:p>
         </p:txBody>
@@ -20742,8 +20644,8 @@
         </p:nvSpPr>
         <p:spPr>
           <a:xfrm>
-            <a:off x="7726679" y="4069080"/>
-            <a:ext cx="3794760" cy="502920"/>
+            <a:off x="7726679" y="4251960"/>
+            <a:ext cx="3794760" cy="548640"/>
           </a:xfrm>
           <a:prstGeom prst="rect">
             <a:avLst/>
@@ -20762,7 +20664,7 @@
                 </a:solidFill>
                 <a:latin typeface="Segoe UI"/>
               </a:rPr>
-              <a:t>▸  AI now layers operating leverage onto an established service core</a:t>
+              <a:t>▸  Free launch maximizes global user acquisition before monetization</a:t>
             </a:r>
           </a:p>
         </p:txBody>
@@ -20775,8 +20677,8 @@
         </p:nvSpPr>
         <p:spPr>
           <a:xfrm>
-            <a:off x="7726679" y="4572000"/>
-            <a:ext cx="3794760" cy="502920"/>
+            <a:off x="7726679" y="4846320"/>
+            <a:ext cx="3794760" cy="548640"/>
           </a:xfrm>
           <a:prstGeom prst="rect">
             <a:avLst/>
@@ -20795,7 +20697,7 @@
                 </a:solidFill>
                 <a:latin typeface="Segoe UI"/>
               </a:rPr>
-              <a:t>▸  Existing revenue de-risks the platform transition</a:t>
+              <a:t>▸  Clear path: membership · consulting · education fees</a:t>
             </a:r>
           </a:p>
         </p:txBody>
@@ -20828,7 +20730,7 @@
                 </a:solidFill>
                 <a:latin typeface="Segoe UI"/>
               </a:rPr>
-              <a:t>† Third-party estimates (ZoomInfo; LeadIQ, 2025–26) ranging US$9.7–15M revenue and ≈30–50 staff; to be confirmed in due diligence.</a:t>
+              <a:t>Platform revenue is currently US$0 by design (free access). Candidate totals reflect 51 Careers operating history since 2016.</a:t>
             </a:r>
           </a:p>
         </p:txBody>

</xml_diff>

<commit_message>
Polish deck alignment, chart titles, and layout defects
Fix overlapping market bars, clipped technology bullets, buried architecture
label, duplicate chart titles, empty Launch column, competition branding, and
tighten leadership copy for consistent card alignment.

Co-authored-by: anthonyleedu <anthonyleedu@users.noreply.github.com>
</commit_message>
<xml_diff>
--- a/51Careers_AI_Investor_Presentation.pptx
+++ b/51Careers_AI_Investor_Presentation.pptx
@@ -125,7 +125,7 @@
 <c:chartSpace xmlns:c="http://schemas.openxmlformats.org/drawingml/2006/chart" xmlns:a="http://schemas.openxmlformats.org/drawingml/2006/main" xmlns:r="http://schemas.openxmlformats.org/officeDocument/2006/relationships">
   <c:date1904 val="0"/>
   <c:chart>
-    <c:autoTitleDeleted val="0"/>
+    <c:autoTitleDeleted val="1"/>
     <c:plotArea>
       <c:barChart>
         <c:barDir val="col"/>
@@ -139,7 +139,7 @@
               <c:strCache>
                 <c:ptCount val="1"/>
                 <c:pt idx="0">
-                  <c:v>Global AI hiring &amp; career tech</c:v>
+                  <c:v>Spend</c:v>
                 </c:pt>
               </c:strCache>
             </c:strRef>
@@ -307,7 +307,7 @@
 <c:chartSpace xmlns:c="http://schemas.openxmlformats.org/drawingml/2006/chart" xmlns:a="http://schemas.openxmlformats.org/drawingml/2006/main" xmlns:r="http://schemas.openxmlformats.org/officeDocument/2006/relationships">
   <c:date1904 val="0"/>
   <c:chart>
-    <c:autoTitleDeleted val="0"/>
+    <c:autoTitleDeleted val="1"/>
     <c:plotArea>
       <c:barChart>
         <c:barDir val="col"/>
@@ -338,16 +338,13 @@
           </c:spPr>
           <c:cat>
             <c:strRef>
-              <c:f>Sheet1!$A$2:$A$4</c:f>
+              <c:f>Sheet1!$A$2:$A$3</c:f>
               <c:strCache>
-                <c:ptCount val="3"/>
+                <c:ptCount val="2"/>
                 <c:pt idx="0">
-                  <c:v>Launch</c:v>
+                  <c:v>2027E</c:v>
                 </c:pt>
                 <c:pt idx="1">
-                  <c:v>2027E</c:v>
-                </c:pt>
-                <c:pt idx="2">
                   <c:v>2029E</c:v>
                 </c:pt>
               </c:strCache>
@@ -355,17 +352,14 @@
           </c:cat>
           <c:val>
             <c:numRef>
-              <c:f>Sheet1!$B$2:$B$4</c:f>
+              <c:f>Sheet1!$B$2:$B$3</c:f>
               <c:numCache>
                 <c:formatCode>General</c:formatCode>
-                <c:ptCount val="3"/>
+                <c:ptCount val="2"/>
                 <c:pt idx="0">
-                  <c:v>0</c:v>
+                  <c:v>55</c:v>
                 </c:pt>
                 <c:pt idx="1">
-                  <c:v>55</c:v>
-                </c:pt>
-                <c:pt idx="2">
                   <c:v>50</c:v>
                 </c:pt>
               </c:numCache>
@@ -398,16 +392,13 @@
           </c:spPr>
           <c:cat>
             <c:strRef>
-              <c:f>Sheet1!$A$2:$A$4</c:f>
+              <c:f>Sheet1!$A$2:$A$3</c:f>
               <c:strCache>
-                <c:ptCount val="3"/>
+                <c:ptCount val="2"/>
                 <c:pt idx="0">
-                  <c:v>Launch</c:v>
+                  <c:v>2027E</c:v>
                 </c:pt>
                 <c:pt idx="1">
-                  <c:v>2027E</c:v>
-                </c:pt>
-                <c:pt idx="2">
                   <c:v>2029E</c:v>
                 </c:pt>
               </c:strCache>
@@ -415,17 +406,14 @@
           </c:cat>
           <c:val>
             <c:numRef>
-              <c:f>Sheet1!$C$2:$C$4</c:f>
+              <c:f>Sheet1!$C$2:$C$3</c:f>
               <c:numCache>
                 <c:formatCode>General</c:formatCode>
-                <c:ptCount val="3"/>
+                <c:ptCount val="2"/>
                 <c:pt idx="0">
-                  <c:v>0</c:v>
+                  <c:v>30</c:v>
                 </c:pt>
                 <c:pt idx="1">
-                  <c:v>30</c:v>
-                </c:pt>
-                <c:pt idx="2">
                   <c:v>30</c:v>
                 </c:pt>
               </c:numCache>
@@ -458,16 +446,13 @@
           </c:spPr>
           <c:cat>
             <c:strRef>
-              <c:f>Sheet1!$A$2:$A$4</c:f>
+              <c:f>Sheet1!$A$2:$A$3</c:f>
               <c:strCache>
-                <c:ptCount val="3"/>
+                <c:ptCount val="2"/>
                 <c:pt idx="0">
-                  <c:v>Launch</c:v>
+                  <c:v>2027E</c:v>
                 </c:pt>
                 <c:pt idx="1">
-                  <c:v>2027E</c:v>
-                </c:pt>
-                <c:pt idx="2">
                   <c:v>2029E</c:v>
                 </c:pt>
               </c:strCache>
@@ -475,17 +460,14 @@
           </c:cat>
           <c:val>
             <c:numRef>
-              <c:f>Sheet1!$D$2:$D$4</c:f>
+              <c:f>Sheet1!$D$2:$D$3</c:f>
               <c:numCache>
                 <c:formatCode>General</c:formatCode>
-                <c:ptCount val="3"/>
+                <c:ptCount val="2"/>
                 <c:pt idx="0">
-                  <c:v>0</c:v>
+                  <c:v>15</c:v>
                 </c:pt>
                 <c:pt idx="1">
-                  <c:v>15</c:v>
-                </c:pt>
-                <c:pt idx="2">
                   <c:v>20</c:v>
                 </c:pt>
               </c:numCache>
@@ -616,7 +598,7 @@
 <c:chartSpace xmlns:c="http://schemas.openxmlformats.org/drawingml/2006/chart" xmlns:a="http://schemas.openxmlformats.org/drawingml/2006/main" xmlns:r="http://schemas.openxmlformats.org/officeDocument/2006/relationships">
   <c:date1904 val="0"/>
   <c:chart>
-    <c:autoTitleDeleted val="0"/>
+    <c:autoTitleDeleted val="1"/>
     <c:plotArea>
       <c:barChart>
         <c:barDir val="bar"/>
@@ -630,7 +612,7 @@
               <c:strCache>
                 <c:ptCount val="1"/>
                 <c:pt idx="0">
-                  <c:v>Career AI depth</c:v>
+                  <c:v>Score</c:v>
                 </c:pt>
               </c:strCache>
             </c:strRef>
@@ -798,7 +780,7 @@
 <c:chartSpace xmlns:c="http://schemas.openxmlformats.org/drawingml/2006/chart" xmlns:a="http://schemas.openxmlformats.org/drawingml/2006/main" xmlns:r="http://schemas.openxmlformats.org/officeDocument/2006/relationships">
   <c:date1904 val="0"/>
   <c:chart>
-    <c:autoTitleDeleted val="0"/>
+    <c:autoTitleDeleted val="1"/>
     <c:plotArea>
       <c:lineChart>
         <c:grouping val="standard"/>
@@ -812,7 +794,7 @@
               <c:strCache>
                 <c:ptCount val="1"/>
                 <c:pt idx="0">
-                  <c:v>Active users (index)</c:v>
+                  <c:v>Index</c:v>
                 </c:pt>
               </c:strCache>
             </c:strRef>
@@ -985,7 +967,7 @@
 <c:chartSpace xmlns:c="http://schemas.openxmlformats.org/drawingml/2006/chart" xmlns:a="http://schemas.openxmlformats.org/drawingml/2006/main" xmlns:r="http://schemas.openxmlformats.org/officeDocument/2006/relationships">
   <c:date1904 val="0"/>
   <c:chart>
-    <c:autoTitleDeleted val="0"/>
+    <c:autoTitleDeleted val="1"/>
     <c:plotArea>
       <c:barChart>
         <c:barDir val="col"/>
@@ -999,7 +981,7 @@
               <c:strCache>
                 <c:ptCount val="1"/>
                 <c:pt idx="0">
-                  <c:v>Platform revenue</c:v>
+                  <c:v>Revenue</c:v>
                 </c:pt>
               </c:strCache>
             </c:strRef>
@@ -1167,7 +1149,7 @@
 <c:chartSpace xmlns:c="http://schemas.openxmlformats.org/drawingml/2006/chart" xmlns:a="http://schemas.openxmlformats.org/drawingml/2006/main" xmlns:r="http://schemas.openxmlformats.org/officeDocument/2006/relationships">
   <c:date1904 val="0"/>
   <c:chart>
-    <c:autoTitleDeleted val="0"/>
+    <c:autoTitleDeleted val="1"/>
     <c:plotArea>
       <c:lineChart>
         <c:grouping val="standard"/>
@@ -1181,7 +1163,7 @@
               <c:strCache>
                 <c:ptCount val="1"/>
                 <c:pt idx="0">
-                  <c:v>Paid conversion</c:v>
+                  <c:v>Conversion</c:v>
                 </c:pt>
               </c:strCache>
             </c:strRef>
@@ -1355,7 +1337,7 @@
   <c:date1904 val="0"/>
   <c:roundedCorners val="0"/>
   <c:chart>
-    <c:autoTitleDeleted val="0"/>
+    <c:autoTitleDeleted val="1"/>
     <c:plotArea>
       <c:layout/>
       <c:doughnutChart>
@@ -1369,7 +1351,7 @@
               <c:strCache>
                 <c:ptCount val="1"/>
                 <c:pt idx="0">
-                  <c:v>Use of Proceeds</c:v>
+                  <c:v>Allocation</c:v>
                 </c:pt>
               </c:strCache>
             </c:strRef>
@@ -4760,7 +4742,7 @@
                 </a:solidFill>
                 <a:latin typeface="Segoe UI"/>
               </a:rPr>
-              <a:t>Who we are — An AI career platform from the 51 Careers team: mock interviews, a 100K+ question bank, and a new AI résumé builder — free today, built for global professionals.</a:t>
+              <a:t>Who we are — An AI career platform from the 51Careers team: mock interviews, a 100K+ question bank, and a new AI résumé builder — free today, built for global professionals.</a:t>
             </a:r>
           </a:p>
         </p:txBody>
@@ -5636,7 +5618,7 @@
                           </a:solidFill>
                           <a:latin typeface="Segoe UI"/>
                         </a:rPr>
-                        <a:t>51Careers</a:t>
+                        <a:t>51Careers.AI</a:t>
                       </a:r>
                     </a:p>
                   </a:txBody>
@@ -7673,8 +7655,8 @@
         </p:nvSpPr>
         <p:spPr>
           <a:xfrm>
-            <a:off x="685800" y="4846320"/>
-            <a:ext cx="4114800" cy="256032"/>
+            <a:off x="685800" y="4828032"/>
+            <a:ext cx="10789920" cy="228600"/>
           </a:xfrm>
           <a:prstGeom prst="rect">
             <a:avLst/>
@@ -7707,8 +7689,8 @@
           <p:nvPr/>
         </p:nvGraphicFramePr>
         <p:xfrm>
-          <a:off x="4572000" y="4709160"/>
-          <a:ext cx="6949440" cy="1143000"/>
+          <a:off x="640080" y="4937760"/>
+          <a:ext cx="10881360" cy="868680"/>
         </p:xfrm>
         <a:graphic>
           <a:graphicData uri="http://schemas.openxmlformats.org/drawingml/2006/chart">
@@ -10180,7 +10162,7 @@
                 </a:solidFill>
                 <a:latin typeface="Segoe UI"/>
               </a:rPr>
-              <a:t>▸  Founder of 51 Careers and 51Careers.AI; investor &amp; Managing Director at publicly listed Helio</a:t>
+              <a:t>▸  Founder of 51Careers and 51Careers.AI; investor &amp; Managing Director at publicly listed Helio</a:t>
             </a:r>
           </a:p>
         </p:txBody>
@@ -10213,7 +10195,7 @@
                 </a:solidFill>
                 <a:latin typeface="Segoe UI"/>
               </a:rPr>
-              <a:t>▸  Decade of international business, capital markets, and global resource integration across AI, education, and related industries</a:t>
+              <a:t>▸  Decade of international business, capital markets, and global resource integration</a:t>
             </a:r>
           </a:p>
         </p:txBody>
@@ -10402,7 +10384,7 @@
                 </a:solidFill>
                 <a:latin typeface="Segoe UI"/>
               </a:rPr>
-              <a:t>▸  Co-Founder since 2016; U.S. CPA — M.S. Accounting (Pace); B.A. Accounting (Dongbei University of Finance and Economics)</a:t>
+              <a:t>▸  Co-Founder since 2016; U.S. CPA — M.S. Accounting (Pace University)</a:t>
             </a:r>
           </a:p>
         </p:txBody>
@@ -10435,7 +10417,7 @@
                 </a:solidFill>
                 <a:latin typeface="Segoe UI"/>
               </a:rPr>
-              <a:t>▸  Oversees financial strategy, corporate governance, and sustainable growth; prior senior finance leadership in U.S. industry</a:t>
+              <a:t>▸  Oversees financial strategy, corporate governance, and sustainable growth</a:t>
             </a:r>
           </a:p>
         </p:txBody>
@@ -10624,7 +10606,7 @@
                 </a:solidFill>
                 <a:latin typeface="Segoe UI"/>
               </a:rPr>
-              <a:t>▸  Serial entrepreneur (10+ yrs) across SaaS, AI, and digital business; B.S. Computer Science, ECUST</a:t>
+              <a:t>▸  Serial entrepreneur (10+ yrs) across SaaS, AI, and digital business; B.S. CS, ECUST</a:t>
             </a:r>
           </a:p>
         </p:txBody>
@@ -10657,7 +10639,7 @@
                 </a:solidFill>
                 <a:latin typeface="Segoe UI"/>
               </a:rPr>
-              <a:t>▸  Prior CTO roles (Youpindao, Roubeibei) and multiple co-founded ventures; leads technology, operations, and AI strategy</a:t>
+              <a:t>▸  Prior CTO roles and multiple co-founded ventures; leads technology, operations, and AI</a:t>
             </a:r>
           </a:p>
         </p:txBody>
@@ -10879,7 +10861,7 @@
                 </a:solidFill>
                 <a:latin typeface="Segoe UI"/>
               </a:rPr>
-              <a:t>▸  Former CTO &amp; Director of Product, Ci Finance; senior product/tech roles at CPIC, Allinpay, Noah Holdings, and Tianrang Intelligence</a:t>
+              <a:t>▸  Former CTO &amp; Director of Product, Ci Finance; senior roles at CPIC, Allinpay, Noah</a:t>
             </a:r>
           </a:p>
         </p:txBody>
@@ -11068,7 +11050,7 @@
                 </a:solidFill>
                 <a:latin typeface="Segoe UI"/>
               </a:rPr>
-              <a:t>▸  Full-stack engineer; previously at Amazon Web Services (AWS) on mission-critical systems</a:t>
+              <a:t>▸  Full-stack engineer; previously at Amazon Web Services (AWS)</a:t>
             </a:r>
           </a:p>
         </p:txBody>
@@ -11101,7 +11083,7 @@
                 </a:solidFill>
                 <a:latin typeface="Segoe UI"/>
               </a:rPr>
-              <a:t>▸  B.S. Mechanical Engineering (Northwestern), M.S. Robotics; extensive hiring-panel experience and career mentorship</a:t>
+              <a:t>▸  B.S. Northwestern, M.S. Robotics; extensive hiring-panel experience and mentorship</a:t>
             </a:r>
           </a:p>
         </p:txBody>
@@ -11290,7 +11272,7 @@
                 </a:solidFill>
                 <a:latin typeface="Segoe UI"/>
               </a:rPr>
-              <a:t>▸  Harvard &amp; MIT; former senior executive at Morgan Stanley; founder of Cedar (Wall Street investment banking)</a:t>
+              <a:t>▸  Harvard &amp; MIT; former senior executive at Morgan Stanley; founder of Cedar</a:t>
             </a:r>
           </a:p>
         </p:txBody>
@@ -11323,7 +11305,7 @@
                 </a:solidFill>
                 <a:latin typeface="Segoe UI"/>
               </a:rPr>
-              <a:t>▸  40+ years advising tech M&amp;A, capital raising, and listings; advises 51Careers.AI on growth, capital markets, and expansion</a:t>
+              <a:t>▸  40+ years in tech M&amp;A and capital raising; advises on growth and expansion</a:t>
             </a:r>
           </a:p>
         </p:txBody>
@@ -12544,7 +12526,7 @@
                 </a:solidFill>
                 <a:latin typeface="Segoe UI"/>
               </a:rPr>
-              <a:t>51Careers.AI is the AI-powered career platform from the 51 Careers team — helping professionals worldwide prepare, apply, and compete for great jobs.</a:t>
+              <a:t>51Careers.AI is the AI-powered career platform from the 51Careers team — helping professionals worldwide prepare, apply, and compete for great jobs.</a:t>
             </a:r>
           </a:p>
         </p:txBody>
@@ -15113,8 +15095,8 @@
         </p:nvSpPr>
         <p:spPr>
           <a:xfrm>
-            <a:off x="502920" y="1234440"/>
-            <a:ext cx="5852160" cy="1234440"/>
+            <a:off x="502920" y="1207008"/>
+            <a:ext cx="5852160" cy="1353312"/>
           </a:xfrm>
           <a:prstGeom prst="roundRect">
             <a:avLst>
@@ -15154,14 +15136,113 @@
       </p:sp>
       <p:sp>
         <p:nvSpPr>
-          <p:cNvPr id="6" name="Rectangle 5"/>
+          <p:cNvPr id="6" name="TextBox 5"/>
+          <p:cNvSpPr txBox="1"/>
+          <p:nvPr/>
+        </p:nvSpPr>
+        <p:spPr>
+          <a:xfrm>
+            <a:off x="685800" y="1316736"/>
+            <a:ext cx="5394960" cy="201168"/>
+          </a:xfrm>
+          <a:prstGeom prst="rect">
+            <a:avLst/>
+          </a:prstGeom>
+          <a:noFill/>
+        </p:spPr>
+        <p:txBody>
+          <a:bodyPr wrap="square" anchor="t"/>
+          <a:lstStyle/>
+          <a:p>
+            <a:pPr algn="l"/>
+            <a:r>
+              <a:rPr sz="900" b="1" i="0">
+                <a:solidFill>
+                  <a:srgbClr val="5E6E80"/>
+                </a:solidFill>
+                <a:latin typeface="Segoe UI"/>
+              </a:rPr>
+              <a:t>TOTAL ADDRESSABLE MARKET</a:t>
+            </a:r>
+          </a:p>
+        </p:txBody>
+      </p:sp>
+      <p:sp>
+        <p:nvSpPr>
+          <p:cNvPr id="7" name="TextBox 6"/>
+          <p:cNvSpPr txBox="1"/>
+          <p:nvPr/>
+        </p:nvSpPr>
+        <p:spPr>
+          <a:xfrm>
+            <a:off x="685800" y="1536192"/>
+            <a:ext cx="5394960" cy="365760"/>
+          </a:xfrm>
+          <a:prstGeom prst="rect">
+            <a:avLst/>
+          </a:prstGeom>
+          <a:noFill/>
+        </p:spPr>
+        <p:txBody>
+          <a:bodyPr wrap="square" anchor="t"/>
+          <a:lstStyle/>
+          <a:p>
+            <a:pPr algn="l"/>
+            <a:r>
+              <a:rPr sz="2600" b="1" i="0">
+                <a:solidFill>
+                  <a:srgbClr val="0B1F33"/>
+                </a:solidFill>
+                <a:latin typeface="Georgia"/>
+              </a:rPr>
+              <a:t>US$200B+</a:t>
+            </a:r>
+          </a:p>
+        </p:txBody>
+      </p:sp>
+      <p:sp>
+        <p:nvSpPr>
+          <p:cNvPr id="8" name="TextBox 7"/>
+          <p:cNvSpPr txBox="1"/>
+          <p:nvPr/>
+        </p:nvSpPr>
+        <p:spPr>
+          <a:xfrm>
+            <a:off x="685800" y="1956816"/>
+            <a:ext cx="5394960" cy="320040"/>
+          </a:xfrm>
+          <a:prstGeom prst="rect">
+            <a:avLst/>
+          </a:prstGeom>
+          <a:noFill/>
+        </p:spPr>
+        <p:txBody>
+          <a:bodyPr wrap="square" anchor="t"/>
+          <a:lstStyle/>
+          <a:p>
+            <a:pPr algn="l"/>
+            <a:r>
+              <a:rPr sz="1100" b="0" i="0">
+                <a:solidFill>
+                  <a:srgbClr val="2C3A4B"/>
+                </a:solidFill>
+                <a:latin typeface="Segoe UI"/>
+              </a:rPr>
+              <a:t>Global recruitment, talent-acquisition, and career-development spend worldwide.</a:t>
+            </a:r>
+          </a:p>
+        </p:txBody>
+      </p:sp>
+      <p:sp>
+        <p:nvSpPr>
+          <p:cNvPr id="9" name="Rectangle 8"/>
           <p:cNvSpPr/>
           <p:nvPr/>
         </p:nvSpPr>
         <p:spPr>
           <a:xfrm>
-            <a:off x="685800" y="2148840"/>
-            <a:ext cx="5394960" cy="146304"/>
+            <a:off x="685800" y="2322576"/>
+            <a:ext cx="5394960" cy="128016"/>
           </a:xfrm>
           <a:prstGeom prst="rect">
             <a:avLst/>
@@ -15197,113 +15278,14 @@
       </p:sp>
       <p:sp>
         <p:nvSpPr>
-          <p:cNvPr id="7" name="TextBox 6"/>
-          <p:cNvSpPr txBox="1"/>
-          <p:nvPr/>
-        </p:nvSpPr>
-        <p:spPr>
-          <a:xfrm>
-            <a:off x="685800" y="1344168"/>
-            <a:ext cx="5394960" cy="228600"/>
-          </a:xfrm>
-          <a:prstGeom prst="rect">
-            <a:avLst/>
-          </a:prstGeom>
-          <a:noFill/>
-        </p:spPr>
-        <p:txBody>
-          <a:bodyPr wrap="square" anchor="t"/>
-          <a:lstStyle/>
-          <a:p>
-            <a:pPr algn="l"/>
-            <a:r>
-              <a:rPr sz="900" b="1" i="0">
-                <a:solidFill>
-                  <a:srgbClr val="5E6E80"/>
-                </a:solidFill>
-                <a:latin typeface="Segoe UI"/>
-              </a:rPr>
-              <a:t>TOTAL ADDRESSABLE MARKET</a:t>
-            </a:r>
-          </a:p>
-        </p:txBody>
-      </p:sp>
-      <p:sp>
-        <p:nvSpPr>
-          <p:cNvPr id="8" name="TextBox 7"/>
-          <p:cNvSpPr txBox="1"/>
-          <p:nvPr/>
-        </p:nvSpPr>
-        <p:spPr>
-          <a:xfrm>
-            <a:off x="685800" y="1554480"/>
-            <a:ext cx="5394960" cy="365760"/>
-          </a:xfrm>
-          <a:prstGeom prst="rect">
-            <a:avLst/>
-          </a:prstGeom>
-          <a:noFill/>
-        </p:spPr>
-        <p:txBody>
-          <a:bodyPr wrap="square" anchor="t"/>
-          <a:lstStyle/>
-          <a:p>
-            <a:pPr algn="l"/>
-            <a:r>
-              <a:rPr sz="2600" b="1" i="0">
-                <a:solidFill>
-                  <a:srgbClr val="0B1F33"/>
-                </a:solidFill>
-                <a:latin typeface="Georgia"/>
-              </a:rPr>
-              <a:t>US$200B+</a:t>
-            </a:r>
-          </a:p>
-        </p:txBody>
-      </p:sp>
-      <p:sp>
-        <p:nvSpPr>
-          <p:cNvPr id="9" name="TextBox 8"/>
-          <p:cNvSpPr txBox="1"/>
-          <p:nvPr/>
-        </p:nvSpPr>
-        <p:spPr>
-          <a:xfrm>
-            <a:off x="685800" y="1892808"/>
-            <a:ext cx="5394960" cy="256032"/>
-          </a:xfrm>
-          <a:prstGeom prst="rect">
-            <a:avLst/>
-          </a:prstGeom>
-          <a:noFill/>
-        </p:spPr>
-        <p:txBody>
-          <a:bodyPr wrap="square" anchor="t"/>
-          <a:lstStyle/>
-          <a:p>
-            <a:pPr algn="l"/>
-            <a:r>
-              <a:rPr sz="1000" b="0" i="0">
-                <a:solidFill>
-                  <a:srgbClr val="2C3A4B"/>
-                </a:solidFill>
-                <a:latin typeface="Segoe UI"/>
-              </a:rPr>
-              <a:t>Global recruitment, talent-acquisition, and career-development spend worldwide.</a:t>
-            </a:r>
-          </a:p>
-        </p:txBody>
-      </p:sp>
-      <p:sp>
-        <p:nvSpPr>
           <p:cNvPr id="10" name="Rounded Rectangle 9"/>
           <p:cNvSpPr/>
           <p:nvPr/>
         </p:nvSpPr>
         <p:spPr>
           <a:xfrm>
-            <a:off x="502920" y="2606040"/>
-            <a:ext cx="5852160" cy="1234440"/>
+            <a:off x="502920" y="2651760"/>
+            <a:ext cx="5852160" cy="1353312"/>
           </a:xfrm>
           <a:prstGeom prst="roundRect">
             <a:avLst>
@@ -15343,14 +15325,113 @@
       </p:sp>
       <p:sp>
         <p:nvSpPr>
-          <p:cNvPr id="11" name="Rectangle 10"/>
+          <p:cNvPr id="11" name="TextBox 10"/>
+          <p:cNvSpPr txBox="1"/>
+          <p:nvPr/>
+        </p:nvSpPr>
+        <p:spPr>
+          <a:xfrm>
+            <a:off x="685800" y="2761488"/>
+            <a:ext cx="5394960" cy="201168"/>
+          </a:xfrm>
+          <a:prstGeom prst="rect">
+            <a:avLst/>
+          </a:prstGeom>
+          <a:noFill/>
+        </p:spPr>
+        <p:txBody>
+          <a:bodyPr wrap="square" anchor="t"/>
+          <a:lstStyle/>
+          <a:p>
+            <a:pPr algn="l"/>
+            <a:r>
+              <a:rPr sz="900" b="1" i="0">
+                <a:solidFill>
+                  <a:srgbClr val="5E6E80"/>
+                </a:solidFill>
+                <a:latin typeface="Segoe UI"/>
+              </a:rPr>
+              <a:t>SERVICEABLE MARKET</a:t>
+            </a:r>
+          </a:p>
+        </p:txBody>
+      </p:sp>
+      <p:sp>
+        <p:nvSpPr>
+          <p:cNvPr id="12" name="TextBox 11"/>
+          <p:cNvSpPr txBox="1"/>
+          <p:nvPr/>
+        </p:nvSpPr>
+        <p:spPr>
+          <a:xfrm>
+            <a:off x="685800" y="2980944"/>
+            <a:ext cx="5394960" cy="365760"/>
+          </a:xfrm>
+          <a:prstGeom prst="rect">
+            <a:avLst/>
+          </a:prstGeom>
+          <a:noFill/>
+        </p:spPr>
+        <p:txBody>
+          <a:bodyPr wrap="square" anchor="t"/>
+          <a:lstStyle/>
+          <a:p>
+            <a:pPr algn="l"/>
+            <a:r>
+              <a:rPr sz="2600" b="1" i="0">
+                <a:solidFill>
+                  <a:srgbClr val="0B1F33"/>
+                </a:solidFill>
+                <a:latin typeface="Georgia"/>
+              </a:rPr>
+              <a:t>US$30B+</a:t>
+            </a:r>
+          </a:p>
+        </p:txBody>
+      </p:sp>
+      <p:sp>
+        <p:nvSpPr>
+          <p:cNvPr id="13" name="TextBox 12"/>
+          <p:cNvSpPr txBox="1"/>
+          <p:nvPr/>
+        </p:nvSpPr>
+        <p:spPr>
+          <a:xfrm>
+            <a:off x="685800" y="3401568"/>
+            <a:ext cx="5394960" cy="320040"/>
+          </a:xfrm>
+          <a:prstGeom prst="rect">
+            <a:avLst/>
+          </a:prstGeom>
+          <a:noFill/>
+        </p:spPr>
+        <p:txBody>
+          <a:bodyPr wrap="square" anchor="t"/>
+          <a:lstStyle/>
+          <a:p>
+            <a:pPr algn="l"/>
+            <a:r>
+              <a:rPr sz="1100" b="0" i="0">
+                <a:solidFill>
+                  <a:srgbClr val="2C3A4B"/>
+                </a:solidFill>
+                <a:latin typeface="Segoe UI"/>
+              </a:rPr>
+              <a:t>Global AI-enabled hiring technology and digital career preparation.</a:t>
+            </a:r>
+          </a:p>
+        </p:txBody>
+      </p:sp>
+      <p:sp>
+        <p:nvSpPr>
+          <p:cNvPr id="14" name="Rectangle 13"/>
           <p:cNvSpPr/>
           <p:nvPr/>
         </p:nvSpPr>
         <p:spPr>
           <a:xfrm>
-            <a:off x="685800" y="3520440"/>
-            <a:ext cx="2967228" cy="146304"/>
+            <a:off x="685800" y="3767328"/>
+            <a:ext cx="3129076" cy="128016"/>
           </a:xfrm>
           <a:prstGeom prst="rect">
             <a:avLst/>
@@ -15386,113 +15467,14 @@
       </p:sp>
       <p:sp>
         <p:nvSpPr>
-          <p:cNvPr id="12" name="TextBox 11"/>
-          <p:cNvSpPr txBox="1"/>
-          <p:nvPr/>
-        </p:nvSpPr>
-        <p:spPr>
-          <a:xfrm>
-            <a:off x="685800" y="2715768"/>
-            <a:ext cx="5394960" cy="228600"/>
-          </a:xfrm>
-          <a:prstGeom prst="rect">
-            <a:avLst/>
-          </a:prstGeom>
-          <a:noFill/>
-        </p:spPr>
-        <p:txBody>
-          <a:bodyPr wrap="square" anchor="t"/>
-          <a:lstStyle/>
-          <a:p>
-            <a:pPr algn="l"/>
-            <a:r>
-              <a:rPr sz="900" b="1" i="0">
-                <a:solidFill>
-                  <a:srgbClr val="5E6E80"/>
-                </a:solidFill>
-                <a:latin typeface="Segoe UI"/>
-              </a:rPr>
-              <a:t>SERVICEABLE MARKET</a:t>
-            </a:r>
-          </a:p>
-        </p:txBody>
-      </p:sp>
-      <p:sp>
-        <p:nvSpPr>
-          <p:cNvPr id="13" name="TextBox 12"/>
-          <p:cNvSpPr txBox="1"/>
-          <p:nvPr/>
-        </p:nvSpPr>
-        <p:spPr>
-          <a:xfrm>
-            <a:off x="685800" y="2926080"/>
-            <a:ext cx="5394960" cy="365760"/>
-          </a:xfrm>
-          <a:prstGeom prst="rect">
-            <a:avLst/>
-          </a:prstGeom>
-          <a:noFill/>
-        </p:spPr>
-        <p:txBody>
-          <a:bodyPr wrap="square" anchor="t"/>
-          <a:lstStyle/>
-          <a:p>
-            <a:pPr algn="l"/>
-            <a:r>
-              <a:rPr sz="2600" b="1" i="0">
-                <a:solidFill>
-                  <a:srgbClr val="0B1F33"/>
-                </a:solidFill>
-                <a:latin typeface="Georgia"/>
-              </a:rPr>
-              <a:t>US$30B+</a:t>
-            </a:r>
-          </a:p>
-        </p:txBody>
-      </p:sp>
-      <p:sp>
-        <p:nvSpPr>
-          <p:cNvPr id="14" name="TextBox 13"/>
-          <p:cNvSpPr txBox="1"/>
-          <p:nvPr/>
-        </p:nvSpPr>
-        <p:spPr>
-          <a:xfrm>
-            <a:off x="685800" y="3264408"/>
-            <a:ext cx="5394960" cy="256032"/>
-          </a:xfrm>
-          <a:prstGeom prst="rect">
-            <a:avLst/>
-          </a:prstGeom>
-          <a:noFill/>
-        </p:spPr>
-        <p:txBody>
-          <a:bodyPr wrap="square" anchor="t"/>
-          <a:lstStyle/>
-          <a:p>
-            <a:pPr algn="l"/>
-            <a:r>
-              <a:rPr sz="1000" b="0" i="0">
-                <a:solidFill>
-                  <a:srgbClr val="2C3A4B"/>
-                </a:solidFill>
-                <a:latin typeface="Segoe UI"/>
-              </a:rPr>
-              <a:t>Global AI-enabled hiring technology and digital career preparation.</a:t>
-            </a:r>
-          </a:p>
-        </p:txBody>
-      </p:sp>
-      <p:sp>
-        <p:nvSpPr>
           <p:cNvPr id="15" name="Rounded Rectangle 14"/>
           <p:cNvSpPr/>
           <p:nvPr/>
         </p:nvSpPr>
         <p:spPr>
           <a:xfrm>
-            <a:off x="502920" y="3977639"/>
-            <a:ext cx="5852160" cy="1234440"/>
+            <a:off x="502920" y="4096512"/>
+            <a:ext cx="5852160" cy="1353312"/>
           </a:xfrm>
           <a:prstGeom prst="roundRect">
             <a:avLst>
@@ -15532,14 +15514,113 @@
       </p:sp>
       <p:sp>
         <p:nvSpPr>
-          <p:cNvPr id="16" name="Rectangle 15"/>
+          <p:cNvPr id="16" name="TextBox 15"/>
+          <p:cNvSpPr txBox="1"/>
+          <p:nvPr/>
+        </p:nvSpPr>
+        <p:spPr>
+          <a:xfrm>
+            <a:off x="685800" y="4206240"/>
+            <a:ext cx="5394960" cy="201168"/>
+          </a:xfrm>
+          <a:prstGeom prst="rect">
+            <a:avLst/>
+          </a:prstGeom>
+          <a:noFill/>
+        </p:spPr>
+        <p:txBody>
+          <a:bodyPr wrap="square" anchor="t"/>
+          <a:lstStyle/>
+          <a:p>
+            <a:pPr algn="l"/>
+            <a:r>
+              <a:rPr sz="900" b="1" i="0">
+                <a:solidFill>
+                  <a:srgbClr val="5E6E80"/>
+                </a:solidFill>
+                <a:latin typeface="Segoe UI"/>
+              </a:rPr>
+              <a:t>NEAR-TERM FOCUS</a:t>
+            </a:r>
+          </a:p>
+        </p:txBody>
+      </p:sp>
+      <p:sp>
+        <p:nvSpPr>
+          <p:cNvPr id="17" name="TextBox 16"/>
+          <p:cNvSpPr txBox="1"/>
+          <p:nvPr/>
+        </p:nvSpPr>
+        <p:spPr>
+          <a:xfrm>
+            <a:off x="685800" y="4425696"/>
+            <a:ext cx="5394960" cy="365760"/>
+          </a:xfrm>
+          <a:prstGeom prst="rect">
+            <a:avLst/>
+          </a:prstGeom>
+          <a:noFill/>
+        </p:spPr>
+        <p:txBody>
+          <a:bodyPr wrap="square" anchor="t"/>
+          <a:lstStyle/>
+          <a:p>
+            <a:pPr algn="l"/>
+            <a:r>
+              <a:rPr sz="2600" b="1" i="0">
+                <a:solidFill>
+                  <a:srgbClr val="0B1F33"/>
+                </a:solidFill>
+                <a:latin typeface="Georgia"/>
+              </a:rPr>
+              <a:t>US$5B+</a:t>
+            </a:r>
+          </a:p>
+        </p:txBody>
+      </p:sp>
+      <p:sp>
+        <p:nvSpPr>
+          <p:cNvPr id="18" name="TextBox 17"/>
+          <p:cNvSpPr txBox="1"/>
+          <p:nvPr/>
+        </p:nvSpPr>
+        <p:spPr>
+          <a:xfrm>
+            <a:off x="685800" y="4846320"/>
+            <a:ext cx="5394960" cy="320040"/>
+          </a:xfrm>
+          <a:prstGeom prst="rect">
+            <a:avLst/>
+          </a:prstGeom>
+          <a:noFill/>
+        </p:spPr>
+        <p:txBody>
+          <a:bodyPr wrap="square" anchor="t"/>
+          <a:lstStyle/>
+          <a:p>
+            <a:pPr algn="l"/>
+            <a:r>
+              <a:rPr sz="1100" b="0" i="0">
+                <a:solidFill>
+                  <a:srgbClr val="2C3A4B"/>
+                </a:solidFill>
+                <a:latin typeface="Segoe UI"/>
+              </a:rPr>
+              <a:t>Global professionals seeking AI prep, résumés, and interview readiness.</a:t>
+            </a:r>
+          </a:p>
+        </p:txBody>
+      </p:sp>
+      <p:sp>
+        <p:nvSpPr>
+          <p:cNvPr id="19" name="Rectangle 18"/>
           <p:cNvSpPr/>
           <p:nvPr/>
         </p:nvSpPr>
         <p:spPr>
           <a:xfrm>
-            <a:off x="685800" y="4892040"/>
-            <a:ext cx="1726387" cy="146304"/>
+            <a:off x="685800" y="5212080"/>
+            <a:ext cx="1834286" cy="128016"/>
           </a:xfrm>
           <a:prstGeom prst="rect">
             <a:avLst/>
@@ -15575,113 +15656,14 @@
       </p:sp>
       <p:sp>
         <p:nvSpPr>
-          <p:cNvPr id="17" name="TextBox 16"/>
-          <p:cNvSpPr txBox="1"/>
-          <p:nvPr/>
-        </p:nvSpPr>
-        <p:spPr>
-          <a:xfrm>
-            <a:off x="685800" y="4087368"/>
-            <a:ext cx="5394960" cy="228600"/>
-          </a:xfrm>
-          <a:prstGeom prst="rect">
-            <a:avLst/>
-          </a:prstGeom>
-          <a:noFill/>
-        </p:spPr>
-        <p:txBody>
-          <a:bodyPr wrap="square" anchor="t"/>
-          <a:lstStyle/>
-          <a:p>
-            <a:pPr algn="l"/>
-            <a:r>
-              <a:rPr sz="900" b="1" i="0">
-                <a:solidFill>
-                  <a:srgbClr val="5E6E80"/>
-                </a:solidFill>
-                <a:latin typeface="Segoe UI"/>
-              </a:rPr>
-              <a:t>NEAR-TERM FOCUS</a:t>
-            </a:r>
-          </a:p>
-        </p:txBody>
-      </p:sp>
-      <p:sp>
-        <p:nvSpPr>
-          <p:cNvPr id="18" name="TextBox 17"/>
-          <p:cNvSpPr txBox="1"/>
-          <p:nvPr/>
-        </p:nvSpPr>
-        <p:spPr>
-          <a:xfrm>
-            <a:off x="685800" y="4297679"/>
-            <a:ext cx="5394960" cy="365760"/>
-          </a:xfrm>
-          <a:prstGeom prst="rect">
-            <a:avLst/>
-          </a:prstGeom>
-          <a:noFill/>
-        </p:spPr>
-        <p:txBody>
-          <a:bodyPr wrap="square" anchor="t"/>
-          <a:lstStyle/>
-          <a:p>
-            <a:pPr algn="l"/>
-            <a:r>
-              <a:rPr sz="2600" b="1" i="0">
-                <a:solidFill>
-                  <a:srgbClr val="0B1F33"/>
-                </a:solidFill>
-                <a:latin typeface="Georgia"/>
-              </a:rPr>
-              <a:t>US$5B+</a:t>
-            </a:r>
-          </a:p>
-        </p:txBody>
-      </p:sp>
-      <p:sp>
-        <p:nvSpPr>
-          <p:cNvPr id="19" name="TextBox 18"/>
-          <p:cNvSpPr txBox="1"/>
-          <p:nvPr/>
-        </p:nvSpPr>
-        <p:spPr>
-          <a:xfrm>
-            <a:off x="685800" y="4636007"/>
-            <a:ext cx="5394960" cy="256032"/>
-          </a:xfrm>
-          <a:prstGeom prst="rect">
-            <a:avLst/>
-          </a:prstGeom>
-          <a:noFill/>
-        </p:spPr>
-        <p:txBody>
-          <a:bodyPr wrap="square" anchor="t"/>
-          <a:lstStyle/>
-          <a:p>
-            <a:pPr algn="l"/>
-            <a:r>
-              <a:rPr sz="1000" b="0" i="0">
-                <a:solidFill>
-                  <a:srgbClr val="2C3A4B"/>
-                </a:solidFill>
-                <a:latin typeface="Segoe UI"/>
-              </a:rPr>
-              <a:t>Global early-career and mid-career professionals seeking AI prep, résumés, and interview readiness.</a:t>
-            </a:r>
-          </a:p>
-        </p:txBody>
-      </p:sp>
-      <p:sp>
-        <p:nvSpPr>
           <p:cNvPr id="20" name="Rounded Rectangle 19"/>
           <p:cNvSpPr/>
           <p:nvPr/>
         </p:nvSpPr>
         <p:spPr>
           <a:xfrm>
-            <a:off x="6537960" y="1234440"/>
-            <a:ext cx="5120640" cy="4160520"/>
+            <a:off x="6537960" y="1207008"/>
+            <a:ext cx="5120640" cy="4315968"/>
           </a:xfrm>
           <a:prstGeom prst="roundRect">
             <a:avLst>
@@ -15727,8 +15709,8 @@
         </p:nvSpPr>
         <p:spPr>
           <a:xfrm>
-            <a:off x="6720840" y="1371600"/>
-            <a:ext cx="4754880" cy="320040"/>
+            <a:off x="6720840" y="1325880"/>
+            <a:ext cx="4754880" cy="274320"/>
           </a:xfrm>
           <a:prstGeom prst="rect">
             <a:avLst/>
@@ -15761,8 +15743,8 @@
           <p:nvPr/>
         </p:nvGraphicFramePr>
         <p:xfrm>
-          <a:off x="6629400" y="1737360"/>
-          <a:ext cx="4892040" cy="3383280"/>
+          <a:off x="6629400" y="1691640"/>
+          <a:ext cx="4892040" cy="3611880"/>
         </p:xfrm>
         <a:graphic>
           <a:graphicData uri="http://schemas.openxmlformats.org/drawingml/2006/chart">
@@ -16442,7 +16424,7 @@
                 </a:solidFill>
                 <a:latin typeface="Georgia"/>
               </a:rPr>
-              <a:t>100K+ Question Database</a:t>
+              <a:t>100K+ Question Bank</a:t>
             </a:r>
           </a:p>
         </p:txBody>
@@ -17167,8 +17149,8 @@
         </p:nvSpPr>
         <p:spPr>
           <a:xfrm>
-            <a:off x="502920" y="1234440"/>
-            <a:ext cx="6766560" cy="2331720"/>
+            <a:off x="502920" y="1170432"/>
+            <a:ext cx="6766560" cy="2468880"/>
           </a:xfrm>
           <a:prstGeom prst="roundRect">
             <a:avLst>
@@ -17214,8 +17196,8 @@
         </p:nvSpPr>
         <p:spPr>
           <a:xfrm>
-            <a:off x="731520" y="1371600"/>
-            <a:ext cx="6400800" cy="320040"/>
+            <a:off x="731520" y="1280160"/>
+            <a:ext cx="6400800" cy="292608"/>
           </a:xfrm>
           <a:prstGeom prst="rect">
             <a:avLst/>
@@ -17247,8 +17229,8 @@
         </p:nvSpPr>
         <p:spPr>
           <a:xfrm>
-            <a:off x="731520" y="1783080"/>
-            <a:ext cx="6309360" cy="1005840"/>
+            <a:off x="731520" y="1645920"/>
+            <a:ext cx="6309360" cy="868680"/>
           </a:xfrm>
           <a:prstGeom prst="rect">
             <a:avLst/>
@@ -17267,7 +17249,7 @@
                 </a:solidFill>
                 <a:latin typeface="Segoe UI"/>
               </a:rPr>
-              <a:t>A deep collaboration integrating frontier AI capability across the platform — the Tongyi large language model, natural-language processing, LLM inference, intelligent recommendation, and semantic search — on enterprise-grade compute and security infrastructure.</a:t>
+              <a:t>A deep collaboration integrating frontier AI across the platform — Tongyi LLM, NLP, inference, recommendation, and semantic search — on enterprise-grade compute and security infrastructure.</a:t>
             </a:r>
           </a:p>
         </p:txBody>
@@ -17280,8 +17262,8 @@
         </p:nvSpPr>
         <p:spPr>
           <a:xfrm>
-            <a:off x="731520" y="2880360"/>
-            <a:ext cx="6309360" cy="256032"/>
+            <a:off x="731520" y="2606040"/>
+            <a:ext cx="6309360" cy="274320"/>
           </a:xfrm>
           <a:prstGeom prst="rect">
             <a:avLst/>
@@ -17300,7 +17282,7 @@
                 </a:solidFill>
                 <a:latin typeface="Segoe UI"/>
               </a:rPr>
-              <a:t>▸  AI Career Advisor delivering personalized career-path recommendations</a:t>
+              <a:t>▸  AI mock interviews and career advisor with personalized recommendations</a:t>
             </a:r>
           </a:p>
         </p:txBody>
@@ -17313,8 +17295,8 @@
         </p:nvSpPr>
         <p:spPr>
           <a:xfrm>
-            <a:off x="731520" y="3136391"/>
-            <a:ext cx="6309360" cy="256032"/>
+            <a:off x="731520" y="2898648"/>
+            <a:ext cx="6309360" cy="274320"/>
           </a:xfrm>
           <a:prstGeom prst="rect">
             <a:avLst/>
@@ -17333,7 +17315,7 @@
                 </a:solidFill>
                 <a:latin typeface="Segoe UI"/>
               </a:rPr>
-              <a:t>▸  Intelligent matching and screening for precise candidate–role fit</a:t>
+              <a:t>▸  AI résumé builder tuned for real hiring workflows</a:t>
             </a:r>
           </a:p>
         </p:txBody>
@@ -17346,8 +17328,8 @@
         </p:nvSpPr>
         <p:spPr>
           <a:xfrm>
-            <a:off x="731520" y="3392424"/>
-            <a:ext cx="6309360" cy="256032"/>
+            <a:off x="731520" y="3191256"/>
+            <a:ext cx="6309360" cy="274320"/>
           </a:xfrm>
           <a:prstGeom prst="rect">
             <a:avLst/>
@@ -17366,7 +17348,7 @@
                 </a:solidFill>
                 <a:latin typeface="Segoe UI"/>
               </a:rPr>
-              <a:t>▸  Enterprise data-security framework protecting user privacy</a:t>
+              <a:t>▸  Enterprise-grade data security protecting user privacy</a:t>
             </a:r>
           </a:p>
         </p:txBody>
@@ -17379,8 +17361,8 @@
         </p:nvSpPr>
         <p:spPr>
           <a:xfrm>
-            <a:off x="7452360" y="1234440"/>
-            <a:ext cx="4251960" cy="2331720"/>
+            <a:off x="7452360" y="1170432"/>
+            <a:ext cx="4251960" cy="2468880"/>
           </a:xfrm>
           <a:prstGeom prst="roundRect">
             <a:avLst>
@@ -17424,7 +17406,7 @@
         </p:nvSpPr>
         <p:spPr>
           <a:xfrm>
-            <a:off x="7680960" y="1417320"/>
+            <a:off x="7680960" y="1371600"/>
             <a:ext cx="3840480" cy="320040"/>
           </a:xfrm>
           <a:prstGeom prst="rect">
@@ -17438,7 +17420,7 @@
           <a:p>
             <a:pPr algn="l"/>
             <a:r>
-              <a:rPr sz="1400" b="1" i="0">
+              <a:rPr sz="1500" b="1" i="0">
                 <a:solidFill>
                   <a:srgbClr val="FFFFFF"/>
                 </a:solidFill>
@@ -17457,8 +17439,8 @@
         </p:nvSpPr>
         <p:spPr>
           <a:xfrm>
-            <a:off x="7680960" y="1920240"/>
-            <a:ext cx="3840480" cy="1371600"/>
+            <a:off x="7680960" y="1874519"/>
+            <a:ext cx="3840480" cy="1463040"/>
           </a:xfrm>
           <a:prstGeom prst="rect">
             <a:avLst/>
@@ -17490,8 +17472,8 @@
         </p:nvSpPr>
         <p:spPr>
           <a:xfrm>
-            <a:off x="502920" y="3703320"/>
-            <a:ext cx="5486400" cy="274320"/>
+            <a:off x="502920" y="3794760"/>
+            <a:ext cx="7315200" cy="256032"/>
           </a:xfrm>
           <a:prstGeom prst="rect">
             <a:avLst/>
@@ -17523,8 +17505,8 @@
         </p:nvSpPr>
         <p:spPr>
           <a:xfrm>
-            <a:off x="502920" y="3794760"/>
-            <a:ext cx="11201400" cy="640080"/>
+            <a:off x="502920" y="4114800"/>
+            <a:ext cx="11201400" cy="530352"/>
           </a:xfrm>
           <a:prstGeom prst="roundRect">
             <a:avLst>
@@ -17570,8 +17552,8 @@
         </p:nvSpPr>
         <p:spPr>
           <a:xfrm>
-            <a:off x="502920" y="3794760"/>
-            <a:ext cx="109728" cy="640080"/>
+            <a:off x="502920" y="4114800"/>
+            <a:ext cx="109728" cy="530352"/>
           </a:xfrm>
           <a:prstGeom prst="rect">
             <a:avLst/>
@@ -17613,8 +17595,8 @@
         </p:nvSpPr>
         <p:spPr>
           <a:xfrm>
-            <a:off x="822960" y="3867912"/>
-            <a:ext cx="3200400" cy="256032"/>
+            <a:off x="822960" y="4242816"/>
+            <a:ext cx="3200400" cy="274320"/>
           </a:xfrm>
           <a:prstGeom prst="rect">
             <a:avLst/>
@@ -17646,8 +17628,8 @@
         </p:nvSpPr>
         <p:spPr>
           <a:xfrm>
-            <a:off x="4114800" y="3959352"/>
-            <a:ext cx="7315200" cy="320040"/>
+            <a:off x="4114800" y="4242816"/>
+            <a:ext cx="7315200" cy="274320"/>
           </a:xfrm>
           <a:prstGeom prst="rect">
             <a:avLst/>
@@ -17679,8 +17661,8 @@
         </p:nvSpPr>
         <p:spPr>
           <a:xfrm>
-            <a:off x="502920" y="4526280"/>
-            <a:ext cx="11201400" cy="640080"/>
+            <a:off x="502920" y="4709160"/>
+            <a:ext cx="11201400" cy="530352"/>
           </a:xfrm>
           <a:prstGeom prst="roundRect">
             <a:avLst>
@@ -17726,8 +17708,8 @@
         </p:nvSpPr>
         <p:spPr>
           <a:xfrm>
-            <a:off x="502920" y="4526280"/>
-            <a:ext cx="109728" cy="640080"/>
+            <a:off x="502920" y="4709160"/>
+            <a:ext cx="109728" cy="530352"/>
           </a:xfrm>
           <a:prstGeom prst="rect">
             <a:avLst/>
@@ -17769,8 +17751,8 @@
         </p:nvSpPr>
         <p:spPr>
           <a:xfrm>
-            <a:off x="822960" y="4599432"/>
-            <a:ext cx="3200400" cy="256032"/>
+            <a:off x="822960" y="4837176"/>
+            <a:ext cx="3200400" cy="274320"/>
           </a:xfrm>
           <a:prstGeom prst="rect">
             <a:avLst/>
@@ -17802,8 +17784,8 @@
         </p:nvSpPr>
         <p:spPr>
           <a:xfrm>
-            <a:off x="4114800" y="4690872"/>
-            <a:ext cx="7315200" cy="320040"/>
+            <a:off x="4114800" y="4837176"/>
+            <a:ext cx="7315200" cy="274320"/>
           </a:xfrm>
           <a:prstGeom prst="rect">
             <a:avLst/>
@@ -17835,8 +17817,8 @@
         </p:nvSpPr>
         <p:spPr>
           <a:xfrm>
-            <a:off x="502920" y="5257800"/>
-            <a:ext cx="11201400" cy="640080"/>
+            <a:off x="502920" y="5303520"/>
+            <a:ext cx="11201400" cy="530352"/>
           </a:xfrm>
           <a:prstGeom prst="roundRect">
             <a:avLst>
@@ -17882,8 +17864,8 @@
         </p:nvSpPr>
         <p:spPr>
           <a:xfrm>
-            <a:off x="502920" y="5257800"/>
-            <a:ext cx="109728" cy="640080"/>
+            <a:off x="502920" y="5303520"/>
+            <a:ext cx="109728" cy="530352"/>
           </a:xfrm>
           <a:prstGeom prst="rect">
             <a:avLst/>
@@ -17925,8 +17907,8 @@
         </p:nvSpPr>
         <p:spPr>
           <a:xfrm>
-            <a:off x="822960" y="5330952"/>
-            <a:ext cx="3200400" cy="256032"/>
+            <a:off x="822960" y="5431536"/>
+            <a:ext cx="3200400" cy="274320"/>
           </a:xfrm>
           <a:prstGeom prst="rect">
             <a:avLst/>
@@ -17958,8 +17940,8 @@
         </p:nvSpPr>
         <p:spPr>
           <a:xfrm>
-            <a:off x="4114800" y="5422392"/>
-            <a:ext cx="7315200" cy="320040"/>
+            <a:off x="4114800" y="5431536"/>
+            <a:ext cx="7315200" cy="274320"/>
           </a:xfrm>
           <a:prstGeom prst="rect">
             <a:avLst/>
@@ -18992,7 +18974,7 @@
         <p:spPr>
           <a:xfrm>
             <a:off x="685800" y="4160520"/>
-            <a:ext cx="5486400" cy="274320"/>
+            <a:ext cx="6858000" cy="274320"/>
           </a:xfrm>
           <a:prstGeom prst="rect">
             <a:avLst/>
@@ -19025,8 +19007,8 @@
           <p:nvPr/>
         </p:nvGraphicFramePr>
         <p:xfrm>
-          <a:off x="640080" y="4389120"/>
-          <a:ext cx="7498079" cy="1554480"/>
+          <a:off x="640080" y="4434840"/>
+          <a:ext cx="6949440" cy="1463040"/>
         </p:xfrm>
         <a:graphic>
           <a:graphicData uri="http://schemas.openxmlformats.org/drawingml/2006/chart">
@@ -19042,8 +19024,8 @@
         </p:nvSpPr>
         <p:spPr>
           <a:xfrm>
-            <a:off x="8321040" y="4663440"/>
-            <a:ext cx="3108960" cy="1188720"/>
+            <a:off x="7863840" y="4617720"/>
+            <a:ext cx="3566160" cy="1188720"/>
           </a:xfrm>
           <a:prstGeom prst="rect">
             <a:avLst/>
@@ -19056,11 +19038,11 @@
           <a:p>
             <a:pPr algn="l">
               <a:spcAft>
-                <a:spcPts val="600"/>
+                <a:spcPts val="800"/>
               </a:spcAft>
             </a:pPr>
             <a:r>
-              <a:rPr sz="1200" b="1" i="0">
+              <a:rPr sz="1300" b="1" i="0">
                 <a:solidFill>
                   <a:srgbClr val="0B1F33"/>
                 </a:solidFill>
@@ -19072,7 +19054,7 @@
           <a:p>
             <a:pPr algn="l"/>
             <a:r>
-              <a:rPr sz="1100" b="0" i="0">
+              <a:rPr sz="1200" b="0" i="0">
                 <a:solidFill>
                   <a:srgbClr val="2C3A4B"/>
                 </a:solidFill>
@@ -19378,8 +19360,8 @@
         </p:nvSpPr>
         <p:spPr>
           <a:xfrm>
-            <a:off x="502920" y="1188720"/>
-            <a:ext cx="2697480" cy="1143000"/>
+            <a:off x="502920" y="1170432"/>
+            <a:ext cx="2697480" cy="1051560"/>
           </a:xfrm>
           <a:prstGeom prst="roundRect">
             <a:avLst>
@@ -19425,8 +19407,8 @@
         </p:nvSpPr>
         <p:spPr>
           <a:xfrm>
-            <a:off x="640080" y="1280160"/>
-            <a:ext cx="2423160" cy="502920"/>
+            <a:off x="640080" y="1261872"/>
+            <a:ext cx="2423160" cy="457200"/>
           </a:xfrm>
           <a:prstGeom prst="rect">
             <a:avLst/>
@@ -19458,7 +19440,7 @@
         </p:nvSpPr>
         <p:spPr>
           <a:xfrm>
-            <a:off x="640080" y="1874519"/>
+            <a:off x="640080" y="1783080"/>
             <a:ext cx="2423160" cy="320040"/>
           </a:xfrm>
           <a:prstGeom prst="rect">
@@ -19491,8 +19473,8 @@
         </p:nvSpPr>
         <p:spPr>
           <a:xfrm>
-            <a:off x="3383280" y="1188720"/>
-            <a:ext cx="2697480" cy="1143000"/>
+            <a:off x="3383280" y="1170432"/>
+            <a:ext cx="2697480" cy="1051560"/>
           </a:xfrm>
           <a:prstGeom prst="roundRect">
             <a:avLst>
@@ -19538,8 +19520,8 @@
         </p:nvSpPr>
         <p:spPr>
           <a:xfrm>
-            <a:off x="3520440" y="1280160"/>
-            <a:ext cx="2423160" cy="502920"/>
+            <a:off x="3520440" y="1261872"/>
+            <a:ext cx="2423160" cy="457200"/>
           </a:xfrm>
           <a:prstGeom prst="rect">
             <a:avLst/>
@@ -19571,7 +19553,7 @@
         </p:nvSpPr>
         <p:spPr>
           <a:xfrm>
-            <a:off x="3520440" y="1874519"/>
+            <a:off x="3520440" y="1783080"/>
             <a:ext cx="2423160" cy="320040"/>
           </a:xfrm>
           <a:prstGeom prst="rect">
@@ -19604,8 +19586,8 @@
         </p:nvSpPr>
         <p:spPr>
           <a:xfrm>
-            <a:off x="6263640" y="1188720"/>
-            <a:ext cx="2697480" cy="1143000"/>
+            <a:off x="6263640" y="1170432"/>
+            <a:ext cx="2697480" cy="1051560"/>
           </a:xfrm>
           <a:prstGeom prst="roundRect">
             <a:avLst>
@@ -19651,8 +19633,8 @@
         </p:nvSpPr>
         <p:spPr>
           <a:xfrm>
-            <a:off x="6400800" y="1280160"/>
-            <a:ext cx="2423160" cy="502920"/>
+            <a:off x="6400800" y="1261872"/>
+            <a:ext cx="2423160" cy="457200"/>
           </a:xfrm>
           <a:prstGeom prst="rect">
             <a:avLst/>
@@ -19684,7 +19666,7 @@
         </p:nvSpPr>
         <p:spPr>
           <a:xfrm>
-            <a:off x="6400800" y="1874519"/>
+            <a:off x="6400800" y="1783080"/>
             <a:ext cx="2423160" cy="320040"/>
           </a:xfrm>
           <a:prstGeom prst="rect">
@@ -19717,8 +19699,8 @@
         </p:nvSpPr>
         <p:spPr>
           <a:xfrm>
-            <a:off x="9144000" y="1188720"/>
-            <a:ext cx="2697480" cy="1143000"/>
+            <a:off x="9144000" y="1170432"/>
+            <a:ext cx="2697480" cy="1051560"/>
           </a:xfrm>
           <a:prstGeom prst="roundRect">
             <a:avLst>
@@ -19764,8 +19746,8 @@
         </p:nvSpPr>
         <p:spPr>
           <a:xfrm>
-            <a:off x="9281160" y="1280160"/>
-            <a:ext cx="2423160" cy="502920"/>
+            <a:off x="9281160" y="1261872"/>
+            <a:ext cx="2423160" cy="457200"/>
           </a:xfrm>
           <a:prstGeom prst="rect">
             <a:avLst/>
@@ -19797,7 +19779,7 @@
         </p:nvSpPr>
         <p:spPr>
           <a:xfrm>
-            <a:off x="9281160" y="1874519"/>
+            <a:off x="9281160" y="1783080"/>
             <a:ext cx="2423160" cy="320040"/>
           </a:xfrm>
           <a:prstGeom prst="rect">
@@ -19830,7 +19812,7 @@
         </p:nvSpPr>
         <p:spPr>
           <a:xfrm>
-            <a:off x="502920" y="2514600"/>
+            <a:off x="502920" y="2377440"/>
             <a:ext cx="6858000" cy="3246120"/>
           </a:xfrm>
           <a:prstGeom prst="roundRect">
@@ -19877,8 +19859,8 @@
         </p:nvSpPr>
         <p:spPr>
           <a:xfrm>
-            <a:off x="685800" y="2651760"/>
-            <a:ext cx="6400800" cy="274320"/>
+            <a:off x="685800" y="2487168"/>
+            <a:ext cx="6400800" cy="256032"/>
           </a:xfrm>
           <a:prstGeom prst="rect">
             <a:avLst/>
@@ -19910,8 +19892,8 @@
         </p:nvSpPr>
         <p:spPr>
           <a:xfrm>
-            <a:off x="1051560" y="3154680"/>
-            <a:ext cx="36576" cy="2331720"/>
+            <a:off x="1051560" y="2926080"/>
+            <a:ext cx="36576" cy="2468880"/>
           </a:xfrm>
           <a:prstGeom prst="rect">
             <a:avLst/>
@@ -19953,7 +19935,7 @@
         </p:nvSpPr>
         <p:spPr>
           <a:xfrm>
-            <a:off x="960120" y="3136392"/>
+            <a:off x="960120" y="2935224"/>
             <a:ext cx="219456" cy="219456"/>
           </a:xfrm>
           <a:prstGeom prst="ellipse">
@@ -19996,8 +19978,8 @@
         </p:nvSpPr>
         <p:spPr>
           <a:xfrm>
-            <a:off x="1371600" y="3063240"/>
-            <a:ext cx="1097280" cy="274320"/>
+            <a:off x="1371600" y="2880360"/>
+            <a:ext cx="1051560" cy="256032"/>
           </a:xfrm>
           <a:prstGeom prst="rect">
             <a:avLst/>
@@ -20029,8 +20011,8 @@
         </p:nvSpPr>
         <p:spPr>
           <a:xfrm>
-            <a:off x="2514600" y="3063240"/>
-            <a:ext cx="4572000" cy="457200"/>
+            <a:off x="2468880" y="2880360"/>
+            <a:ext cx="4663440" cy="457200"/>
           </a:xfrm>
           <a:prstGeom prst="rect">
             <a:avLst/>
@@ -20049,7 +20031,7 @@
                 </a:solidFill>
                 <a:latin typeface="Segoe UI"/>
               </a:rPr>
-              <a:t>51 Careers founded — premium career development for global professionals</a:t>
+              <a:t>51Careers founded — premium career development for global professionals</a:t>
             </a:r>
           </a:p>
         </p:txBody>
@@ -20062,7 +20044,7 @@
         </p:nvSpPr>
         <p:spPr>
           <a:xfrm>
-            <a:off x="960120" y="3639312"/>
+            <a:off x="960120" y="3438144"/>
             <a:ext cx="219456" cy="219456"/>
           </a:xfrm>
           <a:prstGeom prst="ellipse">
@@ -20105,8 +20087,8 @@
         </p:nvSpPr>
         <p:spPr>
           <a:xfrm>
-            <a:off x="1371600" y="3566160"/>
-            <a:ext cx="1097280" cy="274320"/>
+            <a:off x="1371600" y="3383280"/>
+            <a:ext cx="1051560" cy="256032"/>
           </a:xfrm>
           <a:prstGeom prst="rect">
             <a:avLst/>
@@ -20138,8 +20120,8 @@
         </p:nvSpPr>
         <p:spPr>
           <a:xfrm>
-            <a:off x="2514600" y="3566160"/>
-            <a:ext cx="4572000" cy="457200"/>
+            <a:off x="2468880" y="3383280"/>
+            <a:ext cx="4663440" cy="457200"/>
           </a:xfrm>
           <a:prstGeom prst="rect">
             <a:avLst/>
@@ -20158,7 +20140,7 @@
                 </a:solidFill>
                 <a:latin typeface="Segoe UI"/>
               </a:rPr>
-              <a:t>Helped 10,000+ candidates; built deep interview &amp; résumé expertise</a:t>
+              <a:t>Helped 10,000+ candidates; built deep interview and résumé expertise</a:t>
             </a:r>
           </a:p>
         </p:txBody>
@@ -20171,7 +20153,7 @@
         </p:nvSpPr>
         <p:spPr>
           <a:xfrm>
-            <a:off x="960120" y="4142232"/>
+            <a:off x="960120" y="3941063"/>
             <a:ext cx="219456" cy="219456"/>
           </a:xfrm>
           <a:prstGeom prst="ellipse">
@@ -20214,8 +20196,8 @@
         </p:nvSpPr>
         <p:spPr>
           <a:xfrm>
-            <a:off x="1371600" y="4069080"/>
-            <a:ext cx="1097280" cy="274320"/>
+            <a:off x="1371600" y="3886200"/>
+            <a:ext cx="1051560" cy="256032"/>
           </a:xfrm>
           <a:prstGeom prst="rect">
             <a:avLst/>
@@ -20247,8 +20229,8 @@
         </p:nvSpPr>
         <p:spPr>
           <a:xfrm>
-            <a:off x="2514600" y="4069080"/>
-            <a:ext cx="4572000" cy="457200"/>
+            <a:off x="2468880" y="3886200"/>
+            <a:ext cx="4663440" cy="457200"/>
           </a:xfrm>
           <a:prstGeom prst="rect">
             <a:avLst/>
@@ -20267,7 +20249,7 @@
                 </a:solidFill>
                 <a:latin typeface="Segoe UI"/>
               </a:rPr>
-              <a:t>Launched 51Careers.AI — free AI platform with mock interviews &amp; 100K+ questions</a:t>
+              <a:t>Launched 51Careers.AI — free AI platform with mock interviews and 100K+ questions</a:t>
             </a:r>
           </a:p>
         </p:txBody>
@@ -20280,7 +20262,7 @@
         </p:nvSpPr>
         <p:spPr>
           <a:xfrm>
-            <a:off x="960120" y="4645152"/>
+            <a:off x="960120" y="4443983"/>
             <a:ext cx="219456" cy="219456"/>
           </a:xfrm>
           <a:prstGeom prst="ellipse">
@@ -20323,8 +20305,8 @@
         </p:nvSpPr>
         <p:spPr>
           <a:xfrm>
-            <a:off x="1371600" y="4572000"/>
-            <a:ext cx="1097280" cy="274320"/>
+            <a:off x="1371600" y="4389120"/>
+            <a:ext cx="1051560" cy="256032"/>
           </a:xfrm>
           <a:prstGeom prst="rect">
             <a:avLst/>
@@ -20356,8 +20338,8 @@
         </p:nvSpPr>
         <p:spPr>
           <a:xfrm>
-            <a:off x="2514600" y="4572000"/>
-            <a:ext cx="4572000" cy="457200"/>
+            <a:off x="2468880" y="4389120"/>
+            <a:ext cx="4663440" cy="457200"/>
           </a:xfrm>
           <a:prstGeom prst="rect">
             <a:avLst/>
@@ -20389,7 +20371,7 @@
         </p:nvSpPr>
         <p:spPr>
           <a:xfrm>
-            <a:off x="960120" y="5148072"/>
+            <a:off x="960120" y="4946903"/>
             <a:ext cx="219456" cy="219456"/>
           </a:xfrm>
           <a:prstGeom prst="ellipse">
@@ -20432,8 +20414,8 @@
         </p:nvSpPr>
         <p:spPr>
           <a:xfrm>
-            <a:off x="1371600" y="5074920"/>
-            <a:ext cx="1097280" cy="274320"/>
+            <a:off x="1371600" y="4892040"/>
+            <a:ext cx="1051560" cy="256032"/>
           </a:xfrm>
           <a:prstGeom prst="rect">
             <a:avLst/>
@@ -20465,8 +20447,8 @@
         </p:nvSpPr>
         <p:spPr>
           <a:xfrm>
-            <a:off x="2514600" y="5074920"/>
-            <a:ext cx="4572000" cy="457200"/>
+            <a:off x="2468880" y="4892040"/>
+            <a:ext cx="4663440" cy="457200"/>
           </a:xfrm>
           <a:prstGeom prst="rect">
             <a:avLst/>
@@ -20498,7 +20480,7 @@
         </p:nvSpPr>
         <p:spPr>
           <a:xfrm>
-            <a:off x="7543800" y="2514600"/>
+            <a:off x="7543800" y="2377440"/>
             <a:ext cx="4160520" cy="3246120"/>
           </a:xfrm>
           <a:prstGeom prst="roundRect">
@@ -20545,8 +20527,8 @@
         </p:nvSpPr>
         <p:spPr>
           <a:xfrm>
-            <a:off x="7726679" y="2651760"/>
-            <a:ext cx="3840480" cy="274320"/>
+            <a:off x="7726679" y="2487168"/>
+            <a:ext cx="3840480" cy="256032"/>
           </a:xfrm>
           <a:prstGeom prst="rect">
             <a:avLst/>
@@ -20578,21 +20560,21 @@
         </p:nvSpPr>
         <p:spPr>
           <a:xfrm>
-            <a:off x="7726679" y="3063240"/>
-            <a:ext cx="3794760" cy="548640"/>
-          </a:xfrm>
-          <a:prstGeom prst="rect">
-            <a:avLst/>
-          </a:prstGeom>
-          <a:noFill/>
-        </p:spPr>
-        <p:txBody>
-          <a:bodyPr wrap="square" anchor="t"/>
-          <a:lstStyle/>
-          <a:p>
-            <a:pPr algn="l"/>
-            <a:r>
-              <a:rPr sz="1100" b="0" i="0">
+            <a:off x="7726679" y="2880360"/>
+            <a:ext cx="3794760" cy="594360"/>
+          </a:xfrm>
+          <a:prstGeom prst="rect">
+            <a:avLst/>
+          </a:prstGeom>
+          <a:noFill/>
+        </p:spPr>
+        <p:txBody>
+          <a:bodyPr wrap="square" anchor="t"/>
+          <a:lstStyle/>
+          <a:p>
+            <a:pPr algn="l"/>
+            <a:r>
+              <a:rPr sz="1200" b="0" i="0">
                 <a:solidFill>
                   <a:srgbClr val="2C3A4B"/>
                 </a:solidFill>
@@ -20611,27 +20593,27 @@
         </p:nvSpPr>
         <p:spPr>
           <a:xfrm>
-            <a:off x="7726679" y="3657600"/>
-            <a:ext cx="3794760" cy="548640"/>
-          </a:xfrm>
-          <a:prstGeom prst="rect">
-            <a:avLst/>
-          </a:prstGeom>
-          <a:noFill/>
-        </p:spPr>
-        <p:txBody>
-          <a:bodyPr wrap="square" anchor="t"/>
-          <a:lstStyle/>
-          <a:p>
-            <a:pPr algn="l"/>
-            <a:r>
-              <a:rPr sz="1100" b="0" i="0">
+            <a:off x="7726679" y="3520440"/>
+            <a:ext cx="3794760" cy="594360"/>
+          </a:xfrm>
+          <a:prstGeom prst="rect">
+            <a:avLst/>
+          </a:prstGeom>
+          <a:noFill/>
+        </p:spPr>
+        <p:txBody>
+          <a:bodyPr wrap="square" anchor="t"/>
+          <a:lstStyle/>
+          <a:p>
+            <a:pPr algn="l"/>
+            <a:r>
+              <a:rPr sz="1200" b="0" i="0">
                 <a:solidFill>
                   <a:srgbClr val="2C3A4B"/>
                 </a:solidFill>
                 <a:latin typeface="Segoe UI"/>
               </a:rPr>
-              <a:t>▸  100K+ proprietary questions create a durable data advantage vs. generic LLMs</a:t>
+              <a:t>▸  100K+ proprietary questions create a durable advantage vs. generic LLMs</a:t>
             </a:r>
           </a:p>
         </p:txBody>
@@ -20644,21 +20626,21 @@
         </p:nvSpPr>
         <p:spPr>
           <a:xfrm>
-            <a:off x="7726679" y="4251960"/>
-            <a:ext cx="3794760" cy="548640"/>
-          </a:xfrm>
-          <a:prstGeom prst="rect">
-            <a:avLst/>
-          </a:prstGeom>
-          <a:noFill/>
-        </p:spPr>
-        <p:txBody>
-          <a:bodyPr wrap="square" anchor="t"/>
-          <a:lstStyle/>
-          <a:p>
-            <a:pPr algn="l"/>
-            <a:r>
-              <a:rPr sz="1100" b="0" i="0">
+            <a:off x="7726679" y="4160520"/>
+            <a:ext cx="3794760" cy="594360"/>
+          </a:xfrm>
+          <a:prstGeom prst="rect">
+            <a:avLst/>
+          </a:prstGeom>
+          <a:noFill/>
+        </p:spPr>
+        <p:txBody>
+          <a:bodyPr wrap="square" anchor="t"/>
+          <a:lstStyle/>
+          <a:p>
+            <a:pPr algn="l"/>
+            <a:r>
+              <a:rPr sz="1200" b="0" i="0">
                 <a:solidFill>
                   <a:srgbClr val="2C3A4B"/>
                 </a:solidFill>
@@ -20677,21 +20659,21 @@
         </p:nvSpPr>
         <p:spPr>
           <a:xfrm>
-            <a:off x="7726679" y="4846320"/>
-            <a:ext cx="3794760" cy="548640"/>
-          </a:xfrm>
-          <a:prstGeom prst="rect">
-            <a:avLst/>
-          </a:prstGeom>
-          <a:noFill/>
-        </p:spPr>
-        <p:txBody>
-          <a:bodyPr wrap="square" anchor="t"/>
-          <a:lstStyle/>
-          <a:p>
-            <a:pPr algn="l"/>
-            <a:r>
-              <a:rPr sz="1100" b="0" i="0">
+            <a:off x="7726679" y="4800600"/>
+            <a:ext cx="3794760" cy="594360"/>
+          </a:xfrm>
+          <a:prstGeom prst="rect">
+            <a:avLst/>
+          </a:prstGeom>
+          <a:noFill/>
+        </p:spPr>
+        <p:txBody>
+          <a:bodyPr wrap="square" anchor="t"/>
+          <a:lstStyle/>
+          <a:p>
+            <a:pPr algn="l"/>
+            <a:r>
+              <a:rPr sz="1200" b="0" i="0">
                 <a:solidFill>
                   <a:srgbClr val="2C3A4B"/>
                 </a:solidFill>
@@ -20710,8 +20692,8 @@
         </p:nvSpPr>
         <p:spPr>
           <a:xfrm>
-            <a:off x="502920" y="5852160"/>
-            <a:ext cx="10972800" cy="274320"/>
+            <a:off x="502920" y="5760720"/>
+            <a:ext cx="10972800" cy="256032"/>
           </a:xfrm>
           <a:prstGeom prst="rect">
             <a:avLst/>
@@ -20730,7 +20712,7 @@
                 </a:solidFill>
                 <a:latin typeface="Segoe UI"/>
               </a:rPr>
-              <a:t>Platform revenue is currently US$0 by design (free access). Candidate totals reflect 51 Careers operating history since 2016.</a:t>
+              <a:t>Platform revenue is currently US$0 by design (free access). Candidate totals reflect 51Careers operating history since 2016.</a:t>
             </a:r>
           </a:p>
         </p:txBody>

</xml_diff>

<commit_message>
Clarify slide 12 revenue starts at US$0 in 2025
Replace any residual $10M reading with an explicit 2025A ($0) label,
data labels on the trajectory chart, and copy stating current platform
revenue is zero while the product remains free.

Co-authored-by: anthonyleedu <anthonyleedu@users.noreply.github.com>
</commit_message>
<xml_diff>
--- a/51Careers_AI_Investor_Presentation.pptx
+++ b/51Careers_AI_Investor_Presentation.pptx
@@ -718,7 +718,10 @@
       </c:catAx>
       <c:valAx>
         <c:axId val="-2113994440"/>
-        <c:scaling/>
+        <c:scaling>
+          <c:max val="6.0"/>
+          <c:min val="0.0"/>
+        </c:scaling>
         <c:delete val="0"/>
         <c:axPos val="b"/>
         <c:majorGridlines>
@@ -1002,7 +1005,7 @@
               <c:strCache>
                 <c:ptCount val="5"/>
                 <c:pt idx="0">
-                  <c:v>2025A</c:v>
+                  <c:v>2025A ($0)</c:v>
                 </c:pt>
                 <c:pt idx="1">
                   <c:v>2026E</c:v>
@@ -1044,6 +1047,30 @@
             </c:numRef>
           </c:val>
         </c:ser>
+        <c:dLbls>
+          <c:numFmt formatCode="0.0" sourceLinked="0"/>
+          <c:txPr>
+            <a:bodyPr/>
+            <a:lstStyle/>
+            <a:p>
+              <a:pPr>
+                <a:defRPr sz="900">
+                  <a:solidFill>
+                    <a:srgbClr val="0B1F33"/>
+                  </a:solidFill>
+                  <a:latin typeface="Segoe UI"/>
+                </a:defRPr>
+              </a:pPr>
+            </a:p>
+          </c:txPr>
+          <c:showLegendKey val="0"/>
+          <c:showVal val="1"/>
+          <c:showCatName val="0"/>
+          <c:showSerName val="0"/>
+          <c:showPercent val="0"/>
+          <c:showBubbleSize val="0"/>
+          <c:showLeaderLines val="1"/>
+        </c:dLbls>
         <c:axId val="-2068027336"/>
         <c:axId val="-2113994440"/>
       </c:barChart>
@@ -1184,7 +1211,7 @@
               <c:strCache>
                 <c:ptCount val="5"/>
                 <c:pt idx="0">
-                  <c:v>2025A</c:v>
+                  <c:v>2025A ($0)</c:v>
                 </c:pt>
                 <c:pt idx="1">
                   <c:v>2026E</c:v>
@@ -8013,7 +8040,7 @@
                 </a:solidFill>
                 <a:latin typeface="Georgia"/>
               </a:rPr>
-              <a:t>From Free Platform to Paid Scale</a:t>
+              <a:t>Illustrative Five-Year Trajectory — Starting at US$0</a:t>
             </a:r>
           </a:p>
         </p:txBody>
@@ -8073,8 +8100,8 @@
         </p:nvSpPr>
         <p:spPr>
           <a:xfrm>
-            <a:off x="685800" y="1280160"/>
-            <a:ext cx="5486400" cy="256032"/>
+            <a:off x="685800" y="1261872"/>
+            <a:ext cx="6858000" cy="256032"/>
           </a:xfrm>
           <a:prstGeom prst="rect">
             <a:avLst/>
@@ -8093,7 +8120,7 @@
                 </a:solidFill>
                 <a:latin typeface="Segoe UI"/>
               </a:rPr>
-              <a:t>Illustrative platform revenue, US$ millions</a:t>
+              <a:t>Platform revenue, US$ millions  ·  2025A = US$0 (free product today)</a:t>
             </a:r>
           </a:p>
         </p:txBody>
@@ -8565,7 +8592,7 @@
                 </a:solidFill>
                 <a:latin typeface="Segoe UI"/>
               </a:rPr>
-              <a:t>Illustrative management projections only — not a forecast. 2025A platform revenue is US$0 (free product). Actual results will differ.</a:t>
+              <a:t>Illustrative only — not a forecast. 2025A is actual platform revenue of US$0 while the product remains free. Future years assume paid conversion begins.</a:t>
             </a:r>
           </a:p>
         </p:txBody>

</xml_diff>